<commit_message>
feat: upgrade editor dark mode, reader mode, inline edit, bootstrap default accounts, update docs and gitignore
</commit_message>
<xml_diff>
--- a/docs/PPT_RAG_Tao_tai_lieu_giang_day.pptx
+++ b/docs/PPT_RAG_Tao_tai_lieu_giang_day.pptx
@@ -5,7 +5,7 @@
     <p:sldMasterId id="2147483648" r:id="rId1"/>
   </p:sldMasterIdLst>
   <p:notesMasterIdLst>
-    <p:notesMasterId r:id="rId20"/>
+    <p:notesMasterId r:id="rId18"/>
   </p:notesMasterIdLst>
   <p:sldIdLst>
     <p:sldId id="256" r:id="rId2"/>
@@ -17,15 +17,13 @@
     <p:sldId id="274" r:id="rId8"/>
     <p:sldId id="299" r:id="rId9"/>
     <p:sldId id="301" r:id="rId10"/>
-    <p:sldId id="300" r:id="rId11"/>
-    <p:sldId id="302" r:id="rId12"/>
-    <p:sldId id="303" r:id="rId13"/>
-    <p:sldId id="305" r:id="rId14"/>
-    <p:sldId id="306" r:id="rId15"/>
-    <p:sldId id="309" r:id="rId16"/>
-    <p:sldId id="275" r:id="rId17"/>
-    <p:sldId id="307" r:id="rId18"/>
-    <p:sldId id="308" r:id="rId19"/>
+    <p:sldId id="302" r:id="rId11"/>
+    <p:sldId id="303" r:id="rId12"/>
+    <p:sldId id="305" r:id="rId13"/>
+    <p:sldId id="306" r:id="rId14"/>
+    <p:sldId id="309" r:id="rId15"/>
+    <p:sldId id="310" r:id="rId16"/>
+    <p:sldId id="308" r:id="rId17"/>
   </p:sldIdLst>
   <p:sldSz cx="9144000" cy="6858000" type="screen4x3"/>
   <p:notesSz cx="6858000" cy="9144000"/>
@@ -5011,35 +5009,7 @@
               <a:latin typeface="Arial" panose="020B0604020202020204" pitchFamily="34" charset="0"/>
               <a:cs typeface="Arial" panose="020B0604020202020204" pitchFamily="34" charset="0"/>
             </a:rPr>
-            <a:t>nghiên cứu </a:t>
-          </a:r>
-          <a:r>
-            <a:rPr lang="vi-VN" sz="2800" smtClean="0">
-              <a:latin typeface="Arial" panose="020B0604020202020204" pitchFamily="34" charset="0"/>
-              <a:cs typeface="Arial" panose="020B0604020202020204" pitchFamily="34" charset="0"/>
-            </a:rPr>
-            <a:t>và </a:t>
-          </a:r>
-          <a:r>
-            <a:rPr lang="vi-VN" sz="2800" err="1">
-              <a:latin typeface="Arial" panose="020B0604020202020204" pitchFamily="34" charset="0"/>
-              <a:cs typeface="Arial" panose="020B0604020202020204" pitchFamily="34" charset="0"/>
-            </a:rPr>
-            <a:t>đánh</a:t>
-          </a:r>
-          <a:r>
-            <a:rPr lang="vi-VN" sz="2800">
-              <a:latin typeface="Arial" panose="020B0604020202020204" pitchFamily="34" charset="0"/>
-              <a:cs typeface="Arial" panose="020B0604020202020204" pitchFamily="34" charset="0"/>
-            </a:rPr>
-            <a:t> </a:t>
-          </a:r>
-          <a:r>
-            <a:rPr lang="vi-VN" sz="2800" err="1">
-              <a:latin typeface="Arial" panose="020B0604020202020204" pitchFamily="34" charset="0"/>
-              <a:cs typeface="Arial" panose="020B0604020202020204" pitchFamily="34" charset="0"/>
-            </a:rPr>
-            <a:t>giá</a:t>
+            <a:t>nghiên cứu</a:t>
           </a:r>
           <a:endParaRPr lang="en-US" sz="2800">
             <a:latin typeface="Arial" panose="020B0604020202020204" pitchFamily="34" charset="0"/>
@@ -5201,7 +5171,7 @@
               <a:latin typeface="Arial" panose="020B0604020202020204" pitchFamily="34" charset="0"/>
               <a:cs typeface="Arial" panose="020B0604020202020204" pitchFamily="34" charset="0"/>
             </a:rPr>
-            <a:t>Cơ sở lý thuyết</a:t>
+            <a:t>Công nghệ sử dụng</a:t>
           </a:r>
           <a:endParaRPr lang="en-US" sz="2800">
             <a:latin typeface="Arial" panose="020B0604020202020204" pitchFamily="34" charset="0"/>
@@ -5570,13 +5540,18 @@
         <a:p>
           <a:pPr algn="l"/>
           <a:r>
-            <a:rPr lang="en-US" sz="2400" b="1" smtClean="0"/>
+            <a:rPr lang="en-US" sz="2400" b="1" smtClean="0">
+              <a:latin typeface="Arial" panose="020B0604020202020204" pitchFamily="34" charset="0"/>
+              <a:cs typeface="Arial" panose="020B0604020202020204" pitchFamily="34" charset="0"/>
+            </a:rPr>
             <a:t>Thực trạng hiện tại</a:t>
           </a:r>
           <a:endParaRPr lang="en-US" sz="2400">
             <a:solidFill>
               <a:srgbClr val="FFFF00"/>
             </a:solidFill>
+            <a:latin typeface="Arial" panose="020B0604020202020204" pitchFamily="34" charset="0"/>
+            <a:cs typeface="Arial" panose="020B0604020202020204" pitchFamily="34" charset="0"/>
           </a:endParaRPr>
         </a:p>
       </dgm:t>
@@ -5663,18 +5638,30 @@
         <a:p>
           <a:pPr algn="l"/>
           <a:r>
-            <a:rPr lang="en-US" sz="2400" b="1" err="1"/>
+            <a:rPr lang="en-US" sz="2400" b="1" err="1">
+              <a:latin typeface="Arial" panose="020B0604020202020204" pitchFamily="34" charset="0"/>
+              <a:cs typeface="Arial" panose="020B0604020202020204" pitchFamily="34" charset="0"/>
+            </a:rPr>
             <a:t>Vấn</a:t>
           </a:r>
           <a:r>
-            <a:rPr lang="en-US" sz="2400" b="1"/>
+            <a:rPr lang="en-US" sz="2400" b="1">
+              <a:latin typeface="Arial" panose="020B0604020202020204" pitchFamily="34" charset="0"/>
+              <a:cs typeface="Arial" panose="020B0604020202020204" pitchFamily="34" charset="0"/>
+            </a:rPr>
             <a:t> </a:t>
           </a:r>
           <a:r>
-            <a:rPr lang="en-US" sz="2400" b="1" err="1"/>
+            <a:rPr lang="en-US" sz="2400" b="1" err="1">
+              <a:latin typeface="Arial" panose="020B0604020202020204" pitchFamily="34" charset="0"/>
+              <a:cs typeface="Arial" panose="020B0604020202020204" pitchFamily="34" charset="0"/>
+            </a:rPr>
             <a:t>đề</a:t>
           </a:r>
-          <a:endParaRPr lang="en-US" sz="2400"/>
+          <a:endParaRPr lang="en-US" sz="2400">
+            <a:latin typeface="Arial" panose="020B0604020202020204" pitchFamily="34" charset="0"/>
+            <a:cs typeface="Arial" panose="020B0604020202020204" pitchFamily="34" charset="0"/>
+          </a:endParaRPr>
         </a:p>
       </dgm:t>
     </dgm:pt>
@@ -5757,30 +5744,51 @@
         <a:p>
           <a:pPr algn="l"/>
           <a:r>
-            <a:rPr lang="en-US" sz="2400" b="1" err="1"/>
+            <a:rPr lang="en-US" sz="2400" b="1" err="1">
+              <a:latin typeface="Arial" panose="020B0604020202020204" pitchFamily="34" charset="0"/>
+              <a:cs typeface="Arial" panose="020B0604020202020204" pitchFamily="34" charset="0"/>
+            </a:rPr>
             <a:t>Hạn</a:t>
           </a:r>
           <a:r>
-            <a:rPr lang="en-US" sz="2400" b="1"/>
+            <a:rPr lang="en-US" sz="2400" b="1">
+              <a:latin typeface="Arial" panose="020B0604020202020204" pitchFamily="34" charset="0"/>
+              <a:cs typeface="Arial" panose="020B0604020202020204" pitchFamily="34" charset="0"/>
+            </a:rPr>
             <a:t> </a:t>
           </a:r>
           <a:r>
-            <a:rPr lang="en-US" sz="2400" b="1" err="1"/>
+            <a:rPr lang="en-US" sz="2400" b="1" err="1">
+              <a:latin typeface="Arial" panose="020B0604020202020204" pitchFamily="34" charset="0"/>
+              <a:cs typeface="Arial" panose="020B0604020202020204" pitchFamily="34" charset="0"/>
+            </a:rPr>
             <a:t>chế</a:t>
           </a:r>
           <a:r>
-            <a:rPr lang="en-US" sz="2400" b="1"/>
+            <a:rPr lang="en-US" sz="2400" b="1">
+              <a:latin typeface="Arial" panose="020B0604020202020204" pitchFamily="34" charset="0"/>
+              <a:cs typeface="Arial" panose="020B0604020202020204" pitchFamily="34" charset="0"/>
+            </a:rPr>
             <a:t> </a:t>
           </a:r>
           <a:r>
-            <a:rPr lang="en-US" sz="2400" b="1" smtClean="0"/>
+            <a:rPr lang="en-US" sz="2400" b="1" smtClean="0">
+              <a:latin typeface="Arial" panose="020B0604020202020204" pitchFamily="34" charset="0"/>
+              <a:cs typeface="Arial" panose="020B0604020202020204" pitchFamily="34" charset="0"/>
+            </a:rPr>
             <a:t>của các công cụ AI hiện </a:t>
           </a:r>
           <a:r>
-            <a:rPr lang="en-US" sz="2400" b="1"/>
+            <a:rPr lang="en-US" sz="2400" b="1">
+              <a:latin typeface="Arial" panose="020B0604020202020204" pitchFamily="34" charset="0"/>
+              <a:cs typeface="Arial" panose="020B0604020202020204" pitchFamily="34" charset="0"/>
+            </a:rPr>
             <a:t>nay</a:t>
           </a:r>
-          <a:endParaRPr lang="en-US" sz="2400"/>
+          <a:endParaRPr lang="en-US" sz="2400">
+            <a:latin typeface="Arial" panose="020B0604020202020204" pitchFamily="34" charset="0"/>
+            <a:cs typeface="Arial" panose="020B0604020202020204" pitchFamily="34" charset="0"/>
+          </a:endParaRPr>
         </a:p>
       </dgm:t>
     </dgm:pt>
@@ -6021,7 +6029,7 @@
       </dgm:t>
     </dgm:pt>
     <dgm:pt modelId="{D4C39096-1203-4593-8975-D39D4983E187}" type="pres">
-      <dgm:prSet presAssocID="{E952668C-975F-470E-85AE-4A2C08912C7D}" presName="parentText" presStyleLbl="node1" presStyleIdx="0" presStyleCnt="3">
+      <dgm:prSet presAssocID="{E952668C-975F-470E-85AE-4A2C08912C7D}" presName="parentText" presStyleLbl="node1" presStyleIdx="0" presStyleCnt="3" custLinFactNeighborY="1523">
         <dgm:presLayoutVars>
           <dgm:chMax val="0"/>
           <dgm:bulletEnabled val="1"/>
@@ -6048,7 +6056,7 @@
       </dgm:t>
     </dgm:pt>
     <dgm:pt modelId="{5210A33C-85E6-41F4-98E8-82BF08AFBDFF}" type="pres">
-      <dgm:prSet presAssocID="{E952668C-975F-470E-85AE-4A2C08912C7D}" presName="childText" presStyleLbl="conFgAcc1" presStyleIdx="0" presStyleCnt="3">
+      <dgm:prSet presAssocID="{E952668C-975F-470E-85AE-4A2C08912C7D}" presName="childText" presStyleLbl="conFgAcc1" presStyleIdx="0" presStyleCnt="3" custLinFactNeighborY="8328">
         <dgm:presLayoutVars>
           <dgm:bulletEnabled val="1"/>
         </dgm:presLayoutVars>
@@ -6096,7 +6104,7 @@
       </dgm:t>
     </dgm:pt>
     <dgm:pt modelId="{26359B7A-529D-4539-BC5D-8086974DBA2D}" type="pres">
-      <dgm:prSet presAssocID="{559DBAB0-165C-4519-BCBF-74841D553990}" presName="parentText" presStyleLbl="node1" presStyleIdx="1" presStyleCnt="3">
+      <dgm:prSet presAssocID="{559DBAB0-165C-4519-BCBF-74841D553990}" presName="parentText" presStyleLbl="node1" presStyleIdx="1" presStyleCnt="3" custLinFactNeighborY="1523">
         <dgm:presLayoutVars>
           <dgm:chMax val="0"/>
           <dgm:bulletEnabled val="1"/>
@@ -6123,7 +6131,7 @@
       </dgm:t>
     </dgm:pt>
     <dgm:pt modelId="{6B25478B-BC27-4651-B3DD-138A15D4A396}" type="pres">
-      <dgm:prSet presAssocID="{559DBAB0-165C-4519-BCBF-74841D553990}" presName="childText" presStyleLbl="conFgAcc1" presStyleIdx="1" presStyleCnt="3">
+      <dgm:prSet presAssocID="{559DBAB0-165C-4519-BCBF-74841D553990}" presName="childText" presStyleLbl="conFgAcc1" presStyleIdx="1" presStyleCnt="3" custLinFactNeighborY="8328">
         <dgm:presLayoutVars>
           <dgm:bulletEnabled val="1"/>
         </dgm:presLayoutVars>
@@ -6171,7 +6179,7 @@
       </dgm:t>
     </dgm:pt>
     <dgm:pt modelId="{DDB6D463-0A69-4CF1-97E3-9D3AD67141AE}" type="pres">
-      <dgm:prSet presAssocID="{BF7CED12-C90A-447C-9046-2D274B758DD9}" presName="parentText" presStyleLbl="node1" presStyleIdx="2" presStyleCnt="3">
+      <dgm:prSet presAssocID="{BF7CED12-C90A-447C-9046-2D274B758DD9}" presName="parentText" presStyleLbl="node1" presStyleIdx="2" presStyleCnt="3" custLinFactNeighborY="1523">
         <dgm:presLayoutVars>
           <dgm:chMax val="0"/>
           <dgm:bulletEnabled val="1"/>
@@ -6198,7 +6206,7 @@
       </dgm:t>
     </dgm:pt>
     <dgm:pt modelId="{CC325DDC-40F2-460C-BA34-6EA696CACD51}" type="pres">
-      <dgm:prSet presAssocID="{BF7CED12-C90A-447C-9046-2D274B758DD9}" presName="childText" presStyleLbl="conFgAcc1" presStyleIdx="2" presStyleCnt="3" custLinFactNeighborY="1415">
+      <dgm:prSet presAssocID="{BF7CED12-C90A-447C-9046-2D274B758DD9}" presName="childText" presStyleLbl="conFgAcc1" presStyleIdx="2" presStyleCnt="3" custLinFactNeighborY="4462">
         <dgm:presLayoutVars>
           <dgm:bulletEnabled val="1"/>
         </dgm:presLayoutVars>
@@ -6764,14 +6772,7 @@
               <a:latin typeface="Arial" panose="020B0604020202020204" pitchFamily="34" charset="0"/>
               <a:cs typeface="Arial" panose="020B0604020202020204" pitchFamily="34" charset="0"/>
             </a:rPr>
-            <a:t>Nội dung bám </a:t>
-          </a:r>
-          <a:r>
-            <a:rPr lang="vi-VN" b="0" smtClean="0">
-              <a:latin typeface="Arial" panose="020B0604020202020204" pitchFamily="34" charset="0"/>
-              <a:cs typeface="Arial" panose="020B0604020202020204" pitchFamily="34" charset="0"/>
-            </a:rPr>
-            <a:t>sát </a:t>
+            <a:t>Nội dung bám sát </a:t>
           </a:r>
           <a:r>
             <a:rPr lang="en-US" b="0" smtClean="0">
@@ -6785,14 +6786,7 @@
               <a:latin typeface="Arial" panose="020B0604020202020204" pitchFamily="34" charset="0"/>
               <a:cs typeface="Arial" panose="020B0604020202020204" pitchFamily="34" charset="0"/>
             </a:rPr>
-            <a:t>đề </a:t>
-          </a:r>
-          <a:r>
-            <a:rPr lang="vi-VN" b="0" smtClean="0">
-              <a:latin typeface="Arial" panose="020B0604020202020204" pitchFamily="34" charset="0"/>
-              <a:cs typeface="Arial" panose="020B0604020202020204" pitchFamily="34" charset="0"/>
-            </a:rPr>
-            <a:t>cương môn học</a:t>
+            <a:t>đề cương môn học</a:t>
           </a:r>
           <a:endParaRPr lang="en-US" b="0">
             <a:latin typeface="Arial" panose="020B0604020202020204" pitchFamily="34" charset="0"/>
@@ -7113,13 +7107,7 @@
             <a:rPr lang="en-US" sz="2400" smtClean="0">
               <a:latin typeface="Arial "/>
             </a:rPr>
-            <a:t>tài </a:t>
-          </a:r>
-          <a:r>
-            <a:rPr lang="en-US" sz="2400" smtClean="0">
-              <a:latin typeface="Arial "/>
-            </a:rPr>
-            <a:t>liệu</a:t>
+            <a:t>tài liệu</a:t>
           </a:r>
           <a:endParaRPr lang="en-US" sz="2400">
             <a:latin typeface="Arial "/>
@@ -7345,13 +7333,7 @@
             <a:rPr lang="en-US" sz="2400" smtClean="0">
               <a:latin typeface="Arial "/>
             </a:rPr>
-            <a:t> </a:t>
-          </a:r>
-          <a:r>
-            <a:rPr lang="en-US" sz="2400" smtClean="0">
-              <a:latin typeface="Arial "/>
-            </a:rPr>
-            <a:t>người </a:t>
+            <a:t> người </a:t>
           </a:r>
           <a:r>
             <a:rPr lang="vi-VN" sz="2400" smtClean="0">
@@ -7407,13 +7389,7 @@
             <a:rPr lang="en-US" sz="2400" smtClean="0">
               <a:latin typeface="Arial "/>
             </a:rPr>
-            <a:t>em </a:t>
-          </a:r>
-          <a:r>
-            <a:rPr lang="en-US" sz="2400" smtClean="0">
-              <a:latin typeface="Arial "/>
-            </a:rPr>
-            <a:t>thống kê  hệ thống</a:t>
+            <a:t>em thống kê  hệ thống</a:t>
           </a:r>
           <a:endParaRPr lang="en-US" sz="2400">
             <a:latin typeface="Arial "/>
@@ -7433,6 +7409,50 @@
       </dgm:t>
     </dgm:pt>
     <dgm:pt modelId="{2600F942-FA23-41CA-829A-1F550F0A48EB}" type="sibTrans" cxnId="{8D3739F7-AD69-433E-BDBB-820E09F88D4E}">
+      <dgm:prSet/>
+      <dgm:spPr/>
+      <dgm:t>
+        <a:bodyPr/>
+        <a:lstStyle/>
+        <a:p>
+          <a:endParaRPr lang="en-US"/>
+        </a:p>
+      </dgm:t>
+    </dgm:pt>
+    <dgm:pt modelId="{B8067916-0A99-4FC3-86E9-7085BFF45525}">
+      <dgm:prSet custT="1"/>
+      <dgm:spPr/>
+      <dgm:t>
+        <a:bodyPr/>
+        <a:lstStyle/>
+        <a:p>
+          <a:pPr>
+            <a:buNone/>
+          </a:pPr>
+          <a:r>
+            <a:rPr lang="en-US" sz="2400" smtClean="0">
+              <a:latin typeface="Arial "/>
+            </a:rPr>
+            <a:t>Tạo bài giảng</a:t>
+          </a:r>
+          <a:endParaRPr lang="en-US" sz="2400">
+            <a:latin typeface="Arial "/>
+          </a:endParaRPr>
+        </a:p>
+      </dgm:t>
+    </dgm:pt>
+    <dgm:pt modelId="{0D60693C-A511-4D1A-AA2F-6EC25EFAD9B1}" type="parTrans" cxnId="{A2A1BAFD-16A4-4100-9D86-EF103CACB810}">
+      <dgm:prSet/>
+      <dgm:spPr/>
+      <dgm:t>
+        <a:bodyPr/>
+        <a:lstStyle/>
+        <a:p>
+          <a:endParaRPr lang="en-US"/>
+        </a:p>
+      </dgm:t>
+    </dgm:pt>
+    <dgm:pt modelId="{CED3F739-E117-4C9D-8C46-EA01AD808C7F}" type="sibTrans" cxnId="{A2A1BAFD-16A4-4100-9D86-EF103CACB810}">
       <dgm:prSet/>
       <dgm:spPr/>
       <dgm:t>
@@ -7566,29 +7586,31 @@
     </dgm:pt>
   </dgm:ptLst>
   <dgm:cxnLst>
+    <dgm:cxn modelId="{72345E88-5D4F-46DC-9ABF-9E4EBFBD9D9B}" type="presOf" srcId="{C71CA00F-2300-45B8-96FB-F9C188F6F4D7}" destId="{CA7141B4-8AE9-4B2A-A720-1AD6C8C5938D}" srcOrd="1" destOrd="0" presId="urn:microsoft.com/office/officeart/2005/8/layout/list1"/>
+    <dgm:cxn modelId="{FF269E10-5CAE-4739-97BA-45514B2BE91D}" type="presOf" srcId="{ADF8C160-C666-46E1-9519-EE1BA8420C00}" destId="{BAA6E47A-EAE7-460E-B70E-2BBD832609B7}" srcOrd="1" destOrd="0" presId="urn:microsoft.com/office/officeart/2005/8/layout/list1"/>
+    <dgm:cxn modelId="{D6240E9F-556A-443D-A13A-34F494ACE700}" srcId="{B820F01C-B89C-4146-B3CE-47D543CF7F89}" destId="{ADF8C160-C666-46E1-9519-EE1BA8420C00}" srcOrd="0" destOrd="0" parTransId="{D03B1926-5593-4A24-9BC7-A511876E6CF9}" sibTransId="{58939B33-A188-4D62-A41C-1FEB09084085}"/>
+    <dgm:cxn modelId="{B38F8896-ED80-4EEA-8F16-A689D84ACC74}" type="presOf" srcId="{4C361ECF-8DB4-4C86-A1E2-A8DA4616DC0C}" destId="{333CA5EC-5E59-4853-9FAF-0949264CD166}" srcOrd="0" destOrd="5" presId="urn:microsoft.com/office/officeart/2005/8/layout/list1"/>
+    <dgm:cxn modelId="{FA3F4ECC-32F5-42E0-9A2D-46F63249CADB}" type="presOf" srcId="{A860DA55-48F2-41AB-8C52-59841AA43B31}" destId="{8E73A191-5E1B-49D6-987E-11CA2BCDBD99}" srcOrd="0" destOrd="1" presId="urn:microsoft.com/office/officeart/2005/8/layout/list1"/>
+    <dgm:cxn modelId="{C2305138-2B64-4FE4-8690-EAFD5AD0EFCC}" type="presOf" srcId="{ADF8C160-C666-46E1-9519-EE1BA8420C00}" destId="{A2EE139B-42AA-4E95-856B-0CFA2DE5CC8E}" srcOrd="0" destOrd="0" presId="urn:microsoft.com/office/officeart/2005/8/layout/list1"/>
+    <dgm:cxn modelId="{02844456-6D53-40CD-B269-078BA1F05562}" srcId="{ADF8C160-C666-46E1-9519-EE1BA8420C00}" destId="{439B88AA-4EBC-4EAC-AF44-129EE924E449}" srcOrd="1" destOrd="0" parTransId="{19D3340C-36F0-4634-B835-EA349520DE44}" sibTransId="{C3BB9266-D552-4C44-839F-EE15F5423BDC}"/>
+    <dgm:cxn modelId="{06B01FDC-CD18-4F77-BD9F-45AE05169C61}" srcId="{ADF8C160-C666-46E1-9519-EE1BA8420C00}" destId="{4C361ECF-8DB4-4C86-A1E2-A8DA4616DC0C}" srcOrd="5" destOrd="0" parTransId="{EBBFE1BF-025C-40DF-968E-57486935B638}" sibTransId="{CBBF3668-DCB1-4C6F-B9A6-ADE48B884E31}"/>
+    <dgm:cxn modelId="{60B53C48-A4DB-4A7A-8A3E-B165D3EC30F9}" type="presOf" srcId="{705C2A1F-8E2B-49A1-9CD0-4D52137D0035}" destId="{333CA5EC-5E59-4853-9FAF-0949264CD166}" srcOrd="0" destOrd="3" presId="urn:microsoft.com/office/officeart/2005/8/layout/list1"/>
+    <dgm:cxn modelId="{76D28A65-E92D-4B91-9071-9F906C498B18}" type="presOf" srcId="{7A86EFC7-A2BF-477B-8EAB-D9BCE0ED29EB}" destId="{333CA5EC-5E59-4853-9FAF-0949264CD166}" srcOrd="0" destOrd="0" presId="urn:microsoft.com/office/officeart/2005/8/layout/list1"/>
+    <dgm:cxn modelId="{2A2840FE-5BEE-4A21-A46C-A9E5C4DBDF8C}" type="presOf" srcId="{B8067916-0A99-4FC3-86E9-7085BFF45525}" destId="{333CA5EC-5E59-4853-9FAF-0949264CD166}" srcOrd="0" destOrd="2" presId="urn:microsoft.com/office/officeart/2005/8/layout/list1"/>
+    <dgm:cxn modelId="{F7D5E0B0-6F05-42F2-BFF5-ACADFC96AB0F}" srcId="{B820F01C-B89C-4146-B3CE-47D543CF7F89}" destId="{C71CA00F-2300-45B8-96FB-F9C188F6F4D7}" srcOrd="1" destOrd="0" parTransId="{9A0F4579-91F5-42B6-B2B4-7DB06CA9EB34}" sibTransId="{73E6BC27-733D-482B-B073-763123A7ED93}"/>
+    <dgm:cxn modelId="{7040650F-4A23-43FF-AFA2-3AE8EFCDF72C}" type="presOf" srcId="{C71CA00F-2300-45B8-96FB-F9C188F6F4D7}" destId="{BEFCB198-37FF-4F6A-863E-A684ADCE2F6A}" srcOrd="0" destOrd="0" presId="urn:microsoft.com/office/officeart/2005/8/layout/list1"/>
+    <dgm:cxn modelId="{A28BA15A-C2CA-435A-A6FC-A69553B5833F}" srcId="{ADF8C160-C666-46E1-9519-EE1BA8420C00}" destId="{705C2A1F-8E2B-49A1-9CD0-4D52137D0035}" srcOrd="3" destOrd="0" parTransId="{2504AC58-B911-4465-A319-82F4386840CD}" sibTransId="{0FD6D53F-116B-4EBD-A4DB-C52D372D0C77}"/>
+    <dgm:cxn modelId="{DEBCFF6E-C1FA-481C-9156-F9D18113E740}" type="presOf" srcId="{B820F01C-B89C-4146-B3CE-47D543CF7F89}" destId="{D9FD9C5D-66ED-4167-82BC-CEB4BEBF07E0}" srcOrd="0" destOrd="0" presId="urn:microsoft.com/office/officeart/2005/8/layout/list1"/>
+    <dgm:cxn modelId="{8D3739F7-AD69-433E-BDBB-820E09F88D4E}" srcId="{C71CA00F-2300-45B8-96FB-F9C188F6F4D7}" destId="{26F3D37E-BF06-441A-825A-24FF7C2D408C}" srcOrd="2" destOrd="0" parTransId="{5060CEC2-8B56-47F4-8269-3B03F4EE8AE8}" sibTransId="{2600F942-FA23-41CA-829A-1F550F0A48EB}"/>
+    <dgm:cxn modelId="{50A39D22-7E02-4DD6-9B80-909F77EA29D1}" type="presOf" srcId="{E152CEC8-2730-4100-815C-3494AA0BD18A}" destId="{8E73A191-5E1B-49D6-987E-11CA2BCDBD99}" srcOrd="0" destOrd="0" presId="urn:microsoft.com/office/officeart/2005/8/layout/list1"/>
+    <dgm:cxn modelId="{59F39D3F-9481-4330-A258-9AEC936BBF87}" srcId="{ADF8C160-C666-46E1-9519-EE1BA8420C00}" destId="{F9DADB1A-B71E-433E-AB91-D99D88B1E93E}" srcOrd="4" destOrd="0" parTransId="{DDE1237A-6D05-4FBE-B764-A2767B884D3C}" sibTransId="{791D3A48-7501-4996-9687-A8B00950E554}"/>
+    <dgm:cxn modelId="{9CCD6AAA-738C-4B8A-86F9-848C39D936D3}" srcId="{C71CA00F-2300-45B8-96FB-F9C188F6F4D7}" destId="{E152CEC8-2730-4100-815C-3494AA0BD18A}" srcOrd="0" destOrd="0" parTransId="{867279F8-A467-4688-B721-37C89BD51D7B}" sibTransId="{BE65A730-E672-4C5B-9829-E57257C24AC4}"/>
     <dgm:cxn modelId="{5121A9A9-3304-4259-933D-F8ACBEA4EFB9}" srcId="{ADF8C160-C666-46E1-9519-EE1BA8420C00}" destId="{7A86EFC7-A2BF-477B-8EAB-D9BCE0ED29EB}" srcOrd="0" destOrd="0" parTransId="{05EA01B0-0933-4D8B-99A8-1FAAF833E766}" sibTransId="{54B63D80-7CE5-4D6A-A68E-3D6A6ED5D122}"/>
+    <dgm:cxn modelId="{806B3140-89B8-4510-8FC7-36CB3DF334DF}" type="presOf" srcId="{F9DADB1A-B71E-433E-AB91-D99D88B1E93E}" destId="{333CA5EC-5E59-4853-9FAF-0949264CD166}" srcOrd="0" destOrd="4" presId="urn:microsoft.com/office/officeart/2005/8/layout/list1"/>
     <dgm:cxn modelId="{7951F2B9-3F59-4296-A59C-B25979C11432}" srcId="{C71CA00F-2300-45B8-96FB-F9C188F6F4D7}" destId="{A860DA55-48F2-41AB-8C52-59841AA43B31}" srcOrd="1" destOrd="0" parTransId="{865F8B73-6EE7-4206-9DC8-A91222D083E6}" sibTransId="{21EC8D3C-6088-4426-817E-59591190691E}"/>
-    <dgm:cxn modelId="{9CCD6AAA-738C-4B8A-86F9-848C39D936D3}" srcId="{C71CA00F-2300-45B8-96FB-F9C188F6F4D7}" destId="{E152CEC8-2730-4100-815C-3494AA0BD18A}" srcOrd="0" destOrd="0" parTransId="{867279F8-A467-4688-B721-37C89BD51D7B}" sibTransId="{BE65A730-E672-4C5B-9829-E57257C24AC4}"/>
-    <dgm:cxn modelId="{FF269E10-5CAE-4739-97BA-45514B2BE91D}" type="presOf" srcId="{ADF8C160-C666-46E1-9519-EE1BA8420C00}" destId="{BAA6E47A-EAE7-460E-B70E-2BBD832609B7}" srcOrd="1" destOrd="0" presId="urn:microsoft.com/office/officeart/2005/8/layout/list1"/>
+    <dgm:cxn modelId="{CECDA1B7-21B1-447F-A1D1-45E4AA2607AA}" type="presOf" srcId="{439B88AA-4EBC-4EAC-AF44-129EE924E449}" destId="{333CA5EC-5E59-4853-9FAF-0949264CD166}" srcOrd="0" destOrd="1" presId="urn:microsoft.com/office/officeart/2005/8/layout/list1"/>
     <dgm:cxn modelId="{710DF9C2-4B64-4DAF-A101-5CFCE5CC9DE3}" type="presOf" srcId="{26F3D37E-BF06-441A-825A-24FF7C2D408C}" destId="{8E73A191-5E1B-49D6-987E-11CA2BCDBD99}" srcOrd="0" destOrd="2" presId="urn:microsoft.com/office/officeart/2005/8/layout/list1"/>
-    <dgm:cxn modelId="{B38F8896-ED80-4EEA-8F16-A689D84ACC74}" type="presOf" srcId="{4C361ECF-8DB4-4C86-A1E2-A8DA4616DC0C}" destId="{333CA5EC-5E59-4853-9FAF-0949264CD166}" srcOrd="0" destOrd="4" presId="urn:microsoft.com/office/officeart/2005/8/layout/list1"/>
-    <dgm:cxn modelId="{59F39D3F-9481-4330-A258-9AEC936BBF87}" srcId="{ADF8C160-C666-46E1-9519-EE1BA8420C00}" destId="{F9DADB1A-B71E-433E-AB91-D99D88B1E93E}" srcOrd="3" destOrd="0" parTransId="{DDE1237A-6D05-4FBE-B764-A2767B884D3C}" sibTransId="{791D3A48-7501-4996-9687-A8B00950E554}"/>
-    <dgm:cxn modelId="{806B3140-89B8-4510-8FC7-36CB3DF334DF}" type="presOf" srcId="{F9DADB1A-B71E-433E-AB91-D99D88B1E93E}" destId="{333CA5EC-5E59-4853-9FAF-0949264CD166}" srcOrd="0" destOrd="3" presId="urn:microsoft.com/office/officeart/2005/8/layout/list1"/>
-    <dgm:cxn modelId="{A28BA15A-C2CA-435A-A6FC-A69553B5833F}" srcId="{ADF8C160-C666-46E1-9519-EE1BA8420C00}" destId="{705C2A1F-8E2B-49A1-9CD0-4D52137D0035}" srcOrd="2" destOrd="0" parTransId="{2504AC58-B911-4465-A319-82F4386840CD}" sibTransId="{0FD6D53F-116B-4EBD-A4DB-C52D372D0C77}"/>
-    <dgm:cxn modelId="{72345E88-5D4F-46DC-9ABF-9E4EBFBD9D9B}" type="presOf" srcId="{C71CA00F-2300-45B8-96FB-F9C188F6F4D7}" destId="{CA7141B4-8AE9-4B2A-A720-1AD6C8C5938D}" srcOrd="1" destOrd="0" presId="urn:microsoft.com/office/officeart/2005/8/layout/list1"/>
-    <dgm:cxn modelId="{FA3F4ECC-32F5-42E0-9A2D-46F63249CADB}" type="presOf" srcId="{A860DA55-48F2-41AB-8C52-59841AA43B31}" destId="{8E73A191-5E1B-49D6-987E-11CA2BCDBD99}" srcOrd="0" destOrd="1" presId="urn:microsoft.com/office/officeart/2005/8/layout/list1"/>
-    <dgm:cxn modelId="{76D28A65-E92D-4B91-9071-9F906C498B18}" type="presOf" srcId="{7A86EFC7-A2BF-477B-8EAB-D9BCE0ED29EB}" destId="{333CA5EC-5E59-4853-9FAF-0949264CD166}" srcOrd="0" destOrd="0" presId="urn:microsoft.com/office/officeart/2005/8/layout/list1"/>
-    <dgm:cxn modelId="{CECDA1B7-21B1-447F-A1D1-45E4AA2607AA}" type="presOf" srcId="{439B88AA-4EBC-4EAC-AF44-129EE924E449}" destId="{333CA5EC-5E59-4853-9FAF-0949264CD166}" srcOrd="0" destOrd="1" presId="urn:microsoft.com/office/officeart/2005/8/layout/list1"/>
-    <dgm:cxn modelId="{F7D5E0B0-6F05-42F2-BFF5-ACADFC96AB0F}" srcId="{B820F01C-B89C-4146-B3CE-47D543CF7F89}" destId="{C71CA00F-2300-45B8-96FB-F9C188F6F4D7}" srcOrd="1" destOrd="0" parTransId="{9A0F4579-91F5-42B6-B2B4-7DB06CA9EB34}" sibTransId="{73E6BC27-733D-482B-B073-763123A7ED93}"/>
-    <dgm:cxn modelId="{D6240E9F-556A-443D-A13A-34F494ACE700}" srcId="{B820F01C-B89C-4146-B3CE-47D543CF7F89}" destId="{ADF8C160-C666-46E1-9519-EE1BA8420C00}" srcOrd="0" destOrd="0" parTransId="{D03B1926-5593-4A24-9BC7-A511876E6CF9}" sibTransId="{58939B33-A188-4D62-A41C-1FEB09084085}"/>
-    <dgm:cxn modelId="{02844456-6D53-40CD-B269-078BA1F05562}" srcId="{ADF8C160-C666-46E1-9519-EE1BA8420C00}" destId="{439B88AA-4EBC-4EAC-AF44-129EE924E449}" srcOrd="1" destOrd="0" parTransId="{19D3340C-36F0-4634-B835-EA349520DE44}" sibTransId="{C3BB9266-D552-4C44-839F-EE15F5423BDC}"/>
-    <dgm:cxn modelId="{7040650F-4A23-43FF-AFA2-3AE8EFCDF72C}" type="presOf" srcId="{C71CA00F-2300-45B8-96FB-F9C188F6F4D7}" destId="{BEFCB198-37FF-4F6A-863E-A684ADCE2F6A}" srcOrd="0" destOrd="0" presId="urn:microsoft.com/office/officeart/2005/8/layout/list1"/>
-    <dgm:cxn modelId="{50A39D22-7E02-4DD6-9B80-909F77EA29D1}" type="presOf" srcId="{E152CEC8-2730-4100-815C-3494AA0BD18A}" destId="{8E73A191-5E1B-49D6-987E-11CA2BCDBD99}" srcOrd="0" destOrd="0" presId="urn:microsoft.com/office/officeart/2005/8/layout/list1"/>
-    <dgm:cxn modelId="{60B53C48-A4DB-4A7A-8A3E-B165D3EC30F9}" type="presOf" srcId="{705C2A1F-8E2B-49A1-9CD0-4D52137D0035}" destId="{333CA5EC-5E59-4853-9FAF-0949264CD166}" srcOrd="0" destOrd="2" presId="urn:microsoft.com/office/officeart/2005/8/layout/list1"/>
-    <dgm:cxn modelId="{DEBCFF6E-C1FA-481C-9156-F9D18113E740}" type="presOf" srcId="{B820F01C-B89C-4146-B3CE-47D543CF7F89}" destId="{D9FD9C5D-66ED-4167-82BC-CEB4BEBF07E0}" srcOrd="0" destOrd="0" presId="urn:microsoft.com/office/officeart/2005/8/layout/list1"/>
-    <dgm:cxn modelId="{C2305138-2B64-4FE4-8690-EAFD5AD0EFCC}" type="presOf" srcId="{ADF8C160-C666-46E1-9519-EE1BA8420C00}" destId="{A2EE139B-42AA-4E95-856B-0CFA2DE5CC8E}" srcOrd="0" destOrd="0" presId="urn:microsoft.com/office/officeart/2005/8/layout/list1"/>
-    <dgm:cxn modelId="{06B01FDC-CD18-4F77-BD9F-45AE05169C61}" srcId="{ADF8C160-C666-46E1-9519-EE1BA8420C00}" destId="{4C361ECF-8DB4-4C86-A1E2-A8DA4616DC0C}" srcOrd="4" destOrd="0" parTransId="{EBBFE1BF-025C-40DF-968E-57486935B638}" sibTransId="{CBBF3668-DCB1-4C6F-B9A6-ADE48B884E31}"/>
-    <dgm:cxn modelId="{8D3739F7-AD69-433E-BDBB-820E09F88D4E}" srcId="{C71CA00F-2300-45B8-96FB-F9C188F6F4D7}" destId="{26F3D37E-BF06-441A-825A-24FF7C2D408C}" srcOrd="2" destOrd="0" parTransId="{5060CEC2-8B56-47F4-8269-3B03F4EE8AE8}" sibTransId="{2600F942-FA23-41CA-829A-1F550F0A48EB}"/>
+    <dgm:cxn modelId="{A2A1BAFD-16A4-4100-9D86-EF103CACB810}" srcId="{ADF8C160-C666-46E1-9519-EE1BA8420C00}" destId="{B8067916-0A99-4FC3-86E9-7085BFF45525}" srcOrd="2" destOrd="0" parTransId="{0D60693C-A511-4D1A-AA2F-6EC25EFAD9B1}" sibTransId="{CED3F739-E117-4C9D-8C46-EA01AD808C7F}"/>
     <dgm:cxn modelId="{BAD2E1CA-A851-4D38-9BBC-E7BD531BAFF0}" type="presParOf" srcId="{D9FD9C5D-66ED-4167-82BC-CEB4BEBF07E0}" destId="{95E2CC20-F3CC-4BE9-846E-F8D3DEA3D197}" srcOrd="0" destOrd="0" presId="urn:microsoft.com/office/officeart/2005/8/layout/list1"/>
     <dgm:cxn modelId="{EDF55B39-74C8-40F3-8B06-E4A9234E6F91}" type="presParOf" srcId="{95E2CC20-F3CC-4BE9-846E-F8D3DEA3D197}" destId="{A2EE139B-42AA-4E95-856B-0CFA2DE5CC8E}" srcOrd="0" destOrd="0" presId="urn:microsoft.com/office/officeart/2005/8/layout/list1"/>
     <dgm:cxn modelId="{1832C733-08E4-4C0C-8002-6C5BFE0E7E37}" type="presParOf" srcId="{95E2CC20-F3CC-4BE9-846E-F8D3DEA3D197}" destId="{BAA6E47A-EAE7-460E-B70E-2BBD832609B7}" srcOrd="1" destOrd="0" presId="urn:microsoft.com/office/officeart/2005/8/layout/list1"/>
@@ -7923,18 +7945,18 @@
     </dgm:pt>
   </dgm:ptLst>
   <dgm:cxnLst>
+    <dgm:cxn modelId="{5121A9A9-3304-4259-933D-F8ACBEA4EFB9}" srcId="{ADF8C160-C666-46E1-9519-EE1BA8420C00}" destId="{7A86EFC7-A2BF-477B-8EAB-D9BCE0ED29EB}" srcOrd="0" destOrd="0" parTransId="{05EA01B0-0933-4D8B-99A8-1FAAF833E766}" sibTransId="{54B63D80-7CE5-4D6A-A68E-3D6A6ED5D122}"/>
     <dgm:cxn modelId="{4128607C-9925-4EBC-AA07-72CF5D628514}" type="presOf" srcId="{ADF8C160-C666-46E1-9519-EE1BA8420C00}" destId="{A2EE139B-42AA-4E95-856B-0CFA2DE5CC8E}" srcOrd="0" destOrd="0" presId="urn:microsoft.com/office/officeart/2005/8/layout/list1"/>
-    <dgm:cxn modelId="{5121A9A9-3304-4259-933D-F8ACBEA4EFB9}" srcId="{ADF8C160-C666-46E1-9519-EE1BA8420C00}" destId="{7A86EFC7-A2BF-477B-8EAB-D9BCE0ED29EB}" srcOrd="0" destOrd="0" parTransId="{05EA01B0-0933-4D8B-99A8-1FAAF833E766}" sibTransId="{54B63D80-7CE5-4D6A-A68E-3D6A6ED5D122}"/>
-    <dgm:cxn modelId="{F568BC78-5F8C-452E-9704-DDDB2207E094}" srcId="{ADF8C160-C666-46E1-9519-EE1BA8420C00}" destId="{99791EF4-9E51-444F-A33C-627FF2BAB534}" srcOrd="1" destOrd="0" parTransId="{208014E1-3119-4408-B6E3-4187EBC56942}" sibTransId="{2D4FADF0-0900-4F83-9BA1-0F834360A20D}"/>
-    <dgm:cxn modelId="{EBE88596-B02D-4B78-9071-5AE706975EC0}" type="presOf" srcId="{03B5A94F-4DC9-4C6A-9A08-85E18C3F2B7C}" destId="{333CA5EC-5E59-4853-9FAF-0949264CD166}" srcOrd="0" destOrd="2" presId="urn:microsoft.com/office/officeart/2005/8/layout/list1"/>
-    <dgm:cxn modelId="{2F12A2FC-BCB6-4149-897D-8F3759EFE588}" srcId="{ADF8C160-C666-46E1-9519-EE1BA8420C00}" destId="{A9300806-85A2-4B3C-A3BC-B1A977046693}" srcOrd="3" destOrd="0" parTransId="{8DEB6A1D-DC8D-4EBD-86D6-E1F893E52953}" sibTransId="{7CE56F68-B078-4D10-8DCA-7B3CA227161E}"/>
-    <dgm:cxn modelId="{204C1FF5-9C43-437C-9B3C-52962202F368}" type="presOf" srcId="{ADF8C160-C666-46E1-9519-EE1BA8420C00}" destId="{BAA6E47A-EAE7-460E-B70E-2BBD832609B7}" srcOrd="1" destOrd="0" presId="urn:microsoft.com/office/officeart/2005/8/layout/list1"/>
     <dgm:cxn modelId="{D7AF9F9A-6324-4CE6-AE1E-B78A9C194A9D}" type="presOf" srcId="{A9300806-85A2-4B3C-A3BC-B1A977046693}" destId="{333CA5EC-5E59-4853-9FAF-0949264CD166}" srcOrd="0" destOrd="3" presId="urn:microsoft.com/office/officeart/2005/8/layout/list1"/>
     <dgm:cxn modelId="{0002C1E2-3AD4-4831-93BF-DE200AE698B6}" type="presOf" srcId="{7A86EFC7-A2BF-477B-8EAB-D9BCE0ED29EB}" destId="{333CA5EC-5E59-4853-9FAF-0949264CD166}" srcOrd="0" destOrd="0" presId="urn:microsoft.com/office/officeart/2005/8/layout/list1"/>
-    <dgm:cxn modelId="{D6240E9F-556A-443D-A13A-34F494ACE700}" srcId="{B820F01C-B89C-4146-B3CE-47D543CF7F89}" destId="{ADF8C160-C666-46E1-9519-EE1BA8420C00}" srcOrd="0" destOrd="0" parTransId="{D03B1926-5593-4A24-9BC7-A511876E6CF9}" sibTransId="{58939B33-A188-4D62-A41C-1FEB09084085}"/>
+    <dgm:cxn modelId="{EBE88596-B02D-4B78-9071-5AE706975EC0}" type="presOf" srcId="{03B5A94F-4DC9-4C6A-9A08-85E18C3F2B7C}" destId="{333CA5EC-5E59-4853-9FAF-0949264CD166}" srcOrd="0" destOrd="2" presId="urn:microsoft.com/office/officeart/2005/8/layout/list1"/>
+    <dgm:cxn modelId="{F568BC78-5F8C-452E-9704-DDDB2207E094}" srcId="{ADF8C160-C666-46E1-9519-EE1BA8420C00}" destId="{99791EF4-9E51-444F-A33C-627FF2BAB534}" srcOrd="1" destOrd="0" parTransId="{208014E1-3119-4408-B6E3-4187EBC56942}" sibTransId="{2D4FADF0-0900-4F83-9BA1-0F834360A20D}"/>
+    <dgm:cxn modelId="{F07C2DDF-940F-4989-AC6E-62E879DB600E}" srcId="{ADF8C160-C666-46E1-9519-EE1BA8420C00}" destId="{03B5A94F-4DC9-4C6A-9A08-85E18C3F2B7C}" srcOrd="2" destOrd="0" parTransId="{9149AFE0-D967-4EEB-87BA-9D27D595D135}" sibTransId="{39FA960B-F130-43B1-9FF4-DEB3A66A71F0}"/>
     <dgm:cxn modelId="{07B6A9A9-2826-4EAF-9388-D2AF0F6A159A}" type="presOf" srcId="{99791EF4-9E51-444F-A33C-627FF2BAB534}" destId="{333CA5EC-5E59-4853-9FAF-0949264CD166}" srcOrd="0" destOrd="1" presId="urn:microsoft.com/office/officeart/2005/8/layout/list1"/>
     <dgm:cxn modelId="{400ACDEA-112C-4A61-A58C-AB6103F1E8BF}" type="presOf" srcId="{B820F01C-B89C-4146-B3CE-47D543CF7F89}" destId="{D9FD9C5D-66ED-4167-82BC-CEB4BEBF07E0}" srcOrd="0" destOrd="0" presId="urn:microsoft.com/office/officeart/2005/8/layout/list1"/>
-    <dgm:cxn modelId="{F07C2DDF-940F-4989-AC6E-62E879DB600E}" srcId="{ADF8C160-C666-46E1-9519-EE1BA8420C00}" destId="{03B5A94F-4DC9-4C6A-9A08-85E18C3F2B7C}" srcOrd="2" destOrd="0" parTransId="{9149AFE0-D967-4EEB-87BA-9D27D595D135}" sibTransId="{39FA960B-F130-43B1-9FF4-DEB3A66A71F0}"/>
+    <dgm:cxn modelId="{204C1FF5-9C43-437C-9B3C-52962202F368}" type="presOf" srcId="{ADF8C160-C666-46E1-9519-EE1BA8420C00}" destId="{BAA6E47A-EAE7-460E-B70E-2BBD832609B7}" srcOrd="1" destOrd="0" presId="urn:microsoft.com/office/officeart/2005/8/layout/list1"/>
+    <dgm:cxn modelId="{D6240E9F-556A-443D-A13A-34F494ACE700}" srcId="{B820F01C-B89C-4146-B3CE-47D543CF7F89}" destId="{ADF8C160-C666-46E1-9519-EE1BA8420C00}" srcOrd="0" destOrd="0" parTransId="{D03B1926-5593-4A24-9BC7-A511876E6CF9}" sibTransId="{58939B33-A188-4D62-A41C-1FEB09084085}"/>
+    <dgm:cxn modelId="{2F12A2FC-BCB6-4149-897D-8F3759EFE588}" srcId="{ADF8C160-C666-46E1-9519-EE1BA8420C00}" destId="{A9300806-85A2-4B3C-A3BC-B1A977046693}" srcOrd="3" destOrd="0" parTransId="{8DEB6A1D-DC8D-4EBD-86D6-E1F893E52953}" sibTransId="{7CE56F68-B078-4D10-8DCA-7B3CA227161E}"/>
     <dgm:cxn modelId="{E112A4AC-0680-4E5B-ABA6-E723F5BEF3E2}" type="presParOf" srcId="{D9FD9C5D-66ED-4167-82BC-CEB4BEBF07E0}" destId="{95E2CC20-F3CC-4BE9-846E-F8D3DEA3D197}" srcOrd="0" destOrd="0" presId="urn:microsoft.com/office/officeart/2005/8/layout/list1"/>
     <dgm:cxn modelId="{59591CD5-C5B0-43B2-A058-6C3B1F28FB66}" type="presParOf" srcId="{95E2CC20-F3CC-4BE9-846E-F8D3DEA3D197}" destId="{A2EE139B-42AA-4E95-856B-0CFA2DE5CC8E}" srcOrd="0" destOrd="0" presId="urn:microsoft.com/office/officeart/2005/8/layout/list1"/>
     <dgm:cxn modelId="{96FEAA97-A35D-4345-BBB8-D6A836C40733}" type="presParOf" srcId="{95E2CC20-F3CC-4BE9-846E-F8D3DEA3D197}" destId="{BAA6E47A-EAE7-460E-B70E-2BBD832609B7}" srcOrd="1" destOrd="0" presId="urn:microsoft.com/office/officeart/2005/8/layout/list1"/>
@@ -7954,7 +7976,7 @@
 <file path=ppt/diagrams/data6.xml><?xml version="1.0" encoding="utf-8"?>
 <dgm:dataModel xmlns:dgm="http://schemas.openxmlformats.org/drawingml/2006/diagram" xmlns:a="http://schemas.openxmlformats.org/drawingml/2006/main">
   <dgm:ptLst>
-    <dgm:pt modelId="{B820F01C-B89C-4146-B3CE-47D543CF7F89}" type="doc">
+    <dgm:pt modelId="{687D8256-1659-432A-9D0B-7F4F9320D9EB}" type="doc">
       <dgm:prSet loTypeId="urn:microsoft.com/office/officeart/2005/8/layout/list1" loCatId="list" qsTypeId="urn:microsoft.com/office/officeart/2005/8/quickstyle/simple1" qsCatId="simple" csTypeId="urn:microsoft.com/office/officeart/2005/8/colors/accent0_3" csCatId="mainScheme" phldr="1"/>
       <dgm:spPr/>
       <dgm:t>
@@ -7965,32 +7987,232 @@
         </a:p>
       </dgm:t>
     </dgm:pt>
-    <dgm:pt modelId="{7A86EFC7-A2BF-477B-8EAB-D9BCE0ED29EB}">
+    <dgm:pt modelId="{E952668C-975F-470E-85AE-4A2C08912C7D}">
       <dgm:prSet custT="1"/>
       <dgm:spPr/>
       <dgm:t>
         <a:bodyPr/>
         <a:lstStyle/>
         <a:p>
-          <a:pPr>
-            <a:lnSpc>
-              <a:spcPct val="150000"/>
-            </a:lnSpc>
-            <a:buNone/>
-          </a:pPr>
+          <a:pPr algn="l"/>
           <a:r>
-            <a:rPr lang="en-US" sz="1500" smtClean="0">
-              <a:latin typeface="Arial "/>
+            <a:rPr lang="en-US" sz="2400" b="1" smtClean="0">
+              <a:latin typeface="Arial" panose="020B0604020202020204" pitchFamily="34" charset="0"/>
+              <a:cs typeface="Arial" panose="020B0604020202020204" pitchFamily="34" charset="0"/>
             </a:rPr>
-            <a:t>Frontend: ReactJS + Vite</a:t>
+            <a:t>Kết luận</a:t>
           </a:r>
-          <a:endParaRPr lang="en-US" sz="1500">
-            <a:latin typeface="Arial "/>
+          <a:endParaRPr lang="en-US" sz="2400">
+            <a:solidFill>
+              <a:srgbClr val="FFFF00"/>
+            </a:solidFill>
+            <a:latin typeface="Arial" panose="020B0604020202020204" pitchFamily="34" charset="0"/>
+            <a:cs typeface="Arial" panose="020B0604020202020204" pitchFamily="34" charset="0"/>
           </a:endParaRPr>
         </a:p>
       </dgm:t>
     </dgm:pt>
-    <dgm:pt modelId="{54B63D80-7CE5-4D6A-A68E-3D6A6ED5D122}" type="sibTrans" cxnId="{5121A9A9-3304-4259-933D-F8ACBEA4EFB9}">
+    <dgm:pt modelId="{30B5313B-3348-4EC4-80AC-05838E0DB9D9}" type="parTrans" cxnId="{D8D81CBC-ACB1-4C68-9CD6-1E5807C36886}">
+      <dgm:prSet/>
+      <dgm:spPr/>
+      <dgm:t>
+        <a:bodyPr/>
+        <a:lstStyle/>
+        <a:p>
+          <a:pPr algn="l"/>
+          <a:endParaRPr lang="en-US" sz="2000"/>
+        </a:p>
+      </dgm:t>
+    </dgm:pt>
+    <dgm:pt modelId="{5B4A5D51-046A-4696-96E4-08F5338ECAA4}" type="sibTrans" cxnId="{D8D81CBC-ACB1-4C68-9CD6-1E5807C36886}">
+      <dgm:prSet/>
+      <dgm:spPr/>
+      <dgm:t>
+        <a:bodyPr/>
+        <a:lstStyle/>
+        <a:p>
+          <a:pPr algn="l"/>
+          <a:endParaRPr lang="en-US" sz="2000"/>
+        </a:p>
+      </dgm:t>
+    </dgm:pt>
+    <dgm:pt modelId="{D62D50D1-EE9F-4322-8446-72807BDDC2A3}">
+      <dgm:prSet custT="1"/>
+      <dgm:spPr/>
+      <dgm:t>
+        <a:bodyPr/>
+        <a:lstStyle/>
+        <a:p>
+          <a:pPr algn="l">
+            <a:buFont typeface="Arial" panose="020B0604020202020204" pitchFamily="34" charset="0"/>
+            <a:buNone/>
+          </a:pPr>
+          <a:r>
+            <a:rPr lang="en-US" sz="2400" smtClean="0">
+              <a:latin typeface="Arial" panose="020B0604020202020204" pitchFamily="34" charset="0"/>
+              <a:cs typeface="Arial" panose="020B0604020202020204" pitchFamily="34" charset="0"/>
+            </a:rPr>
+            <a:t>Xây dựng thành công hệ thống </a:t>
+          </a:r>
+          <a:endParaRPr lang="en-US" sz="2400" b="0">
+            <a:latin typeface="Arial" panose="020B0604020202020204" pitchFamily="34" charset="0"/>
+            <a:cs typeface="Arial" panose="020B0604020202020204" pitchFamily="34" charset="0"/>
+          </a:endParaRPr>
+        </a:p>
+      </dgm:t>
+    </dgm:pt>
+    <dgm:pt modelId="{CD82F050-B62D-421F-980D-80EB6269DD22}" type="parTrans" cxnId="{19FA11D4-1A15-4D93-8DFA-0E8B324E7500}">
+      <dgm:prSet/>
+      <dgm:spPr/>
+      <dgm:t>
+        <a:bodyPr/>
+        <a:lstStyle/>
+        <a:p>
+          <a:pPr algn="l"/>
+          <a:endParaRPr lang="en-US" sz="2000"/>
+        </a:p>
+      </dgm:t>
+    </dgm:pt>
+    <dgm:pt modelId="{BAB88D84-78F0-4E67-853A-20CF6B292CD9}" type="sibTrans" cxnId="{19FA11D4-1A15-4D93-8DFA-0E8B324E7500}">
+      <dgm:prSet/>
+      <dgm:spPr/>
+      <dgm:t>
+        <a:bodyPr/>
+        <a:lstStyle/>
+        <a:p>
+          <a:pPr algn="l"/>
+          <a:endParaRPr lang="en-US" sz="2000"/>
+        </a:p>
+      </dgm:t>
+    </dgm:pt>
+    <dgm:pt modelId="{559DBAB0-165C-4519-BCBF-74841D553990}">
+      <dgm:prSet custT="1"/>
+      <dgm:spPr/>
+      <dgm:t>
+        <a:bodyPr/>
+        <a:lstStyle/>
+        <a:p>
+          <a:pPr algn="l"/>
+          <a:r>
+            <a:rPr lang="en-US" sz="2400" b="1" smtClean="0">
+              <a:latin typeface="Arial" panose="020B0604020202020204" pitchFamily="34" charset="0"/>
+              <a:cs typeface="Arial" panose="020B0604020202020204" pitchFamily="34" charset="0"/>
+            </a:rPr>
+            <a:t>Hướng phát triển</a:t>
+          </a:r>
+          <a:endParaRPr lang="en-US" sz="2400">
+            <a:latin typeface="Arial" panose="020B0604020202020204" pitchFamily="34" charset="0"/>
+            <a:cs typeface="Arial" panose="020B0604020202020204" pitchFamily="34" charset="0"/>
+          </a:endParaRPr>
+        </a:p>
+      </dgm:t>
+    </dgm:pt>
+    <dgm:pt modelId="{05CAB70D-014A-4D45-AFBE-1A8B49DCC621}" type="parTrans" cxnId="{4C2010E5-A35D-4F5F-9F37-9CA764983542}">
+      <dgm:prSet/>
+      <dgm:spPr/>
+      <dgm:t>
+        <a:bodyPr/>
+        <a:lstStyle/>
+        <a:p>
+          <a:pPr algn="l"/>
+          <a:endParaRPr lang="en-US" sz="2000"/>
+        </a:p>
+      </dgm:t>
+    </dgm:pt>
+    <dgm:pt modelId="{0BD09816-00A9-4E33-8C83-AE06967AA411}" type="sibTrans" cxnId="{4C2010E5-A35D-4F5F-9F37-9CA764983542}">
+      <dgm:prSet/>
+      <dgm:spPr/>
+      <dgm:t>
+        <a:bodyPr/>
+        <a:lstStyle/>
+        <a:p>
+          <a:pPr algn="l"/>
+          <a:endParaRPr lang="en-US" sz="2000"/>
+        </a:p>
+      </dgm:t>
+    </dgm:pt>
+    <dgm:pt modelId="{0FFA85E1-284E-4378-9668-B59008A155BE}">
+      <dgm:prSet custT="1"/>
+      <dgm:spPr/>
+      <dgm:t>
+        <a:bodyPr/>
+        <a:lstStyle/>
+        <a:p>
+          <a:pPr algn="l"/>
+          <a:r>
+            <a:rPr lang="en-US" sz="2400" b="0" smtClean="0">
+              <a:latin typeface="Arial" panose="020B0604020202020204" pitchFamily="34" charset="0"/>
+              <a:cs typeface="Arial" panose="020B0604020202020204" pitchFamily="34" charset="0"/>
+            </a:rPr>
+            <a:t>Áp dụng các kỹ thuật RAG tiên tiến nâng cao    chất lượng nội dung</a:t>
+          </a:r>
+          <a:endParaRPr lang="vi-VN" sz="2400" b="0">
+            <a:latin typeface="Arial" panose="020B0604020202020204" pitchFamily="34" charset="0"/>
+            <a:cs typeface="Arial" panose="020B0604020202020204" pitchFamily="34" charset="0"/>
+          </a:endParaRPr>
+        </a:p>
+      </dgm:t>
+    </dgm:pt>
+    <dgm:pt modelId="{B6AA499E-9B8C-4082-A375-108A80900696}" type="parTrans" cxnId="{90F53AD0-EBCE-434A-83E5-9F37428797B3}">
+      <dgm:prSet/>
+      <dgm:spPr/>
+      <dgm:t>
+        <a:bodyPr/>
+        <a:lstStyle/>
+        <a:p>
+          <a:pPr algn="l"/>
+          <a:endParaRPr lang="en-US" sz="2000"/>
+        </a:p>
+      </dgm:t>
+    </dgm:pt>
+    <dgm:pt modelId="{9536FE3B-62EE-4DA2-8287-C32F11D40FB1}" type="sibTrans" cxnId="{90F53AD0-EBCE-434A-83E5-9F37428797B3}">
+      <dgm:prSet/>
+      <dgm:spPr/>
+      <dgm:t>
+        <a:bodyPr/>
+        <a:lstStyle/>
+        <a:p>
+          <a:pPr algn="l"/>
+          <a:endParaRPr lang="en-US" sz="2000"/>
+        </a:p>
+      </dgm:t>
+    </dgm:pt>
+    <dgm:pt modelId="{FE6CA380-3F6C-458D-977C-BD6BA6DA2F05}">
+      <dgm:prSet/>
+      <dgm:spPr/>
+      <dgm:t>
+        <a:bodyPr/>
+        <a:lstStyle/>
+        <a:p>
+          <a:r>
+            <a:rPr lang="vi-VN" smtClean="0">
+              <a:latin typeface="Arial" panose="020B0604020202020204" pitchFamily="34" charset="0"/>
+              <a:cs typeface="Arial" panose="020B0604020202020204" pitchFamily="34" charset="0"/>
+            </a:rPr>
+            <a:t>Giảm thời gian</a:t>
+          </a:r>
+          <a:r>
+            <a:rPr lang="en-US" smtClean="0">
+              <a:latin typeface="Arial" panose="020B0604020202020204" pitchFamily="34" charset="0"/>
+              <a:cs typeface="Arial" panose="020B0604020202020204" pitchFamily="34" charset="0"/>
+            </a:rPr>
+            <a:t>, công sức </a:t>
+          </a:r>
+          <a:r>
+            <a:rPr lang="vi-VN" smtClean="0">
+              <a:latin typeface="Arial" panose="020B0604020202020204" pitchFamily="34" charset="0"/>
+              <a:cs typeface="Arial" panose="020B0604020202020204" pitchFamily="34" charset="0"/>
+            </a:rPr>
+            <a:t>biên soạn học liệu cho giảng viên.</a:t>
+          </a:r>
+          <a:endParaRPr lang="vi-VN">
+            <a:latin typeface="Arial" panose="020B0604020202020204" pitchFamily="34" charset="0"/>
+            <a:cs typeface="Arial" panose="020B0604020202020204" pitchFamily="34" charset="0"/>
+          </a:endParaRPr>
+        </a:p>
+      </dgm:t>
+    </dgm:pt>
+    <dgm:pt modelId="{594B3884-6EA6-4116-A837-2BC8BBF84A22}" type="parTrans" cxnId="{7FFFF2DC-7332-4B2D-823B-3DF1E33B2942}">
       <dgm:prSet/>
       <dgm:spPr/>
       <dgm:t>
@@ -8001,7 +8223,7 @@
         </a:p>
       </dgm:t>
     </dgm:pt>
-    <dgm:pt modelId="{05EA01B0-0933-4D8B-99A8-1FAAF833E766}" type="parTrans" cxnId="{5121A9A9-3304-4259-933D-F8ACBEA4EFB9}">
+    <dgm:pt modelId="{92E40D9A-3523-4BE5-9523-D174FDCD1CCF}" type="sibTrans" cxnId="{7FFFF2DC-7332-4B2D-823B-3DF1E33B2942}">
       <dgm:prSet/>
       <dgm:spPr/>
       <dgm:t>
@@ -8012,26 +8234,22 @@
         </a:p>
       </dgm:t>
     </dgm:pt>
-    <dgm:pt modelId="{ADF8C160-C666-46E1-9519-EE1BA8420C00}">
+    <dgm:pt modelId="{F24BB8E2-1A92-4D98-9BAE-44C2302C22CF}">
       <dgm:prSet custT="1"/>
       <dgm:spPr/>
       <dgm:t>
         <a:bodyPr/>
         <a:lstStyle/>
         <a:p>
-          <a:r>
-            <a:rPr lang="en-US" sz="2200" smtClean="0">
-              <a:latin typeface="Arial "/>
-            </a:rPr>
-            <a:t>Kiến trúc triển khai</a:t>
-          </a:r>
-          <a:endParaRPr lang="en-US" sz="2200">
-            <a:latin typeface="Arial "/>
+          <a:pPr algn="l"/>
+          <a:endParaRPr lang="vi-VN" sz="2400" b="0">
+            <a:latin typeface="Arial" panose="020B0604020202020204" pitchFamily="34" charset="0"/>
+            <a:cs typeface="Arial" panose="020B0604020202020204" pitchFamily="34" charset="0"/>
           </a:endParaRPr>
         </a:p>
       </dgm:t>
     </dgm:pt>
-    <dgm:pt modelId="{58939B33-A188-4D62-A41C-1FEB09084085}" type="sibTrans" cxnId="{D6240E9F-556A-443D-A13A-34F494ACE700}">
+    <dgm:pt modelId="{1EFD18C1-6AD5-4219-927A-D7080426077E}" type="sibTrans" cxnId="{C41572B7-5B02-4C5F-B3C4-5E2B39ED675E}">
       <dgm:prSet/>
       <dgm:spPr/>
       <dgm:t>
@@ -8042,7 +8260,7 @@
         </a:p>
       </dgm:t>
     </dgm:pt>
-    <dgm:pt modelId="{D03B1926-5593-4A24-9BC7-A511876E6CF9}" type="parTrans" cxnId="{D6240E9F-556A-443D-A13A-34F494ACE700}">
+    <dgm:pt modelId="{7745FE9F-C3B7-445D-B2E2-F8430E2FD325}" type="parTrans" cxnId="{C41572B7-5B02-4C5F-B3C4-5E2B39ED675E}">
       <dgm:prSet/>
       <dgm:spPr/>
       <dgm:t>
@@ -8053,28 +8271,29 @@
         </a:p>
       </dgm:t>
     </dgm:pt>
-    <dgm:pt modelId="{819B46DB-6C2A-4F0D-9592-9313B1A88DC8}">
+    <dgm:pt modelId="{BD594D7B-67FC-4D49-A510-C0612D804C65}">
       <dgm:prSet custT="1"/>
       <dgm:spPr/>
       <dgm:t>
         <a:bodyPr/>
         <a:lstStyle/>
         <a:p>
-          <a:pPr>
-            <a:lnSpc>
-              <a:spcPct val="150000"/>
-            </a:lnSpc>
-          </a:pPr>
+          <a:pPr algn="l"/>
           <a:r>
-            <a:rPr lang="en-US" sz="1500">
-              <a:latin typeface="Arial "/>
+            <a:rPr lang="en-US" sz="2400" b="0" smtClean="0">
+              <a:latin typeface="Arial" panose="020B0604020202020204" pitchFamily="34" charset="0"/>
+              <a:cs typeface="Arial" panose="020B0604020202020204" pitchFamily="34" charset="0"/>
             </a:rPr>
-            <a:t>Backend: FastAPI</a:t>
+            <a:t>Mở rộng áp dụng cho nhiều môn học khác</a:t>
           </a:r>
+          <a:endParaRPr lang="vi-VN" sz="2400" b="0">
+            <a:latin typeface="Arial" panose="020B0604020202020204" pitchFamily="34" charset="0"/>
+            <a:cs typeface="Arial" panose="020B0604020202020204" pitchFamily="34" charset="0"/>
+          </a:endParaRPr>
         </a:p>
       </dgm:t>
     </dgm:pt>
-    <dgm:pt modelId="{8455D939-67FE-4D26-BA70-FF8410048061}" type="parTrans" cxnId="{71DCA74D-8DDB-44CE-A12E-F9986389A08C}">
+    <dgm:pt modelId="{6CDBA07E-A620-4770-A53F-328DE0FBEF6F}" type="parTrans" cxnId="{F47387E4-A218-49C9-9469-9E9394138C52}">
       <dgm:prSet/>
       <dgm:spPr/>
       <dgm:t>
@@ -8085,7 +8304,7 @@
         </a:p>
       </dgm:t>
     </dgm:pt>
-    <dgm:pt modelId="{256B7880-A1A7-4347-AF74-6FA8761C5ACE}" type="sibTrans" cxnId="{71DCA74D-8DDB-44CE-A12E-F9986389A08C}">
+    <dgm:pt modelId="{FA392A2A-9C1B-4BD1-A301-AABC9A8B0F6E}" type="sibTrans" cxnId="{F47387E4-A218-49C9-9469-9E9394138C52}">
       <dgm:prSet/>
       <dgm:spPr/>
       <dgm:t>
@@ -8096,192 +8315,8 @@
         </a:p>
       </dgm:t>
     </dgm:pt>
-    <dgm:pt modelId="{591ECC5B-5CD0-4F7C-942D-51C9DAD7E3BF}">
-      <dgm:prSet custT="1"/>
-      <dgm:spPr/>
-      <dgm:t>
-        <a:bodyPr/>
-        <a:lstStyle/>
-        <a:p>
-          <a:pPr>
-            <a:lnSpc>
-              <a:spcPct val="150000"/>
-            </a:lnSpc>
-          </a:pPr>
-          <a:r>
-            <a:rPr lang="en-US" sz="1500">
-              <a:latin typeface="Arial "/>
-            </a:rPr>
-            <a:t>Application Database: </a:t>
-          </a:r>
-          <a:r>
-            <a:rPr lang="en-US" sz="1500" smtClean="0">
-              <a:latin typeface="Arial "/>
-            </a:rPr>
-            <a:t>PostgreSQL</a:t>
-          </a:r>
-          <a:endParaRPr lang="en-US" sz="1500">
-            <a:latin typeface="Arial "/>
-          </a:endParaRPr>
-        </a:p>
-      </dgm:t>
-    </dgm:pt>
-    <dgm:pt modelId="{A26BC2E1-EE2B-4362-92C4-44A06F2D85EF}" type="parTrans" cxnId="{5C8F7FF1-95D9-40A8-A007-D5C0163C4463}">
-      <dgm:prSet/>
-      <dgm:spPr/>
-      <dgm:t>
-        <a:bodyPr/>
-        <a:lstStyle/>
-        <a:p>
-          <a:endParaRPr lang="en-US"/>
-        </a:p>
-      </dgm:t>
-    </dgm:pt>
-    <dgm:pt modelId="{8EADAB8C-EBAB-427F-95BE-43B96F100962}" type="sibTrans" cxnId="{5C8F7FF1-95D9-40A8-A007-D5C0163C4463}">
-      <dgm:prSet/>
-      <dgm:spPr/>
-      <dgm:t>
-        <a:bodyPr/>
-        <a:lstStyle/>
-        <a:p>
-          <a:endParaRPr lang="en-US"/>
-        </a:p>
-      </dgm:t>
-    </dgm:pt>
-    <dgm:pt modelId="{2968FFA5-5128-418F-94F6-C2C05D54E353}">
-      <dgm:prSet custT="1"/>
-      <dgm:spPr/>
-      <dgm:t>
-        <a:bodyPr/>
-        <a:lstStyle/>
-        <a:p>
-          <a:pPr>
-            <a:lnSpc>
-              <a:spcPct val="150000"/>
-            </a:lnSpc>
-          </a:pPr>
-          <a:r>
-            <a:rPr lang="en-US" sz="1500">
-              <a:latin typeface="Arial "/>
-            </a:rPr>
-            <a:t>Vector Database: Qdrant</a:t>
-          </a:r>
-        </a:p>
-      </dgm:t>
-    </dgm:pt>
-    <dgm:pt modelId="{DB4AC3E4-C514-460E-821D-716D5CEF831F}" type="parTrans" cxnId="{9F5A8FD7-C92F-48B4-B127-796CFD609644}">
-      <dgm:prSet/>
-      <dgm:spPr/>
-      <dgm:t>
-        <a:bodyPr/>
-        <a:lstStyle/>
-        <a:p>
-          <a:endParaRPr lang="en-US"/>
-        </a:p>
-      </dgm:t>
-    </dgm:pt>
-    <dgm:pt modelId="{85BE8A1A-9AC9-4550-877D-0C8CA3D6F6C4}" type="sibTrans" cxnId="{9F5A8FD7-C92F-48B4-B127-796CFD609644}">
-      <dgm:prSet/>
-      <dgm:spPr/>
-      <dgm:t>
-        <a:bodyPr/>
-        <a:lstStyle/>
-        <a:p>
-          <a:endParaRPr lang="en-US"/>
-        </a:p>
-      </dgm:t>
-    </dgm:pt>
-    <dgm:pt modelId="{EA4D4725-576A-4638-8421-A99DD6F08115}">
-      <dgm:prSet custT="1"/>
-      <dgm:spPr/>
-      <dgm:t>
-        <a:bodyPr/>
-        <a:lstStyle/>
-        <a:p>
-          <a:pPr>
-            <a:lnSpc>
-              <a:spcPct val="150000"/>
-            </a:lnSpc>
-          </a:pPr>
-          <a:r>
-            <a:rPr lang="en-US" sz="1500">
-              <a:latin typeface="Arial "/>
-            </a:rPr>
-            <a:t>LLM: Gemini API</a:t>
-          </a:r>
-        </a:p>
-      </dgm:t>
-    </dgm:pt>
-    <dgm:pt modelId="{FEF0D118-80B3-40E3-8D97-97DB5B6CDA54}" type="parTrans" cxnId="{1E743142-7233-4E4D-95AD-F29C72363BCD}">
-      <dgm:prSet/>
-      <dgm:spPr/>
-      <dgm:t>
-        <a:bodyPr/>
-        <a:lstStyle/>
-        <a:p>
-          <a:endParaRPr lang="en-US"/>
-        </a:p>
-      </dgm:t>
-    </dgm:pt>
-    <dgm:pt modelId="{602E6C38-3019-425E-A5F6-F9AD9E72BB25}" type="sibTrans" cxnId="{1E743142-7233-4E4D-95AD-F29C72363BCD}">
-      <dgm:prSet/>
-      <dgm:spPr/>
-      <dgm:t>
-        <a:bodyPr/>
-        <a:lstStyle/>
-        <a:p>
-          <a:endParaRPr lang="en-US"/>
-        </a:p>
-      </dgm:t>
-    </dgm:pt>
-    <dgm:pt modelId="{5F685AFE-85B6-4412-8897-F65A01DE62B6}">
-      <dgm:prSet custT="1"/>
-      <dgm:spPr/>
-      <dgm:t>
-        <a:bodyPr/>
-        <a:lstStyle/>
-        <a:p>
-          <a:pPr>
-            <a:lnSpc>
-              <a:spcPct val="150000"/>
-            </a:lnSpc>
-          </a:pPr>
-          <a:r>
-            <a:rPr lang="en-US" sz="1500" smtClean="0">
-              <a:latin typeface="Arial "/>
-            </a:rPr>
-            <a:t>Container: Docker</a:t>
-          </a:r>
-          <a:endParaRPr lang="en-US" sz="1500">
-            <a:latin typeface="Arial "/>
-          </a:endParaRPr>
-        </a:p>
-      </dgm:t>
-    </dgm:pt>
-    <dgm:pt modelId="{BBA7805E-A46D-429D-A833-C17BD4604FB1}" type="parTrans" cxnId="{63A65D2D-04CC-414B-ADC9-4AC07741F168}">
-      <dgm:prSet/>
-      <dgm:spPr/>
-      <dgm:t>
-        <a:bodyPr/>
-        <a:lstStyle/>
-        <a:p>
-          <a:endParaRPr lang="en-US"/>
-        </a:p>
-      </dgm:t>
-    </dgm:pt>
-    <dgm:pt modelId="{E68F9E1C-882C-4844-A74D-570676DF9045}" type="sibTrans" cxnId="{63A65D2D-04CC-414B-ADC9-4AC07741F168}">
-      <dgm:prSet/>
-      <dgm:spPr/>
-      <dgm:t>
-        <a:bodyPr/>
-        <a:lstStyle/>
-        <a:p>
-          <a:endParaRPr lang="en-US"/>
-        </a:p>
-      </dgm:t>
-    </dgm:pt>
-    <dgm:pt modelId="{D9FD9C5D-66ED-4167-82BC-CEB4BEBF07E0}" type="pres">
-      <dgm:prSet presAssocID="{B820F01C-B89C-4146-B3CE-47D543CF7F89}" presName="linear" presStyleCnt="0">
+    <dgm:pt modelId="{C61E197E-C6B0-4A8A-8A52-E1E9C62D1469}" type="pres">
+      <dgm:prSet presAssocID="{687D8256-1659-432A-9D0B-7F4F9320D9EB}" presName="linear" presStyleCnt="0">
         <dgm:presLayoutVars>
           <dgm:dir/>
           <dgm:animLvl val="lvl"/>
@@ -8297,12 +8332,8 @@
         </a:p>
       </dgm:t>
     </dgm:pt>
-    <dgm:pt modelId="{95E2CC20-F3CC-4BE9-846E-F8D3DEA3D197}" type="pres">
-      <dgm:prSet presAssocID="{ADF8C160-C666-46E1-9519-EE1BA8420C00}" presName="parentLin" presStyleCnt="0"/>
-      <dgm:spPr/>
-    </dgm:pt>
-    <dgm:pt modelId="{A2EE139B-42AA-4E95-856B-0CFA2DE5CC8E}" type="pres">
-      <dgm:prSet presAssocID="{ADF8C160-C666-46E1-9519-EE1BA8420C00}" presName="parentLeftMargin" presStyleLbl="node1" presStyleIdx="0" presStyleCnt="1"/>
+    <dgm:pt modelId="{9B994DF4-A209-41DF-AA43-B5EA53FC4799}" type="pres">
+      <dgm:prSet presAssocID="{E952668C-975F-470E-85AE-4A2C08912C7D}" presName="parentLin" presStyleCnt="0"/>
       <dgm:spPr/>
       <dgm:t>
         <a:bodyPr/>
@@ -8312,8 +8343,19 @@
         </a:p>
       </dgm:t>
     </dgm:pt>
-    <dgm:pt modelId="{BAA6E47A-EAE7-460E-B70E-2BBD832609B7}" type="pres">
-      <dgm:prSet presAssocID="{ADF8C160-C666-46E1-9519-EE1BA8420C00}" presName="parentText" presStyleLbl="node1" presStyleIdx="0" presStyleCnt="1" custScaleX="714460" custScaleY="59420" custLinFactNeighborX="11144" custLinFactNeighborY="15283">
+    <dgm:pt modelId="{B3FB7B23-C287-4048-A0D5-789E41DA2DF1}" type="pres">
+      <dgm:prSet presAssocID="{E952668C-975F-470E-85AE-4A2C08912C7D}" presName="parentLeftMargin" presStyleLbl="node1" presStyleIdx="0" presStyleCnt="2"/>
+      <dgm:spPr/>
+      <dgm:t>
+        <a:bodyPr/>
+        <a:lstStyle/>
+        <a:p>
+          <a:endParaRPr lang="en-US"/>
+        </a:p>
+      </dgm:t>
+    </dgm:pt>
+    <dgm:pt modelId="{D4C39096-1203-4593-8975-D39D4983E187}" type="pres">
+      <dgm:prSet presAssocID="{E952668C-975F-470E-85AE-4A2C08912C7D}" presName="parentText" presStyleLbl="node1" presStyleIdx="0" presStyleCnt="2" custScaleY="31030" custLinFactNeighborX="-100000" custLinFactNeighborY="-38093">
         <dgm:presLayoutVars>
           <dgm:chMax val="0"/>
           <dgm:bulletEnabled val="1"/>
@@ -8328,12 +8370,94 @@
         </a:p>
       </dgm:t>
     </dgm:pt>
-    <dgm:pt modelId="{AF25C1F6-67A8-40B5-918B-0F57E4FDA1AF}" type="pres">
-      <dgm:prSet presAssocID="{ADF8C160-C666-46E1-9519-EE1BA8420C00}" presName="negativeSpace" presStyleCnt="0"/>
+    <dgm:pt modelId="{2D5C5F5F-BE3F-4791-B171-75F6AFBB0C76}" type="pres">
+      <dgm:prSet presAssocID="{E952668C-975F-470E-85AE-4A2C08912C7D}" presName="negativeSpace" presStyleCnt="0"/>
       <dgm:spPr/>
+      <dgm:t>
+        <a:bodyPr/>
+        <a:lstStyle/>
+        <a:p>
+          <a:endParaRPr lang="en-US"/>
+        </a:p>
+      </dgm:t>
     </dgm:pt>
-    <dgm:pt modelId="{333CA5EC-5E59-4853-9FAF-0949264CD166}" type="pres">
-      <dgm:prSet presAssocID="{ADF8C160-C666-46E1-9519-EE1BA8420C00}" presName="childText" presStyleLbl="conFgAcc1" presStyleIdx="0" presStyleCnt="1" custLinFactNeighborY="30956">
+    <dgm:pt modelId="{5210A33C-85E6-41F4-98E8-82BF08AFBDFF}" type="pres">
+      <dgm:prSet presAssocID="{E952668C-975F-470E-85AE-4A2C08912C7D}" presName="childText" presStyleLbl="conFgAcc1" presStyleIdx="0" presStyleCnt="2" custScaleY="55802" custLinFactNeighborX="-1447" custLinFactNeighborY="5656">
+        <dgm:presLayoutVars>
+          <dgm:bulletEnabled val="1"/>
+        </dgm:presLayoutVars>
+      </dgm:prSet>
+      <dgm:spPr/>
+      <dgm:t>
+        <a:bodyPr/>
+        <a:lstStyle/>
+        <a:p>
+          <a:endParaRPr lang="en-US"/>
+        </a:p>
+      </dgm:t>
+    </dgm:pt>
+    <dgm:pt modelId="{DEFBBC1D-09F5-4C15-9F81-BF79EED3E4CE}" type="pres">
+      <dgm:prSet presAssocID="{5B4A5D51-046A-4696-96E4-08F5338ECAA4}" presName="spaceBetweenRectangles" presStyleCnt="0"/>
+      <dgm:spPr/>
+      <dgm:t>
+        <a:bodyPr/>
+        <a:lstStyle/>
+        <a:p>
+          <a:endParaRPr lang="en-US"/>
+        </a:p>
+      </dgm:t>
+    </dgm:pt>
+    <dgm:pt modelId="{95F8C24F-4869-4A98-A3B5-F93D38F80EF7}" type="pres">
+      <dgm:prSet presAssocID="{559DBAB0-165C-4519-BCBF-74841D553990}" presName="parentLin" presStyleCnt="0"/>
+      <dgm:spPr/>
+      <dgm:t>
+        <a:bodyPr/>
+        <a:lstStyle/>
+        <a:p>
+          <a:endParaRPr lang="en-US"/>
+        </a:p>
+      </dgm:t>
+    </dgm:pt>
+    <dgm:pt modelId="{ED137E0A-5B6A-4FE9-96F2-3C7D6856490F}" type="pres">
+      <dgm:prSet presAssocID="{559DBAB0-165C-4519-BCBF-74841D553990}" presName="parentLeftMargin" presStyleLbl="node1" presStyleIdx="0" presStyleCnt="2"/>
+      <dgm:spPr/>
+      <dgm:t>
+        <a:bodyPr/>
+        <a:lstStyle/>
+        <a:p>
+          <a:endParaRPr lang="en-US"/>
+        </a:p>
+      </dgm:t>
+    </dgm:pt>
+    <dgm:pt modelId="{26359B7A-529D-4539-BC5D-8086974DBA2D}" type="pres">
+      <dgm:prSet presAssocID="{559DBAB0-165C-4519-BCBF-74841D553990}" presName="parentText" presStyleLbl="node1" presStyleIdx="1" presStyleCnt="2" custScaleY="30085" custLinFactNeighborX="-100000" custLinFactNeighborY="-16566">
+        <dgm:presLayoutVars>
+          <dgm:chMax val="0"/>
+          <dgm:bulletEnabled val="1"/>
+        </dgm:presLayoutVars>
+      </dgm:prSet>
+      <dgm:spPr/>
+      <dgm:t>
+        <a:bodyPr/>
+        <a:lstStyle/>
+        <a:p>
+          <a:endParaRPr lang="en-US"/>
+        </a:p>
+      </dgm:t>
+    </dgm:pt>
+    <dgm:pt modelId="{81C560CB-62C5-417B-A955-4F93D3155D70}" type="pres">
+      <dgm:prSet presAssocID="{559DBAB0-165C-4519-BCBF-74841D553990}" presName="negativeSpace" presStyleCnt="0"/>
+      <dgm:spPr/>
+      <dgm:t>
+        <a:bodyPr/>
+        <a:lstStyle/>
+        <a:p>
+          <a:endParaRPr lang="en-US"/>
+        </a:p>
+      </dgm:t>
+    </dgm:pt>
+    <dgm:pt modelId="{6B25478B-BC27-4651-B3DD-138A15D4A396}" type="pres">
+      <dgm:prSet presAssocID="{559DBAB0-165C-4519-BCBF-74841D553990}" presName="childText" presStyleLbl="conFgAcc1" presStyleIdx="1" presStyleCnt="2" custScaleY="67712" custLinFactNeighborY="44505">
         <dgm:presLayoutVars>
           <dgm:bulletEnabled val="1"/>
         </dgm:presLayoutVars>
@@ -8349,33 +8473,40 @@
     </dgm:pt>
   </dgm:ptLst>
   <dgm:cxnLst>
-    <dgm:cxn modelId="{FC3B222C-7F61-4755-BFA1-8A160FFD1EDE}" type="presOf" srcId="{591ECC5B-5CD0-4F7C-942D-51C9DAD7E3BF}" destId="{333CA5EC-5E59-4853-9FAF-0949264CD166}" srcOrd="0" destOrd="2" presId="urn:microsoft.com/office/officeart/2005/8/layout/list1"/>
-    <dgm:cxn modelId="{5121A9A9-3304-4259-933D-F8ACBEA4EFB9}" srcId="{ADF8C160-C666-46E1-9519-EE1BA8420C00}" destId="{7A86EFC7-A2BF-477B-8EAB-D9BCE0ED29EB}" srcOrd="0" destOrd="0" parTransId="{05EA01B0-0933-4D8B-99A8-1FAAF833E766}" sibTransId="{54B63D80-7CE5-4D6A-A68E-3D6A6ED5D122}"/>
-    <dgm:cxn modelId="{A9061701-C29C-401C-B9C4-14EC0D41477E}" type="presOf" srcId="{7A86EFC7-A2BF-477B-8EAB-D9BCE0ED29EB}" destId="{333CA5EC-5E59-4853-9FAF-0949264CD166}" srcOrd="0" destOrd="0" presId="urn:microsoft.com/office/officeart/2005/8/layout/list1"/>
-    <dgm:cxn modelId="{9F5A8FD7-C92F-48B4-B127-796CFD609644}" srcId="{ADF8C160-C666-46E1-9519-EE1BA8420C00}" destId="{2968FFA5-5128-418F-94F6-C2C05D54E353}" srcOrd="3" destOrd="0" parTransId="{DB4AC3E4-C514-460E-821D-716D5CEF831F}" sibTransId="{85BE8A1A-9AC9-4550-877D-0C8CA3D6F6C4}"/>
-    <dgm:cxn modelId="{8ABA1A1F-4F2C-40D7-A2A1-889D1DEF444E}" type="presOf" srcId="{ADF8C160-C666-46E1-9519-EE1BA8420C00}" destId="{BAA6E47A-EAE7-460E-B70E-2BBD832609B7}" srcOrd="1" destOrd="0" presId="urn:microsoft.com/office/officeart/2005/8/layout/list1"/>
-    <dgm:cxn modelId="{6F76C687-7293-4C4E-9FAF-F0E690BAAB93}" type="presOf" srcId="{B820F01C-B89C-4146-B3CE-47D543CF7F89}" destId="{D9FD9C5D-66ED-4167-82BC-CEB4BEBF07E0}" srcOrd="0" destOrd="0" presId="urn:microsoft.com/office/officeart/2005/8/layout/list1"/>
-    <dgm:cxn modelId="{CE3BA273-20A2-413E-98FF-BEEC3AD4EDAE}" type="presOf" srcId="{EA4D4725-576A-4638-8421-A99DD6F08115}" destId="{333CA5EC-5E59-4853-9FAF-0949264CD166}" srcOrd="0" destOrd="4" presId="urn:microsoft.com/office/officeart/2005/8/layout/list1"/>
-    <dgm:cxn modelId="{71DCA74D-8DDB-44CE-A12E-F9986389A08C}" srcId="{ADF8C160-C666-46E1-9519-EE1BA8420C00}" destId="{819B46DB-6C2A-4F0D-9592-9313B1A88DC8}" srcOrd="1" destOrd="0" parTransId="{8455D939-67FE-4D26-BA70-FF8410048061}" sibTransId="{256B7880-A1A7-4347-AF74-6FA8761C5ACE}"/>
-    <dgm:cxn modelId="{1E743142-7233-4E4D-95AD-F29C72363BCD}" srcId="{ADF8C160-C666-46E1-9519-EE1BA8420C00}" destId="{EA4D4725-576A-4638-8421-A99DD6F08115}" srcOrd="4" destOrd="0" parTransId="{FEF0D118-80B3-40E3-8D97-97DB5B6CDA54}" sibTransId="{602E6C38-3019-425E-A5F6-F9AD9E72BB25}"/>
-    <dgm:cxn modelId="{C416E518-0112-476E-AF66-A3DAA029B557}" type="presOf" srcId="{ADF8C160-C666-46E1-9519-EE1BA8420C00}" destId="{A2EE139B-42AA-4E95-856B-0CFA2DE5CC8E}" srcOrd="0" destOrd="0" presId="urn:microsoft.com/office/officeart/2005/8/layout/list1"/>
-    <dgm:cxn modelId="{D6240E9F-556A-443D-A13A-34F494ACE700}" srcId="{B820F01C-B89C-4146-B3CE-47D543CF7F89}" destId="{ADF8C160-C666-46E1-9519-EE1BA8420C00}" srcOrd="0" destOrd="0" parTransId="{D03B1926-5593-4A24-9BC7-A511876E6CF9}" sibTransId="{58939B33-A188-4D62-A41C-1FEB09084085}"/>
-    <dgm:cxn modelId="{3C6CBF70-2A3F-4478-8D3B-DD0A990A6AEA}" type="presOf" srcId="{2968FFA5-5128-418F-94F6-C2C05D54E353}" destId="{333CA5EC-5E59-4853-9FAF-0949264CD166}" srcOrd="0" destOrd="3" presId="urn:microsoft.com/office/officeart/2005/8/layout/list1"/>
-    <dgm:cxn modelId="{E064FB1F-C4DB-4FD3-9F5B-584A4E235A3D}" type="presOf" srcId="{819B46DB-6C2A-4F0D-9592-9313B1A88DC8}" destId="{333CA5EC-5E59-4853-9FAF-0949264CD166}" srcOrd="0" destOrd="1" presId="urn:microsoft.com/office/officeart/2005/8/layout/list1"/>
-    <dgm:cxn modelId="{63A65D2D-04CC-414B-ADC9-4AC07741F168}" srcId="{ADF8C160-C666-46E1-9519-EE1BA8420C00}" destId="{5F685AFE-85B6-4412-8897-F65A01DE62B6}" srcOrd="5" destOrd="0" parTransId="{BBA7805E-A46D-429D-A833-C17BD4604FB1}" sibTransId="{E68F9E1C-882C-4844-A74D-570676DF9045}"/>
-    <dgm:cxn modelId="{5C8F7FF1-95D9-40A8-A007-D5C0163C4463}" srcId="{ADF8C160-C666-46E1-9519-EE1BA8420C00}" destId="{591ECC5B-5CD0-4F7C-942D-51C9DAD7E3BF}" srcOrd="2" destOrd="0" parTransId="{A26BC2E1-EE2B-4362-92C4-44A06F2D85EF}" sibTransId="{8EADAB8C-EBAB-427F-95BE-43B96F100962}"/>
-    <dgm:cxn modelId="{DD037F48-BE3E-403B-BE9C-3E790875ECFD}" type="presOf" srcId="{5F685AFE-85B6-4412-8897-F65A01DE62B6}" destId="{333CA5EC-5E59-4853-9FAF-0949264CD166}" srcOrd="0" destOrd="5" presId="urn:microsoft.com/office/officeart/2005/8/layout/list1"/>
-    <dgm:cxn modelId="{80F34348-5632-44CA-8DFB-45F3AD1C3C62}" type="presParOf" srcId="{D9FD9C5D-66ED-4167-82BC-CEB4BEBF07E0}" destId="{95E2CC20-F3CC-4BE9-846E-F8D3DEA3D197}" srcOrd="0" destOrd="0" presId="urn:microsoft.com/office/officeart/2005/8/layout/list1"/>
-    <dgm:cxn modelId="{B6D63AD6-B4BC-4B20-A6C7-CA9886DF94C1}" type="presParOf" srcId="{95E2CC20-F3CC-4BE9-846E-F8D3DEA3D197}" destId="{A2EE139B-42AA-4E95-856B-0CFA2DE5CC8E}" srcOrd="0" destOrd="0" presId="urn:microsoft.com/office/officeart/2005/8/layout/list1"/>
-    <dgm:cxn modelId="{7C5BB462-70E9-4A3D-B28D-E4898DCDB4DA}" type="presParOf" srcId="{95E2CC20-F3CC-4BE9-846E-F8D3DEA3D197}" destId="{BAA6E47A-EAE7-460E-B70E-2BBD832609B7}" srcOrd="1" destOrd="0" presId="urn:microsoft.com/office/officeart/2005/8/layout/list1"/>
-    <dgm:cxn modelId="{AF9EF71C-EF2E-45C0-8D7B-469B8C294CA4}" type="presParOf" srcId="{D9FD9C5D-66ED-4167-82BC-CEB4BEBF07E0}" destId="{AF25C1F6-67A8-40B5-918B-0F57E4FDA1AF}" srcOrd="1" destOrd="0" presId="urn:microsoft.com/office/officeart/2005/8/layout/list1"/>
-    <dgm:cxn modelId="{CD3947B7-BB12-4F00-8788-C4DF9542D928}" type="presParOf" srcId="{D9FD9C5D-66ED-4167-82BC-CEB4BEBF07E0}" destId="{333CA5EC-5E59-4853-9FAF-0949264CD166}" srcOrd="2" destOrd="0" presId="urn:microsoft.com/office/officeart/2005/8/layout/list1"/>
+    <dgm:cxn modelId="{13675CC3-5DC9-4296-BD5F-EA6F4E5EADB4}" type="presOf" srcId="{FE6CA380-3F6C-458D-977C-BD6BA6DA2F05}" destId="{5210A33C-85E6-41F4-98E8-82BF08AFBDFF}" srcOrd="0" destOrd="1" presId="urn:microsoft.com/office/officeart/2005/8/layout/list1"/>
+    <dgm:cxn modelId="{8EB94F73-890E-4A96-A76F-D45BEC5A9FF8}" type="presOf" srcId="{559DBAB0-165C-4519-BCBF-74841D553990}" destId="{ED137E0A-5B6A-4FE9-96F2-3C7D6856490F}" srcOrd="0" destOrd="0" presId="urn:microsoft.com/office/officeart/2005/8/layout/list1"/>
+    <dgm:cxn modelId="{F47387E4-A218-49C9-9469-9E9394138C52}" srcId="{559DBAB0-165C-4519-BCBF-74841D553990}" destId="{BD594D7B-67FC-4D49-A510-C0612D804C65}" srcOrd="1" destOrd="0" parTransId="{6CDBA07E-A620-4770-A53F-328DE0FBEF6F}" sibTransId="{FA392A2A-9C1B-4BD1-A301-AABC9A8B0F6E}"/>
+    <dgm:cxn modelId="{4C2010E5-A35D-4F5F-9F37-9CA764983542}" srcId="{687D8256-1659-432A-9D0B-7F4F9320D9EB}" destId="{559DBAB0-165C-4519-BCBF-74841D553990}" srcOrd="1" destOrd="0" parTransId="{05CAB70D-014A-4D45-AFBE-1A8B49DCC621}" sibTransId="{0BD09816-00A9-4E33-8C83-AE06967AA411}"/>
+    <dgm:cxn modelId="{25B8C02A-5A10-4509-A984-0DF35AF3D48B}" type="presOf" srcId="{E952668C-975F-470E-85AE-4A2C08912C7D}" destId="{D4C39096-1203-4593-8975-D39D4983E187}" srcOrd="1" destOrd="0" presId="urn:microsoft.com/office/officeart/2005/8/layout/list1"/>
+    <dgm:cxn modelId="{90F53AD0-EBCE-434A-83E5-9F37428797B3}" srcId="{559DBAB0-165C-4519-BCBF-74841D553990}" destId="{0FFA85E1-284E-4378-9668-B59008A155BE}" srcOrd="0" destOrd="0" parTransId="{B6AA499E-9B8C-4082-A375-108A80900696}" sibTransId="{9536FE3B-62EE-4DA2-8287-C32F11D40FB1}"/>
+    <dgm:cxn modelId="{66569C17-8025-48FB-9911-214452CE57E1}" type="presOf" srcId="{F24BB8E2-1A92-4D98-9BAE-44C2302C22CF}" destId="{6B25478B-BC27-4651-B3DD-138A15D4A396}" srcOrd="0" destOrd="2" presId="urn:microsoft.com/office/officeart/2005/8/layout/list1"/>
+    <dgm:cxn modelId="{B8473B30-E5BD-4EF1-BDB5-00C3660342D0}" type="presOf" srcId="{E952668C-975F-470E-85AE-4A2C08912C7D}" destId="{B3FB7B23-C287-4048-A0D5-789E41DA2DF1}" srcOrd="0" destOrd="0" presId="urn:microsoft.com/office/officeart/2005/8/layout/list1"/>
+    <dgm:cxn modelId="{7FFFF2DC-7332-4B2D-823B-3DF1E33B2942}" srcId="{E952668C-975F-470E-85AE-4A2C08912C7D}" destId="{FE6CA380-3F6C-458D-977C-BD6BA6DA2F05}" srcOrd="1" destOrd="0" parTransId="{594B3884-6EA6-4116-A837-2BC8BBF84A22}" sibTransId="{92E40D9A-3523-4BE5-9523-D174FDCD1CCF}"/>
+    <dgm:cxn modelId="{D8D81CBC-ACB1-4C68-9CD6-1E5807C36886}" srcId="{687D8256-1659-432A-9D0B-7F4F9320D9EB}" destId="{E952668C-975F-470E-85AE-4A2C08912C7D}" srcOrd="0" destOrd="0" parTransId="{30B5313B-3348-4EC4-80AC-05838E0DB9D9}" sibTransId="{5B4A5D51-046A-4696-96E4-08F5338ECAA4}"/>
+    <dgm:cxn modelId="{C41572B7-5B02-4C5F-B3C4-5E2B39ED675E}" srcId="{559DBAB0-165C-4519-BCBF-74841D553990}" destId="{F24BB8E2-1A92-4D98-9BAE-44C2302C22CF}" srcOrd="2" destOrd="0" parTransId="{7745FE9F-C3B7-445D-B2E2-F8430E2FD325}" sibTransId="{1EFD18C1-6AD5-4219-927A-D7080426077E}"/>
+    <dgm:cxn modelId="{E9C6E9F3-C622-4FCD-AF35-467D4CF590CA}" type="presOf" srcId="{0FFA85E1-284E-4378-9668-B59008A155BE}" destId="{6B25478B-BC27-4651-B3DD-138A15D4A396}" srcOrd="0" destOrd="0" presId="urn:microsoft.com/office/officeart/2005/8/layout/list1"/>
+    <dgm:cxn modelId="{F5141D73-5445-47AE-A209-6EA3B5FC169D}" type="presOf" srcId="{559DBAB0-165C-4519-BCBF-74841D553990}" destId="{26359B7A-529D-4539-BC5D-8086974DBA2D}" srcOrd="1" destOrd="0" presId="urn:microsoft.com/office/officeart/2005/8/layout/list1"/>
+    <dgm:cxn modelId="{9C98E6A1-86A4-447D-B16E-0FCCD929470A}" type="presOf" srcId="{BD594D7B-67FC-4D49-A510-C0612D804C65}" destId="{6B25478B-BC27-4651-B3DD-138A15D4A396}" srcOrd="0" destOrd="1" presId="urn:microsoft.com/office/officeart/2005/8/layout/list1"/>
+    <dgm:cxn modelId="{27E07F05-A274-4BFE-9ED9-9268E0D234C3}" type="presOf" srcId="{687D8256-1659-432A-9D0B-7F4F9320D9EB}" destId="{C61E197E-C6B0-4A8A-8A52-E1E9C62D1469}" srcOrd="0" destOrd="0" presId="urn:microsoft.com/office/officeart/2005/8/layout/list1"/>
+    <dgm:cxn modelId="{19FA11D4-1A15-4D93-8DFA-0E8B324E7500}" srcId="{E952668C-975F-470E-85AE-4A2C08912C7D}" destId="{D62D50D1-EE9F-4322-8446-72807BDDC2A3}" srcOrd="0" destOrd="0" parTransId="{CD82F050-B62D-421F-980D-80EB6269DD22}" sibTransId="{BAB88D84-78F0-4E67-853A-20CF6B292CD9}"/>
+    <dgm:cxn modelId="{BD3F3C7E-6465-4122-8DCB-C90A52EEE4D0}" type="presOf" srcId="{D62D50D1-EE9F-4322-8446-72807BDDC2A3}" destId="{5210A33C-85E6-41F4-98E8-82BF08AFBDFF}" srcOrd="0" destOrd="0" presId="urn:microsoft.com/office/officeart/2005/8/layout/list1"/>
+    <dgm:cxn modelId="{FB8BF0C3-4D3E-4F43-B3A4-677313918D95}" type="presParOf" srcId="{C61E197E-C6B0-4A8A-8A52-E1E9C62D1469}" destId="{9B994DF4-A209-41DF-AA43-B5EA53FC4799}" srcOrd="0" destOrd="0" presId="urn:microsoft.com/office/officeart/2005/8/layout/list1"/>
+    <dgm:cxn modelId="{40DACC7C-5F5A-4ECC-A8B8-00300398D3DA}" type="presParOf" srcId="{9B994DF4-A209-41DF-AA43-B5EA53FC4799}" destId="{B3FB7B23-C287-4048-A0D5-789E41DA2DF1}" srcOrd="0" destOrd="0" presId="urn:microsoft.com/office/officeart/2005/8/layout/list1"/>
+    <dgm:cxn modelId="{6A5E87D8-67D0-4387-B31D-5EC6CFE1250D}" type="presParOf" srcId="{9B994DF4-A209-41DF-AA43-B5EA53FC4799}" destId="{D4C39096-1203-4593-8975-D39D4983E187}" srcOrd="1" destOrd="0" presId="urn:microsoft.com/office/officeart/2005/8/layout/list1"/>
+    <dgm:cxn modelId="{79E09E71-B066-4E48-8A24-9625547975CA}" type="presParOf" srcId="{C61E197E-C6B0-4A8A-8A52-E1E9C62D1469}" destId="{2D5C5F5F-BE3F-4791-B171-75F6AFBB0C76}" srcOrd="1" destOrd="0" presId="urn:microsoft.com/office/officeart/2005/8/layout/list1"/>
+    <dgm:cxn modelId="{72CAAEDC-BDC5-49CA-A566-F21D87BCCE5E}" type="presParOf" srcId="{C61E197E-C6B0-4A8A-8A52-E1E9C62D1469}" destId="{5210A33C-85E6-41F4-98E8-82BF08AFBDFF}" srcOrd="2" destOrd="0" presId="urn:microsoft.com/office/officeart/2005/8/layout/list1"/>
+    <dgm:cxn modelId="{12B3EE8B-5C49-4604-B7EB-A572098B55F9}" type="presParOf" srcId="{C61E197E-C6B0-4A8A-8A52-E1E9C62D1469}" destId="{DEFBBC1D-09F5-4C15-9F81-BF79EED3E4CE}" srcOrd="3" destOrd="0" presId="urn:microsoft.com/office/officeart/2005/8/layout/list1"/>
+    <dgm:cxn modelId="{DD2D0CBE-90A2-4BF0-992C-FB823A37DFD0}" type="presParOf" srcId="{C61E197E-C6B0-4A8A-8A52-E1E9C62D1469}" destId="{95F8C24F-4869-4A98-A3B5-F93D38F80EF7}" srcOrd="4" destOrd="0" presId="urn:microsoft.com/office/officeart/2005/8/layout/list1"/>
+    <dgm:cxn modelId="{5F3BF7CF-69FA-429A-9C42-01379085160C}" type="presParOf" srcId="{95F8C24F-4869-4A98-A3B5-F93D38F80EF7}" destId="{ED137E0A-5B6A-4FE9-96F2-3C7D6856490F}" srcOrd="0" destOrd="0" presId="urn:microsoft.com/office/officeart/2005/8/layout/list1"/>
+    <dgm:cxn modelId="{E185F200-9007-4BE2-8557-2A46CE35E74F}" type="presParOf" srcId="{95F8C24F-4869-4A98-A3B5-F93D38F80EF7}" destId="{26359B7A-529D-4539-BC5D-8086974DBA2D}" srcOrd="1" destOrd="0" presId="urn:microsoft.com/office/officeart/2005/8/layout/list1"/>
+    <dgm:cxn modelId="{97C5A18E-7F26-4932-802F-8A9E03188D47}" type="presParOf" srcId="{C61E197E-C6B0-4A8A-8A52-E1E9C62D1469}" destId="{81C560CB-62C5-417B-A955-4F93D3155D70}" srcOrd="5" destOrd="0" presId="urn:microsoft.com/office/officeart/2005/8/layout/list1"/>
+    <dgm:cxn modelId="{0F678EAC-4AF7-4B31-A15A-3BE2498FDBB4}" type="presParOf" srcId="{C61E197E-C6B0-4A8A-8A52-E1E9C62D1469}" destId="{6B25478B-BC27-4651-B3DD-138A15D4A396}" srcOrd="6" destOrd="0" presId="urn:microsoft.com/office/officeart/2005/8/layout/list1"/>
   </dgm:cxnLst>
   <dgm:bg/>
   <dgm:whole/>
   <dgm:extLst>
     <a:ext uri="http://schemas.microsoft.com/office/drawing/2008/diagram">
-      <dsp:dataModelExt xmlns:dsp="http://schemas.microsoft.com/office/drawing/2008/diagram" relId="rId8" minVer="http://schemas.openxmlformats.org/drawingml/2006/diagram"/>
+      <dsp:dataModelExt xmlns:dsp="http://schemas.microsoft.com/office/drawing/2008/diagram" relId="rId7" minVer="http://schemas.openxmlformats.org/drawingml/2006/diagram"/>
     </a:ext>
   </dgm:extLst>
 </dgm:dataModel>
@@ -8644,7 +8775,7 @@
               <a:latin typeface="Arial" panose="020B0604020202020204" pitchFamily="34" charset="0"/>
               <a:cs typeface="Arial" panose="020B0604020202020204" pitchFamily="34" charset="0"/>
             </a:rPr>
-            <a:t>Cơ sở lý thuyết</a:t>
+            <a:t>Công nghệ sử dụng</a:t>
           </a:r>
           <a:endParaRPr lang="en-US" sz="2800" kern="1200">
             <a:latin typeface="Arial" panose="020B0604020202020204" pitchFamily="34" charset="0"/>
@@ -9061,35 +9192,7 @@
               <a:latin typeface="Arial" panose="020B0604020202020204" pitchFamily="34" charset="0"/>
               <a:cs typeface="Arial" panose="020B0604020202020204" pitchFamily="34" charset="0"/>
             </a:rPr>
-            <a:t>nghiên cứu </a:t>
-          </a:r>
-          <a:r>
-            <a:rPr lang="vi-VN" sz="2800" kern="1200" smtClean="0">
-              <a:latin typeface="Arial" panose="020B0604020202020204" pitchFamily="34" charset="0"/>
-              <a:cs typeface="Arial" panose="020B0604020202020204" pitchFamily="34" charset="0"/>
-            </a:rPr>
-            <a:t>và </a:t>
-          </a:r>
-          <a:r>
-            <a:rPr lang="vi-VN" sz="2800" kern="1200" err="1">
-              <a:latin typeface="Arial" panose="020B0604020202020204" pitchFamily="34" charset="0"/>
-              <a:cs typeface="Arial" panose="020B0604020202020204" pitchFamily="34" charset="0"/>
-            </a:rPr>
-            <a:t>đánh</a:t>
-          </a:r>
-          <a:r>
-            <a:rPr lang="vi-VN" sz="2800" kern="1200">
-              <a:latin typeface="Arial" panose="020B0604020202020204" pitchFamily="34" charset="0"/>
-              <a:cs typeface="Arial" panose="020B0604020202020204" pitchFamily="34" charset="0"/>
-            </a:rPr>
-            <a:t> </a:t>
-          </a:r>
-          <a:r>
-            <a:rPr lang="vi-VN" sz="2800" kern="1200" err="1">
-              <a:latin typeface="Arial" panose="020B0604020202020204" pitchFamily="34" charset="0"/>
-              <a:cs typeface="Arial" panose="020B0604020202020204" pitchFamily="34" charset="0"/>
-            </a:rPr>
-            <a:t>giá</a:t>
+            <a:t>nghiên cứu</a:t>
           </a:r>
           <a:endParaRPr lang="en-US" sz="2800" kern="1200">
             <a:latin typeface="Arial" panose="020B0604020202020204" pitchFamily="34" charset="0"/>
@@ -9431,7 +9534,7 @@
       </dsp:nvSpPr>
       <dsp:spPr>
         <a:xfrm>
-          <a:off x="0" y="339207"/>
+          <a:off x="0" y="349100"/>
           <a:ext cx="8886874" cy="1316699"/>
         </a:xfrm>
         <a:prstGeom prst="rect">
@@ -9525,7 +9628,7 @@
         </a:p>
       </dsp:txBody>
       <dsp:txXfrm>
-        <a:off x="0" y="339207"/>
+        <a:off x="0" y="349100"/>
         <a:ext cx="8886874" cy="1316699"/>
       </dsp:txXfrm>
     </dsp:sp>
@@ -9536,7 +9639,7 @@
       </dsp:nvSpPr>
       <dsp:spPr>
         <a:xfrm>
-          <a:off x="444343" y="14487"/>
+          <a:off x="444343" y="24377"/>
           <a:ext cx="6220811" cy="649440"/>
         </a:xfrm>
         <a:prstGeom prst="roundRect">
@@ -9595,18 +9698,23 @@
             </a:spcAft>
           </a:pPr>
           <a:r>
-            <a:rPr lang="en-US" sz="2400" b="1" kern="1200" smtClean="0"/>
+            <a:rPr lang="en-US" sz="2400" b="1" kern="1200" smtClean="0">
+              <a:latin typeface="Arial" panose="020B0604020202020204" pitchFamily="34" charset="0"/>
+              <a:cs typeface="Arial" panose="020B0604020202020204" pitchFamily="34" charset="0"/>
+            </a:rPr>
             <a:t>Thực trạng hiện tại</a:t>
           </a:r>
           <a:endParaRPr lang="en-US" sz="2400" kern="1200">
             <a:solidFill>
               <a:srgbClr val="FFFF00"/>
             </a:solidFill>
+            <a:latin typeface="Arial" panose="020B0604020202020204" pitchFamily="34" charset="0"/>
+            <a:cs typeface="Arial" panose="020B0604020202020204" pitchFamily="34" charset="0"/>
           </a:endParaRPr>
         </a:p>
       </dsp:txBody>
       <dsp:txXfrm>
-        <a:off x="476046" y="46190"/>
+        <a:off x="476046" y="56080"/>
         <a:ext cx="6157405" cy="586034"/>
       </dsp:txXfrm>
     </dsp:sp>
@@ -9617,7 +9725,7 @@
       </dsp:nvSpPr>
       <dsp:spPr>
         <a:xfrm>
-          <a:off x="0" y="2099427"/>
+          <a:off x="0" y="2109320"/>
           <a:ext cx="8886874" cy="1316699"/>
         </a:xfrm>
         <a:prstGeom prst="rect">
@@ -9714,7 +9822,7 @@
         </a:p>
       </dsp:txBody>
       <dsp:txXfrm>
-        <a:off x="0" y="2099427"/>
+        <a:off x="0" y="2109320"/>
         <a:ext cx="8886874" cy="1316699"/>
       </dsp:txXfrm>
     </dsp:sp>
@@ -9725,7 +9833,7 @@
       </dsp:nvSpPr>
       <dsp:spPr>
         <a:xfrm>
-          <a:off x="444343" y="1774707"/>
+          <a:off x="444343" y="1784597"/>
           <a:ext cx="6220811" cy="649440"/>
         </a:xfrm>
         <a:prstGeom prst="roundRect">
@@ -9784,22 +9892,34 @@
             </a:spcAft>
           </a:pPr>
           <a:r>
-            <a:rPr lang="en-US" sz="2400" b="1" kern="1200" err="1"/>
+            <a:rPr lang="en-US" sz="2400" b="1" kern="1200" err="1">
+              <a:latin typeface="Arial" panose="020B0604020202020204" pitchFamily="34" charset="0"/>
+              <a:cs typeface="Arial" panose="020B0604020202020204" pitchFamily="34" charset="0"/>
+            </a:rPr>
             <a:t>Vấn</a:t>
           </a:r>
           <a:r>
-            <a:rPr lang="en-US" sz="2400" b="1" kern="1200"/>
+            <a:rPr lang="en-US" sz="2400" b="1" kern="1200">
+              <a:latin typeface="Arial" panose="020B0604020202020204" pitchFamily="34" charset="0"/>
+              <a:cs typeface="Arial" panose="020B0604020202020204" pitchFamily="34" charset="0"/>
+            </a:rPr>
             <a:t> </a:t>
           </a:r>
           <a:r>
-            <a:rPr lang="en-US" sz="2400" b="1" kern="1200" err="1"/>
+            <a:rPr lang="en-US" sz="2400" b="1" kern="1200" err="1">
+              <a:latin typeface="Arial" panose="020B0604020202020204" pitchFamily="34" charset="0"/>
+              <a:cs typeface="Arial" panose="020B0604020202020204" pitchFamily="34" charset="0"/>
+            </a:rPr>
             <a:t>đề</a:t>
           </a:r>
-          <a:endParaRPr lang="en-US" sz="2400" kern="1200"/>
+          <a:endParaRPr lang="en-US" sz="2400" kern="1200">
+            <a:latin typeface="Arial" panose="020B0604020202020204" pitchFamily="34" charset="0"/>
+            <a:cs typeface="Arial" panose="020B0604020202020204" pitchFamily="34" charset="0"/>
+          </a:endParaRPr>
         </a:p>
       </dsp:txBody>
       <dsp:txXfrm>
-        <a:off x="476046" y="1806410"/>
+        <a:off x="476046" y="1816300"/>
         <a:ext cx="6157405" cy="586034"/>
       </dsp:txXfrm>
     </dsp:sp>
@@ -9810,7 +9930,7 @@
       </dsp:nvSpPr>
       <dsp:spPr>
         <a:xfrm>
-          <a:off x="0" y="3864241"/>
+          <a:off x="0" y="3874133"/>
           <a:ext cx="8886874" cy="1316699"/>
         </a:xfrm>
         <a:prstGeom prst="rect">
@@ -9907,7 +10027,7 @@
         </a:p>
       </dsp:txBody>
       <dsp:txXfrm>
-        <a:off x="0" y="3864241"/>
+        <a:off x="0" y="3874133"/>
         <a:ext cx="8886874" cy="1316699"/>
       </dsp:txXfrm>
     </dsp:sp>
@@ -9918,7 +10038,7 @@
       </dsp:nvSpPr>
       <dsp:spPr>
         <a:xfrm>
-          <a:off x="444343" y="3534927"/>
+          <a:off x="444343" y="3544817"/>
           <a:ext cx="6220811" cy="649440"/>
         </a:xfrm>
         <a:prstGeom prst="roundRect">
@@ -9977,34 +10097,55 @@
             </a:spcAft>
           </a:pPr>
           <a:r>
-            <a:rPr lang="en-US" sz="2400" b="1" kern="1200" err="1"/>
+            <a:rPr lang="en-US" sz="2400" b="1" kern="1200" err="1">
+              <a:latin typeface="Arial" panose="020B0604020202020204" pitchFamily="34" charset="0"/>
+              <a:cs typeface="Arial" panose="020B0604020202020204" pitchFamily="34" charset="0"/>
+            </a:rPr>
             <a:t>Hạn</a:t>
           </a:r>
           <a:r>
-            <a:rPr lang="en-US" sz="2400" b="1" kern="1200"/>
+            <a:rPr lang="en-US" sz="2400" b="1" kern="1200">
+              <a:latin typeface="Arial" panose="020B0604020202020204" pitchFamily="34" charset="0"/>
+              <a:cs typeface="Arial" panose="020B0604020202020204" pitchFamily="34" charset="0"/>
+            </a:rPr>
             <a:t> </a:t>
           </a:r>
           <a:r>
-            <a:rPr lang="en-US" sz="2400" b="1" kern="1200" err="1"/>
+            <a:rPr lang="en-US" sz="2400" b="1" kern="1200" err="1">
+              <a:latin typeface="Arial" panose="020B0604020202020204" pitchFamily="34" charset="0"/>
+              <a:cs typeface="Arial" panose="020B0604020202020204" pitchFamily="34" charset="0"/>
+            </a:rPr>
             <a:t>chế</a:t>
           </a:r>
           <a:r>
-            <a:rPr lang="en-US" sz="2400" b="1" kern="1200"/>
+            <a:rPr lang="en-US" sz="2400" b="1" kern="1200">
+              <a:latin typeface="Arial" panose="020B0604020202020204" pitchFamily="34" charset="0"/>
+              <a:cs typeface="Arial" panose="020B0604020202020204" pitchFamily="34" charset="0"/>
+            </a:rPr>
             <a:t> </a:t>
           </a:r>
           <a:r>
-            <a:rPr lang="en-US" sz="2400" b="1" kern="1200" smtClean="0"/>
+            <a:rPr lang="en-US" sz="2400" b="1" kern="1200" smtClean="0">
+              <a:latin typeface="Arial" panose="020B0604020202020204" pitchFamily="34" charset="0"/>
+              <a:cs typeface="Arial" panose="020B0604020202020204" pitchFamily="34" charset="0"/>
+            </a:rPr>
             <a:t>của các công cụ AI hiện </a:t>
           </a:r>
           <a:r>
-            <a:rPr lang="en-US" sz="2400" b="1" kern="1200"/>
+            <a:rPr lang="en-US" sz="2400" b="1" kern="1200">
+              <a:latin typeface="Arial" panose="020B0604020202020204" pitchFamily="34" charset="0"/>
+              <a:cs typeface="Arial" panose="020B0604020202020204" pitchFamily="34" charset="0"/>
+            </a:rPr>
             <a:t>nay</a:t>
           </a:r>
-          <a:endParaRPr lang="en-US" sz="2400" kern="1200"/>
+          <a:endParaRPr lang="en-US" sz="2400" kern="1200">
+            <a:latin typeface="Arial" panose="020B0604020202020204" pitchFamily="34" charset="0"/>
+            <a:cs typeface="Arial" panose="020B0604020202020204" pitchFamily="34" charset="0"/>
+          </a:endParaRPr>
         </a:p>
       </dsp:txBody>
       <dsp:txXfrm>
-        <a:off x="476046" y="3566630"/>
+        <a:off x="476046" y="3576520"/>
         <a:ext cx="6157405" cy="586034"/>
       </dsp:txXfrm>
     </dsp:sp>
@@ -10537,14 +10678,7 @@
               <a:latin typeface="Arial" panose="020B0604020202020204" pitchFamily="34" charset="0"/>
               <a:cs typeface="Arial" panose="020B0604020202020204" pitchFamily="34" charset="0"/>
             </a:rPr>
-            <a:t>Nội dung bám </a:t>
-          </a:r>
-          <a:r>
-            <a:rPr lang="vi-VN" sz="2400" b="0" kern="1200" smtClean="0">
-              <a:latin typeface="Arial" panose="020B0604020202020204" pitchFamily="34" charset="0"/>
-              <a:cs typeface="Arial" panose="020B0604020202020204" pitchFamily="34" charset="0"/>
-            </a:rPr>
-            <a:t>sát </a:t>
+            <a:t>Nội dung bám sát </a:t>
           </a:r>
           <a:r>
             <a:rPr lang="en-US" sz="2400" b="0" kern="1200" smtClean="0">
@@ -10558,14 +10692,7 @@
               <a:latin typeface="Arial" panose="020B0604020202020204" pitchFamily="34" charset="0"/>
               <a:cs typeface="Arial" panose="020B0604020202020204" pitchFamily="34" charset="0"/>
             </a:rPr>
-            <a:t>đề </a:t>
-          </a:r>
-          <a:r>
-            <a:rPr lang="vi-VN" sz="2400" b="0" kern="1200" smtClean="0">
-              <a:latin typeface="Arial" panose="020B0604020202020204" pitchFamily="34" charset="0"/>
-              <a:cs typeface="Arial" panose="020B0604020202020204" pitchFamily="34" charset="0"/>
-            </a:rPr>
-            <a:t>cương môn học</a:t>
+            <a:t>đề cương môn học</a:t>
           </a:r>
           <a:endParaRPr lang="en-US" sz="2400" b="0" kern="1200">
             <a:latin typeface="Arial" panose="020B0604020202020204" pitchFamily="34" charset="0"/>
@@ -10597,8 +10724,8 @@
       </dsp:nvSpPr>
       <dsp:spPr>
         <a:xfrm>
-          <a:off x="0" y="204263"/>
-          <a:ext cx="2983426" cy="2520000"/>
+          <a:off x="0" y="158426"/>
+          <a:ext cx="2983426" cy="2898000"/>
         </a:xfrm>
         <a:prstGeom prst="rect">
           <a:avLst/>
@@ -10705,6 +10832,29 @@
             <a:rPr lang="en-US" sz="2400" kern="1200" smtClean="0">
               <a:latin typeface="Arial "/>
             </a:rPr>
+            <a:t>Tạo bài giảng</a:t>
+          </a:r>
+          <a:endParaRPr lang="en-US" sz="2400" kern="1200">
+            <a:latin typeface="Arial "/>
+          </a:endParaRPr>
+        </a:p>
+        <a:p>
+          <a:pPr marL="228600" lvl="1" indent="-228600" algn="l" defTabSz="1066800">
+            <a:lnSpc>
+              <a:spcPct val="90000"/>
+            </a:lnSpc>
+            <a:spcBef>
+              <a:spcPct val="0"/>
+            </a:spcBef>
+            <a:spcAft>
+              <a:spcPct val="15000"/>
+            </a:spcAft>
+            <a:buChar char="••"/>
+          </a:pPr>
+          <a:r>
+            <a:rPr lang="en-US" sz="2400" kern="1200" smtClean="0">
+              <a:latin typeface="Arial "/>
+            </a:rPr>
             <a:t>Tạo câu hỏi</a:t>
           </a:r>
           <a:endParaRPr lang="en-US" sz="2400" kern="1200">
@@ -10759,8 +10909,8 @@
         </a:p>
       </dsp:txBody>
       <dsp:txXfrm>
-        <a:off x="0" y="204263"/>
-        <a:ext cx="2983426" cy="2520000"/>
+        <a:off x="0" y="158426"/>
+        <a:ext cx="2983426" cy="2898000"/>
       </dsp:txXfrm>
     </dsp:sp>
     <dsp:sp modelId="{BAA6E47A-EAE7-460E-B70E-2BBD832609B7}">
@@ -10770,7 +10920,7 @@
       </dsp:nvSpPr>
       <dsp:spPr>
         <a:xfrm>
-          <a:off x="149171" y="56663"/>
+          <a:off x="149171" y="10826"/>
           <a:ext cx="2088398" cy="295200"/>
         </a:xfrm>
         <a:prstGeom prst="roundRect">
@@ -10837,7 +10987,7 @@
         </a:p>
       </dsp:txBody>
       <dsp:txXfrm>
-        <a:off x="163581" y="71073"/>
+        <a:off x="163581" y="25236"/>
         <a:ext cx="2059578" cy="266380"/>
       </dsp:txXfrm>
     </dsp:sp>
@@ -10848,7 +10998,7 @@
       </dsp:nvSpPr>
       <dsp:spPr>
         <a:xfrm>
-          <a:off x="0" y="2925863"/>
+          <a:off x="0" y="3258027"/>
           <a:ext cx="2983426" cy="2079000"/>
         </a:xfrm>
         <a:prstGeom prst="rect">
@@ -10916,13 +11066,7 @@
             <a:rPr lang="en-US" sz="2400" kern="1200" smtClean="0">
               <a:latin typeface="Arial "/>
             </a:rPr>
-            <a:t>tài </a:t>
-          </a:r>
-          <a:r>
-            <a:rPr lang="en-US" sz="2400" kern="1200" smtClean="0">
-              <a:latin typeface="Arial "/>
-            </a:rPr>
-            <a:t>liệu</a:t>
+            <a:t>tài liệu</a:t>
           </a:r>
           <a:endParaRPr lang="en-US" sz="2400" kern="1200">
             <a:latin typeface="Arial "/>
@@ -10951,13 +11095,7 @@
             <a:rPr lang="en-US" sz="2400" kern="1200" smtClean="0">
               <a:latin typeface="Arial "/>
             </a:rPr>
-            <a:t> </a:t>
-          </a:r>
-          <a:r>
-            <a:rPr lang="en-US" sz="2400" kern="1200" smtClean="0">
-              <a:latin typeface="Arial "/>
-            </a:rPr>
-            <a:t>người </a:t>
+            <a:t> người </a:t>
           </a:r>
           <a:r>
             <a:rPr lang="vi-VN" sz="2400" kern="1200" smtClean="0">
@@ -10992,13 +11130,7 @@
             <a:rPr lang="en-US" sz="2400" kern="1200" smtClean="0">
               <a:latin typeface="Arial "/>
             </a:rPr>
-            <a:t>em </a:t>
-          </a:r>
-          <a:r>
-            <a:rPr lang="en-US" sz="2400" kern="1200" smtClean="0">
-              <a:latin typeface="Arial "/>
-            </a:rPr>
-            <a:t>thống kê  hệ thống</a:t>
+            <a:t>em thống kê  hệ thống</a:t>
           </a:r>
           <a:endParaRPr lang="en-US" sz="2400" kern="1200">
             <a:latin typeface="Arial "/>
@@ -11006,7 +11138,7 @@
         </a:p>
       </dsp:txBody>
       <dsp:txXfrm>
-        <a:off x="0" y="2925863"/>
+        <a:off x="0" y="3258027"/>
         <a:ext cx="2983426" cy="2079000"/>
       </dsp:txXfrm>
     </dsp:sp>
@@ -11017,7 +11149,7 @@
       </dsp:nvSpPr>
       <dsp:spPr>
         <a:xfrm>
-          <a:off x="149171" y="2778263"/>
+          <a:off x="149171" y="3110426"/>
           <a:ext cx="2088398" cy="295200"/>
         </a:xfrm>
         <a:prstGeom prst="roundRect">
@@ -11084,7 +11216,7 @@
         </a:p>
       </dsp:txBody>
       <dsp:txXfrm>
-        <a:off x="163581" y="2792673"/>
+        <a:off x="163581" y="3124836"/>
         <a:ext cx="2059578" cy="266380"/>
       </dsp:txXfrm>
     </dsp:sp>
@@ -11343,15 +11475,15 @@
       <dsp:cNvGrpSpPr/>
     </dsp:nvGrpSpPr>
     <dsp:grpSpPr/>
-    <dsp:sp modelId="{333CA5EC-5E59-4853-9FAF-0949264CD166}">
+    <dsp:sp modelId="{5210A33C-85E6-41F4-98E8-82BF08AFBDFF}">
       <dsp:nvSpPr>
         <dsp:cNvPr id="0" name=""/>
         <dsp:cNvSpPr/>
       </dsp:nvSpPr>
       <dsp:spPr>
         <a:xfrm>
-          <a:off x="0" y="593909"/>
-          <a:ext cx="2687365" cy="3931199"/>
+          <a:off x="0" y="597724"/>
+          <a:ext cx="8442782" cy="1574955"/>
         </a:xfrm>
         <a:prstGeom prst="rect">
           <a:avLst/>
@@ -11391,14 +11523,40 @@
         <a:fontRef idx="minor"/>
       </dsp:style>
       <dsp:txBody>
-        <a:bodyPr spcFirstLastPara="0" vert="horz" wrap="square" lIns="208569" tIns="1332992" rIns="208569" bIns="106680" numCol="1" spcCol="1270" anchor="t" anchorCtr="0">
+        <a:bodyPr spcFirstLastPara="0" vert="horz" wrap="square" lIns="655254" tIns="395732" rIns="655254" bIns="170688" numCol="1" spcCol="1270" anchor="t" anchorCtr="0">
           <a:noAutofit/>
         </a:bodyPr>
         <a:lstStyle/>
         <a:p>
-          <a:pPr marL="114300" lvl="1" indent="-114300" algn="l" defTabSz="666750">
+          <a:pPr marL="228600" lvl="1" indent="-228600" algn="l" defTabSz="1066800">
             <a:lnSpc>
-              <a:spcPct val="150000"/>
+              <a:spcPct val="90000"/>
+            </a:lnSpc>
+            <a:spcBef>
+              <a:spcPct val="0"/>
+            </a:spcBef>
+            <a:spcAft>
+              <a:spcPct val="15000"/>
+            </a:spcAft>
+            <a:buFont typeface="Arial" panose="020B0604020202020204" pitchFamily="34" charset="0"/>
+            <a:buChar char="••"/>
+          </a:pPr>
+          <a:r>
+            <a:rPr lang="en-US" sz="2400" kern="1200" smtClean="0">
+              <a:latin typeface="Arial" panose="020B0604020202020204" pitchFamily="34" charset="0"/>
+              <a:cs typeface="Arial" panose="020B0604020202020204" pitchFamily="34" charset="0"/>
+            </a:rPr>
+            <a:t>Xây dựng thành công hệ thống </a:t>
+          </a:r>
+          <a:endParaRPr lang="en-US" sz="2400" b="0" kern="1200">
+            <a:latin typeface="Arial" panose="020B0604020202020204" pitchFamily="34" charset="0"/>
+            <a:cs typeface="Arial" panose="020B0604020202020204" pitchFamily="34" charset="0"/>
+          </a:endParaRPr>
+        </a:p>
+        <a:p>
+          <a:pPr marL="228600" lvl="1" indent="-228600" algn="l" defTabSz="1066800">
+            <a:lnSpc>
+              <a:spcPct val="90000"/>
             </a:lnSpc>
             <a:spcBef>
               <a:spcPct val="0"/>
@@ -11409,142 +11567,46 @@
             <a:buChar char="••"/>
           </a:pPr>
           <a:r>
-            <a:rPr lang="en-US" sz="1500" kern="1200" smtClean="0">
-              <a:latin typeface="Arial "/>
+            <a:rPr lang="vi-VN" sz="2400" kern="1200" smtClean="0">
+              <a:latin typeface="Arial" panose="020B0604020202020204" pitchFamily="34" charset="0"/>
+              <a:cs typeface="Arial" panose="020B0604020202020204" pitchFamily="34" charset="0"/>
             </a:rPr>
-            <a:t>Frontend: ReactJS + Vite</a:t>
-          </a:r>
-          <a:endParaRPr lang="en-US" sz="1500" kern="1200">
-            <a:latin typeface="Arial "/>
-          </a:endParaRPr>
-        </a:p>
-        <a:p>
-          <a:pPr marL="114300" lvl="1" indent="-114300" algn="l" defTabSz="666750">
-            <a:lnSpc>
-              <a:spcPct val="150000"/>
-            </a:lnSpc>
-            <a:spcBef>
-              <a:spcPct val="0"/>
-            </a:spcBef>
-            <a:spcAft>
-              <a:spcPct val="15000"/>
-            </a:spcAft>
-            <a:buChar char="••"/>
-          </a:pPr>
-          <a:r>
-            <a:rPr lang="en-US" sz="1500" kern="1200">
-              <a:latin typeface="Arial "/>
-            </a:rPr>
-            <a:t>Backend: FastAPI</a:t>
-          </a:r>
-        </a:p>
-        <a:p>
-          <a:pPr marL="114300" lvl="1" indent="-114300" algn="l" defTabSz="666750">
-            <a:lnSpc>
-              <a:spcPct val="150000"/>
-            </a:lnSpc>
-            <a:spcBef>
-              <a:spcPct val="0"/>
-            </a:spcBef>
-            <a:spcAft>
-              <a:spcPct val="15000"/>
-            </a:spcAft>
-            <a:buChar char="••"/>
-          </a:pPr>
-          <a:r>
-            <a:rPr lang="en-US" sz="1500" kern="1200">
-              <a:latin typeface="Arial "/>
-            </a:rPr>
-            <a:t>Application Database: </a:t>
+            <a:t>Giảm thời gian</a:t>
           </a:r>
           <a:r>
-            <a:rPr lang="en-US" sz="1500" kern="1200" smtClean="0">
-              <a:latin typeface="Arial "/>
+            <a:rPr lang="en-US" sz="2400" kern="1200" smtClean="0">
+              <a:latin typeface="Arial" panose="020B0604020202020204" pitchFamily="34" charset="0"/>
+              <a:cs typeface="Arial" panose="020B0604020202020204" pitchFamily="34" charset="0"/>
             </a:rPr>
-            <a:t>PostgreSQL</a:t>
+            <a:t>, công sức </a:t>
           </a:r>
-          <a:endParaRPr lang="en-US" sz="1500" kern="1200">
-            <a:latin typeface="Arial "/>
-          </a:endParaRPr>
-        </a:p>
-        <a:p>
-          <a:pPr marL="114300" lvl="1" indent="-114300" algn="l" defTabSz="666750">
-            <a:lnSpc>
-              <a:spcPct val="150000"/>
-            </a:lnSpc>
-            <a:spcBef>
-              <a:spcPct val="0"/>
-            </a:spcBef>
-            <a:spcAft>
-              <a:spcPct val="15000"/>
-            </a:spcAft>
-            <a:buChar char="••"/>
-          </a:pPr>
           <a:r>
-            <a:rPr lang="en-US" sz="1500" kern="1200">
-              <a:latin typeface="Arial "/>
+            <a:rPr lang="vi-VN" sz="2400" kern="1200" smtClean="0">
+              <a:latin typeface="Arial" panose="020B0604020202020204" pitchFamily="34" charset="0"/>
+              <a:cs typeface="Arial" panose="020B0604020202020204" pitchFamily="34" charset="0"/>
             </a:rPr>
-            <a:t>Vector Database: Qdrant</a:t>
+            <a:t>biên soạn học liệu cho giảng viên.</a:t>
           </a:r>
-        </a:p>
-        <a:p>
-          <a:pPr marL="114300" lvl="1" indent="-114300" algn="l" defTabSz="666750">
-            <a:lnSpc>
-              <a:spcPct val="150000"/>
-            </a:lnSpc>
-            <a:spcBef>
-              <a:spcPct val="0"/>
-            </a:spcBef>
-            <a:spcAft>
-              <a:spcPct val="15000"/>
-            </a:spcAft>
-            <a:buChar char="••"/>
-          </a:pPr>
-          <a:r>
-            <a:rPr lang="en-US" sz="1500" kern="1200">
-              <a:latin typeface="Arial "/>
-            </a:rPr>
-            <a:t>LLM: Gemini API</a:t>
-          </a:r>
-        </a:p>
-        <a:p>
-          <a:pPr marL="114300" lvl="1" indent="-114300" algn="l" defTabSz="666750">
-            <a:lnSpc>
-              <a:spcPct val="150000"/>
-            </a:lnSpc>
-            <a:spcBef>
-              <a:spcPct val="0"/>
-            </a:spcBef>
-            <a:spcAft>
-              <a:spcPct val="15000"/>
-            </a:spcAft>
-            <a:buChar char="••"/>
-          </a:pPr>
-          <a:r>
-            <a:rPr lang="en-US" sz="1500" kern="1200" smtClean="0">
-              <a:latin typeface="Arial "/>
-            </a:rPr>
-            <a:t>Container: Docker</a:t>
-          </a:r>
-          <a:endParaRPr lang="en-US" sz="1500" kern="1200">
-            <a:latin typeface="Arial "/>
+          <a:endParaRPr lang="vi-VN" sz="2400" kern="1200">
+            <a:latin typeface="Arial" panose="020B0604020202020204" pitchFamily="34" charset="0"/>
+            <a:cs typeface="Arial" panose="020B0604020202020204" pitchFamily="34" charset="0"/>
           </a:endParaRPr>
         </a:p>
       </dsp:txBody>
       <dsp:txXfrm>
-        <a:off x="0" y="593909"/>
-        <a:ext cx="2687365" cy="3931199"/>
+        <a:off x="0" y="597724"/>
+        <a:ext cx="8442782" cy="1574955"/>
       </dsp:txXfrm>
     </dsp:sp>
-    <dsp:sp modelId="{BAA6E47A-EAE7-460E-B70E-2BBD832609B7}">
+    <dsp:sp modelId="{D4C39096-1203-4593-8975-D39D4983E187}">
       <dsp:nvSpPr>
         <dsp:cNvPr id="0" name=""/>
         <dsp:cNvSpPr/>
       </dsp:nvSpPr>
       <dsp:spPr>
         <a:xfrm>
-          <a:off x="29532" y="496708"/>
-          <a:ext cx="2657833" cy="1122610"/>
+          <a:off x="0" y="216890"/>
+          <a:ext cx="5909947" cy="586243"/>
         </a:xfrm>
         <a:prstGeom prst="roundRect">
           <a:avLst/>
@@ -11585,12 +11647,12 @@
         </a:fontRef>
       </dsp:style>
       <dsp:txBody>
-        <a:bodyPr spcFirstLastPara="0" vert="horz" wrap="square" lIns="71103" tIns="0" rIns="71103" bIns="0" numCol="1" spcCol="1270" anchor="ctr" anchorCtr="0">
+        <a:bodyPr spcFirstLastPara="0" vert="horz" wrap="square" lIns="223382" tIns="0" rIns="223382" bIns="0" numCol="1" spcCol="1270" anchor="ctr" anchorCtr="0">
           <a:noAutofit/>
         </a:bodyPr>
         <a:lstStyle/>
         <a:p>
-          <a:pPr lvl="0" algn="l" defTabSz="977900">
+          <a:pPr lvl="0" algn="l" defTabSz="1066800">
             <a:lnSpc>
               <a:spcPct val="90000"/>
             </a:lnSpc>
@@ -11602,19 +11664,233 @@
             </a:spcAft>
           </a:pPr>
           <a:r>
-            <a:rPr lang="en-US" sz="2200" kern="1200" smtClean="0">
-              <a:latin typeface="Arial "/>
+            <a:rPr lang="en-US" sz="2400" b="1" kern="1200" smtClean="0">
+              <a:latin typeface="Arial" panose="020B0604020202020204" pitchFamily="34" charset="0"/>
+              <a:cs typeface="Arial" panose="020B0604020202020204" pitchFamily="34" charset="0"/>
             </a:rPr>
-            <a:t>Kiến trúc triển khai</a:t>
+            <a:t>Kết luận</a:t>
           </a:r>
-          <a:endParaRPr lang="en-US" sz="2200" kern="1200">
-            <a:latin typeface="Arial "/>
+          <a:endParaRPr lang="en-US" sz="2400" kern="1200">
+            <a:solidFill>
+              <a:srgbClr val="FFFF00"/>
+            </a:solidFill>
+            <a:latin typeface="Arial" panose="020B0604020202020204" pitchFamily="34" charset="0"/>
+            <a:cs typeface="Arial" panose="020B0604020202020204" pitchFamily="34" charset="0"/>
           </a:endParaRPr>
         </a:p>
       </dsp:txBody>
       <dsp:txXfrm>
-        <a:off x="84333" y="551509"/>
-        <a:ext cx="2548231" cy="1013008"/>
+        <a:off x="28618" y="245508"/>
+        <a:ext cx="5852711" cy="529007"/>
+      </dsp:txXfrm>
+    </dsp:sp>
+    <dsp:sp modelId="{6B25478B-BC27-4651-B3DD-138A15D4A396}">
+      <dsp:nvSpPr>
+        <dsp:cNvPr id="0" name=""/>
+        <dsp:cNvSpPr/>
+      </dsp:nvSpPr>
+      <dsp:spPr>
+        <a:xfrm>
+          <a:off x="0" y="2542895"/>
+          <a:ext cx="8442782" cy="1945230"/>
+        </a:xfrm>
+        <a:prstGeom prst="rect">
+          <a:avLst/>
+        </a:prstGeom>
+        <a:solidFill>
+          <a:schemeClr val="lt2">
+            <a:alpha val="90000"/>
+            <a:hueOff val="0"/>
+            <a:satOff val="0"/>
+            <a:lumOff val="0"/>
+            <a:alphaOff val="0"/>
+          </a:schemeClr>
+        </a:solidFill>
+        <a:ln w="25400" cap="flat" cmpd="sng" algn="ctr">
+          <a:solidFill>
+            <a:schemeClr val="dk2">
+              <a:hueOff val="0"/>
+              <a:satOff val="0"/>
+              <a:lumOff val="0"/>
+              <a:alphaOff val="0"/>
+            </a:schemeClr>
+          </a:solidFill>
+          <a:prstDash val="solid"/>
+        </a:ln>
+        <a:effectLst/>
+      </dsp:spPr>
+      <dsp:style>
+        <a:lnRef idx="2">
+          <a:scrgbClr r="0" g="0" b="0"/>
+        </a:lnRef>
+        <a:fillRef idx="1">
+          <a:scrgbClr r="0" g="0" b="0"/>
+        </a:fillRef>
+        <a:effectRef idx="0">
+          <a:scrgbClr r="0" g="0" b="0"/>
+        </a:effectRef>
+        <a:fontRef idx="minor"/>
+      </dsp:style>
+      <dsp:txBody>
+        <a:bodyPr spcFirstLastPara="0" vert="horz" wrap="square" lIns="655254" tIns="395732" rIns="655254" bIns="170688" numCol="1" spcCol="1270" anchor="t" anchorCtr="0">
+          <a:noAutofit/>
+        </a:bodyPr>
+        <a:lstStyle/>
+        <a:p>
+          <a:pPr marL="228600" lvl="1" indent="-228600" algn="l" defTabSz="1066800">
+            <a:lnSpc>
+              <a:spcPct val="90000"/>
+            </a:lnSpc>
+            <a:spcBef>
+              <a:spcPct val="0"/>
+            </a:spcBef>
+            <a:spcAft>
+              <a:spcPct val="15000"/>
+            </a:spcAft>
+            <a:buChar char="••"/>
+          </a:pPr>
+          <a:r>
+            <a:rPr lang="en-US" sz="2400" b="0" kern="1200" smtClean="0">
+              <a:latin typeface="Arial" panose="020B0604020202020204" pitchFamily="34" charset="0"/>
+              <a:cs typeface="Arial" panose="020B0604020202020204" pitchFamily="34" charset="0"/>
+            </a:rPr>
+            <a:t>Áp dụng các kỹ thuật RAG tiên tiến nâng cao    chất lượng nội dung</a:t>
+          </a:r>
+          <a:endParaRPr lang="vi-VN" sz="2400" b="0" kern="1200">
+            <a:latin typeface="Arial" panose="020B0604020202020204" pitchFamily="34" charset="0"/>
+            <a:cs typeface="Arial" panose="020B0604020202020204" pitchFamily="34" charset="0"/>
+          </a:endParaRPr>
+        </a:p>
+        <a:p>
+          <a:pPr marL="228600" lvl="1" indent="-228600" algn="l" defTabSz="1066800">
+            <a:lnSpc>
+              <a:spcPct val="90000"/>
+            </a:lnSpc>
+            <a:spcBef>
+              <a:spcPct val="0"/>
+            </a:spcBef>
+            <a:spcAft>
+              <a:spcPct val="15000"/>
+            </a:spcAft>
+            <a:buChar char="••"/>
+          </a:pPr>
+          <a:r>
+            <a:rPr lang="en-US" sz="2400" b="0" kern="1200" smtClean="0">
+              <a:latin typeface="Arial" panose="020B0604020202020204" pitchFamily="34" charset="0"/>
+              <a:cs typeface="Arial" panose="020B0604020202020204" pitchFamily="34" charset="0"/>
+            </a:rPr>
+            <a:t>Mở rộng áp dụng cho nhiều môn học khác</a:t>
+          </a:r>
+          <a:endParaRPr lang="vi-VN" sz="2400" b="0" kern="1200">
+            <a:latin typeface="Arial" panose="020B0604020202020204" pitchFamily="34" charset="0"/>
+            <a:cs typeface="Arial" panose="020B0604020202020204" pitchFamily="34" charset="0"/>
+          </a:endParaRPr>
+        </a:p>
+        <a:p>
+          <a:pPr marL="228600" lvl="1" indent="-228600" algn="l" defTabSz="1066800">
+            <a:lnSpc>
+              <a:spcPct val="90000"/>
+            </a:lnSpc>
+            <a:spcBef>
+              <a:spcPct val="0"/>
+            </a:spcBef>
+            <a:spcAft>
+              <a:spcPct val="15000"/>
+            </a:spcAft>
+            <a:buChar char="••"/>
+          </a:pPr>
+          <a:endParaRPr lang="vi-VN" sz="2400" b="0" kern="1200">
+            <a:latin typeface="Arial" panose="020B0604020202020204" pitchFamily="34" charset="0"/>
+            <a:cs typeface="Arial" panose="020B0604020202020204" pitchFamily="34" charset="0"/>
+          </a:endParaRPr>
+        </a:p>
+      </dsp:txBody>
+      <dsp:txXfrm>
+        <a:off x="0" y="2542895"/>
+        <a:ext cx="8442782" cy="1945230"/>
+      </dsp:txXfrm>
+    </dsp:sp>
+    <dsp:sp modelId="{26359B7A-529D-4539-BC5D-8086974DBA2D}">
+      <dsp:nvSpPr>
+        <dsp:cNvPr id="0" name=""/>
+        <dsp:cNvSpPr/>
+      </dsp:nvSpPr>
+      <dsp:spPr>
+        <a:xfrm>
+          <a:off x="0" y="2185755"/>
+          <a:ext cx="5909947" cy="568389"/>
+        </a:xfrm>
+        <a:prstGeom prst="roundRect">
+          <a:avLst/>
+        </a:prstGeom>
+        <a:solidFill>
+          <a:schemeClr val="dk2">
+            <a:hueOff val="0"/>
+            <a:satOff val="0"/>
+            <a:lumOff val="0"/>
+            <a:alphaOff val="0"/>
+          </a:schemeClr>
+        </a:solidFill>
+        <a:ln w="25400" cap="flat" cmpd="sng" algn="ctr">
+          <a:solidFill>
+            <a:schemeClr val="lt2">
+              <a:hueOff val="0"/>
+              <a:satOff val="0"/>
+              <a:lumOff val="0"/>
+              <a:alphaOff val="0"/>
+            </a:schemeClr>
+          </a:solidFill>
+          <a:prstDash val="solid"/>
+        </a:ln>
+        <a:effectLst/>
+      </dsp:spPr>
+      <dsp:style>
+        <a:lnRef idx="2">
+          <a:scrgbClr r="0" g="0" b="0"/>
+        </a:lnRef>
+        <a:fillRef idx="1">
+          <a:scrgbClr r="0" g="0" b="0"/>
+        </a:fillRef>
+        <a:effectRef idx="0">
+          <a:scrgbClr r="0" g="0" b="0"/>
+        </a:effectRef>
+        <a:fontRef idx="minor">
+          <a:schemeClr val="lt1"/>
+        </a:fontRef>
+      </dsp:style>
+      <dsp:txBody>
+        <a:bodyPr spcFirstLastPara="0" vert="horz" wrap="square" lIns="223382" tIns="0" rIns="223382" bIns="0" numCol="1" spcCol="1270" anchor="ctr" anchorCtr="0">
+          <a:noAutofit/>
+        </a:bodyPr>
+        <a:lstStyle/>
+        <a:p>
+          <a:pPr lvl="0" algn="l" defTabSz="1066800">
+            <a:lnSpc>
+              <a:spcPct val="90000"/>
+            </a:lnSpc>
+            <a:spcBef>
+              <a:spcPct val="0"/>
+            </a:spcBef>
+            <a:spcAft>
+              <a:spcPct val="35000"/>
+            </a:spcAft>
+          </a:pPr>
+          <a:r>
+            <a:rPr lang="en-US" sz="2400" b="1" kern="1200" smtClean="0">
+              <a:latin typeface="Arial" panose="020B0604020202020204" pitchFamily="34" charset="0"/>
+              <a:cs typeface="Arial" panose="020B0604020202020204" pitchFamily="34" charset="0"/>
+            </a:rPr>
+            <a:t>Hướng phát triển</a:t>
+          </a:r>
+          <a:endParaRPr lang="en-US" sz="2400" kern="1200">
+            <a:latin typeface="Arial" panose="020B0604020202020204" pitchFamily="34" charset="0"/>
+            <a:cs typeface="Arial" panose="020B0604020202020204" pitchFamily="34" charset="0"/>
+          </a:endParaRPr>
+        </a:p>
+      </dsp:txBody>
+      <dsp:txXfrm>
+        <a:off x="27746" y="2213501"/>
+        <a:ext cx="5854455" cy="512897"/>
       </dsp:txXfrm>
     </dsp:sp>
   </dsp:spTree>
@@ -19257,7 +19533,7 @@
           <a:p>
             <a:fld id="{B8B0FA47-8B15-437F-B746-4611B2E50E7E}" type="datetimeFigureOut">
               <a:rPr lang="en-US" smtClean="0"/>
-              <a:t>7/3/2026</a:t>
+              <a:t>7/5/2026</a:t>
             </a:fld>
             <a:endParaRPr lang="en-US"/>
           </a:p>
@@ -19682,7 +19958,7 @@
     </p:spTree>
     <p:extLst>
       <p:ext uri="{BB962C8B-B14F-4D97-AF65-F5344CB8AC3E}">
-        <p14:creationId xmlns:p14="http://schemas.microsoft.com/office/powerpoint/2010/main" val="3983740262"/>
+        <p14:creationId xmlns:p14="http://schemas.microsoft.com/office/powerpoint/2010/main" val="4237075540"/>
       </p:ext>
     </p:extLst>
   </p:cSld>
@@ -19766,7 +20042,7 @@
     </p:spTree>
     <p:extLst>
       <p:ext uri="{BB962C8B-B14F-4D97-AF65-F5344CB8AC3E}">
-        <p14:creationId xmlns:p14="http://schemas.microsoft.com/office/powerpoint/2010/main" val="4237075540"/>
+        <p14:creationId xmlns:p14="http://schemas.microsoft.com/office/powerpoint/2010/main" val="2777833408"/>
       </p:ext>
     </p:extLst>
   </p:cSld>
@@ -19850,7 +20126,7 @@
     </p:spTree>
     <p:extLst>
       <p:ext uri="{BB962C8B-B14F-4D97-AF65-F5344CB8AC3E}">
-        <p14:creationId xmlns:p14="http://schemas.microsoft.com/office/powerpoint/2010/main" val="2777833408"/>
+        <p14:creationId xmlns:p14="http://schemas.microsoft.com/office/powerpoint/2010/main" val="3965894856"/>
       </p:ext>
     </p:extLst>
   </p:cSld>
@@ -19934,7 +20210,7 @@
     </p:spTree>
     <p:extLst>
       <p:ext uri="{BB962C8B-B14F-4D97-AF65-F5344CB8AC3E}">
-        <p14:creationId xmlns:p14="http://schemas.microsoft.com/office/powerpoint/2010/main" val="3965894856"/>
+        <p14:creationId xmlns:p14="http://schemas.microsoft.com/office/powerpoint/2010/main" val="2082147552"/>
       </p:ext>
     </p:extLst>
   </p:cSld>
@@ -20018,7 +20294,7 @@
     </p:spTree>
     <p:extLst>
       <p:ext uri="{BB962C8B-B14F-4D97-AF65-F5344CB8AC3E}">
-        <p14:creationId xmlns:p14="http://schemas.microsoft.com/office/powerpoint/2010/main" val="2082147552"/>
+        <p14:creationId xmlns:p14="http://schemas.microsoft.com/office/powerpoint/2010/main" val="1359437176"/>
       </p:ext>
     </p:extLst>
   </p:cSld>
@@ -20094,174 +20370,6 @@
             <a:fld id="{7EAFC3B5-3211-45B9-A75F-21C4D8AB734F}" type="slidenum">
               <a:rPr lang="en-US" smtClean="0"/>
               <a:t>16</a:t>
-            </a:fld>
-            <a:endParaRPr lang="en-US"/>
-          </a:p>
-        </p:txBody>
-      </p:sp>
-    </p:spTree>
-    <p:extLst>
-      <p:ext uri="{BB962C8B-B14F-4D97-AF65-F5344CB8AC3E}">
-        <p14:creationId xmlns:p14="http://schemas.microsoft.com/office/powerpoint/2010/main" val="2642110491"/>
-      </p:ext>
-    </p:extLst>
-  </p:cSld>
-  <p:clrMapOvr>
-    <a:masterClrMapping/>
-  </p:clrMapOvr>
-</p:notes>
-</file>
-
-<file path=ppt/notesSlides/notesSlide16.xml><?xml version="1.0" encoding="utf-8"?>
-<p:notes xmlns:a="http://schemas.openxmlformats.org/drawingml/2006/main" xmlns:r="http://schemas.openxmlformats.org/officeDocument/2006/relationships" xmlns:p="http://schemas.openxmlformats.org/presentationml/2006/main">
-  <p:cSld>
-    <p:spTree>
-      <p:nvGrpSpPr>
-        <p:cNvPr id="1" name=""/>
-        <p:cNvGrpSpPr/>
-        <p:nvPr/>
-      </p:nvGrpSpPr>
-      <p:grpSpPr>
-        <a:xfrm>
-          <a:off x="0" y="0"/>
-          <a:ext cx="0" cy="0"/>
-          <a:chOff x="0" y="0"/>
-          <a:chExt cx="0" cy="0"/>
-        </a:xfrm>
-      </p:grpSpPr>
-      <p:sp>
-        <p:nvSpPr>
-          <p:cNvPr id="2" name="Slide Image Placeholder 1"/>
-          <p:cNvSpPr>
-            <a:spLocks noGrp="1" noRot="1" noChangeAspect="1"/>
-          </p:cNvSpPr>
-          <p:nvPr>
-            <p:ph type="sldImg"/>
-          </p:nvPr>
-        </p:nvSpPr>
-        <p:spPr/>
-      </p:sp>
-      <p:sp>
-        <p:nvSpPr>
-          <p:cNvPr id="3" name="Notes Placeholder 2"/>
-          <p:cNvSpPr>
-            <a:spLocks noGrp="1"/>
-          </p:cNvSpPr>
-          <p:nvPr>
-            <p:ph type="body" idx="1"/>
-          </p:nvPr>
-        </p:nvSpPr>
-        <p:spPr/>
-        <p:txBody>
-          <a:bodyPr/>
-          <a:lstStyle/>
-          <a:p>
-            <a:endParaRPr lang="en-US"/>
-          </a:p>
-        </p:txBody>
-      </p:sp>
-      <p:sp>
-        <p:nvSpPr>
-          <p:cNvPr id="4" name="Slide Number Placeholder 3"/>
-          <p:cNvSpPr>
-            <a:spLocks noGrp="1"/>
-          </p:cNvSpPr>
-          <p:nvPr>
-            <p:ph type="sldNum" sz="quarter" idx="10"/>
-          </p:nvPr>
-        </p:nvSpPr>
-        <p:spPr/>
-        <p:txBody>
-          <a:bodyPr/>
-          <a:lstStyle/>
-          <a:p>
-            <a:fld id="{7EAFC3B5-3211-45B9-A75F-21C4D8AB734F}" type="slidenum">
-              <a:rPr lang="en-US" smtClean="0"/>
-              <a:t>17</a:t>
-            </a:fld>
-            <a:endParaRPr lang="en-US"/>
-          </a:p>
-        </p:txBody>
-      </p:sp>
-    </p:spTree>
-    <p:extLst>
-      <p:ext uri="{BB962C8B-B14F-4D97-AF65-F5344CB8AC3E}">
-        <p14:creationId xmlns:p14="http://schemas.microsoft.com/office/powerpoint/2010/main" val="3623019760"/>
-      </p:ext>
-    </p:extLst>
-  </p:cSld>
-  <p:clrMapOvr>
-    <a:masterClrMapping/>
-  </p:clrMapOvr>
-</p:notes>
-</file>
-
-<file path=ppt/notesSlides/notesSlide17.xml><?xml version="1.0" encoding="utf-8"?>
-<p:notes xmlns:a="http://schemas.openxmlformats.org/drawingml/2006/main" xmlns:r="http://schemas.openxmlformats.org/officeDocument/2006/relationships" xmlns:p="http://schemas.openxmlformats.org/presentationml/2006/main">
-  <p:cSld>
-    <p:spTree>
-      <p:nvGrpSpPr>
-        <p:cNvPr id="1" name=""/>
-        <p:cNvGrpSpPr/>
-        <p:nvPr/>
-      </p:nvGrpSpPr>
-      <p:grpSpPr>
-        <a:xfrm>
-          <a:off x="0" y="0"/>
-          <a:ext cx="0" cy="0"/>
-          <a:chOff x="0" y="0"/>
-          <a:chExt cx="0" cy="0"/>
-        </a:xfrm>
-      </p:grpSpPr>
-      <p:sp>
-        <p:nvSpPr>
-          <p:cNvPr id="2" name="Slide Image Placeholder 1"/>
-          <p:cNvSpPr>
-            <a:spLocks noGrp="1" noRot="1" noChangeAspect="1"/>
-          </p:cNvSpPr>
-          <p:nvPr>
-            <p:ph type="sldImg"/>
-          </p:nvPr>
-        </p:nvSpPr>
-        <p:spPr/>
-      </p:sp>
-      <p:sp>
-        <p:nvSpPr>
-          <p:cNvPr id="3" name="Notes Placeholder 2"/>
-          <p:cNvSpPr>
-            <a:spLocks noGrp="1"/>
-          </p:cNvSpPr>
-          <p:nvPr>
-            <p:ph type="body" idx="1"/>
-          </p:nvPr>
-        </p:nvSpPr>
-        <p:spPr/>
-        <p:txBody>
-          <a:bodyPr/>
-          <a:lstStyle/>
-          <a:p>
-            <a:endParaRPr lang="en-US"/>
-          </a:p>
-        </p:txBody>
-      </p:sp>
-      <p:sp>
-        <p:nvSpPr>
-          <p:cNvPr id="4" name="Slide Number Placeholder 3"/>
-          <p:cNvSpPr>
-            <a:spLocks noGrp="1"/>
-          </p:cNvSpPr>
-          <p:nvPr>
-            <p:ph type="sldNum" sz="quarter" idx="10"/>
-          </p:nvPr>
-        </p:nvSpPr>
-        <p:spPr/>
-        <p:txBody>
-          <a:bodyPr/>
-          <a:lstStyle/>
-          <a:p>
-            <a:fld id="{7EAFC3B5-3211-45B9-A75F-21C4D8AB734F}" type="slidenum">
-              <a:rPr lang="en-US" smtClean="0"/>
-              <a:t>18</a:t>
             </a:fld>
             <a:endParaRPr lang="en-US"/>
           </a:p>
@@ -20942,7 +21050,7 @@
     </p:spTree>
     <p:extLst>
       <p:ext uri="{BB962C8B-B14F-4D97-AF65-F5344CB8AC3E}">
-        <p14:creationId xmlns:p14="http://schemas.microsoft.com/office/powerpoint/2010/main" val="687011823"/>
+        <p14:creationId xmlns:p14="http://schemas.microsoft.com/office/powerpoint/2010/main" val="3983740262"/>
       </p:ext>
     </p:extLst>
   </p:cSld>
@@ -21131,7 +21239,7 @@
           <a:p>
             <a:fld id="{5BCAD085-E8A6-8845-BD4E-CB4CCA059FC4}" type="datetimeFigureOut">
               <a:rPr lang="en-US" smtClean="0"/>
-              <a:t>7/3/2026</a:t>
+              <a:t>7/5/2026</a:t>
             </a:fld>
             <a:endParaRPr lang="en-US"/>
           </a:p>
@@ -21299,7 +21407,7 @@
           <a:p>
             <a:fld id="{5BCAD085-E8A6-8845-BD4E-CB4CCA059FC4}" type="datetimeFigureOut">
               <a:rPr lang="en-US" smtClean="0"/>
-              <a:t>7/3/2026</a:t>
+              <a:t>7/5/2026</a:t>
             </a:fld>
             <a:endParaRPr lang="en-US"/>
           </a:p>
@@ -21477,7 +21585,7 @@
           <a:p>
             <a:fld id="{5BCAD085-E8A6-8845-BD4E-CB4CCA059FC4}" type="datetimeFigureOut">
               <a:rPr lang="en-US" smtClean="0"/>
-              <a:t>7/3/2026</a:t>
+              <a:t>7/5/2026</a:t>
             </a:fld>
             <a:endParaRPr lang="en-US"/>
           </a:p>
@@ -21697,7 +21805,7 @@
           <a:p>
             <a:fld id="{5BCAD085-E8A6-8845-BD4E-CB4CCA059FC4}" type="datetimeFigureOut">
               <a:rPr lang="en-US" smtClean="0"/>
-              <a:t>7/3/2026</a:t>
+              <a:t>7/5/2026</a:t>
             </a:fld>
             <a:endParaRPr lang="en-US"/>
           </a:p>
@@ -21996,7 +22104,7 @@
           <a:p>
             <a:fld id="{5BCAD085-E8A6-8845-BD4E-CB4CCA059FC4}" type="datetimeFigureOut">
               <a:rPr lang="en-US" smtClean="0"/>
-              <a:t>7/3/2026</a:t>
+              <a:t>7/5/2026</a:t>
             </a:fld>
             <a:endParaRPr lang="en-US"/>
           </a:p>
@@ -22281,7 +22389,7 @@
           <a:p>
             <a:fld id="{5BCAD085-E8A6-8845-BD4E-CB4CCA059FC4}" type="datetimeFigureOut">
               <a:rPr lang="en-US" smtClean="0"/>
-              <a:t>7/3/2026</a:t>
+              <a:t>7/5/2026</a:t>
             </a:fld>
             <a:endParaRPr lang="en-US"/>
           </a:p>
@@ -22700,7 +22808,7 @@
           <a:p>
             <a:fld id="{5BCAD085-E8A6-8845-BD4E-CB4CCA059FC4}" type="datetimeFigureOut">
               <a:rPr lang="en-US" smtClean="0"/>
-              <a:t>7/3/2026</a:t>
+              <a:t>7/5/2026</a:t>
             </a:fld>
             <a:endParaRPr lang="en-US"/>
           </a:p>
@@ -22817,7 +22925,7 @@
           <a:p>
             <a:fld id="{5BCAD085-E8A6-8845-BD4E-CB4CCA059FC4}" type="datetimeFigureOut">
               <a:rPr lang="en-US" smtClean="0"/>
-              <a:t>7/3/2026</a:t>
+              <a:t>7/5/2026</a:t>
             </a:fld>
             <a:endParaRPr lang="en-US"/>
           </a:p>
@@ -22912,7 +23020,7 @@
           <a:p>
             <a:fld id="{5BCAD085-E8A6-8845-BD4E-CB4CCA059FC4}" type="datetimeFigureOut">
               <a:rPr lang="en-US" smtClean="0"/>
-              <a:t>7/3/2026</a:t>
+              <a:t>7/5/2026</a:t>
             </a:fld>
             <a:endParaRPr lang="en-US"/>
           </a:p>
@@ -23187,7 +23295,7 @@
           <a:p>
             <a:fld id="{5BCAD085-E8A6-8845-BD4E-CB4CCA059FC4}" type="datetimeFigureOut">
               <a:rPr lang="en-US" smtClean="0"/>
-              <a:t>7/3/2026</a:t>
+              <a:t>7/5/2026</a:t>
             </a:fld>
             <a:endParaRPr lang="en-US"/>
           </a:p>
@@ -23439,7 +23547,7 @@
           <a:p>
             <a:fld id="{5BCAD085-E8A6-8845-BD4E-CB4CCA059FC4}" type="datetimeFigureOut">
               <a:rPr lang="en-US" smtClean="0"/>
-              <a:t>7/3/2026</a:t>
+              <a:t>7/5/2026</a:t>
             </a:fld>
             <a:endParaRPr lang="en-US"/>
           </a:p>
@@ -23650,7 +23758,7 @@
           <a:p>
             <a:fld id="{5BCAD085-E8A6-8845-BD4E-CB4CCA059FC4}" type="datetimeFigureOut">
               <a:rPr lang="en-US" smtClean="0"/>
-              <a:t>7/3/2026</a:t>
+              <a:t>7/5/2026</a:t>
             </a:fld>
             <a:endParaRPr lang="en-US"/>
           </a:p>
@@ -24065,7 +24173,7 @@
           <p:cNvPr id="3" name="TextBox 2">
             <a:extLst>
               <a:ext uri="{FF2B5EF4-FFF2-40B4-BE49-F238E27FC236}">
-                <a16:creationId xmlns="" xmlns:a16="http://schemas.microsoft.com/office/drawing/2014/main" id="{690E14D1-3873-4F22-AF4A-8A2893212750}"/>
+                <a16:creationId xmlns:a16="http://schemas.microsoft.com/office/drawing/2014/main" xmlns="" id="{690E14D1-3873-4F22-AF4A-8A2893212750}"/>
               </a:ext>
             </a:extLst>
           </p:cNvPr>
@@ -24147,7 +24255,7 @@
           <p:cNvPr id="4" name="TextBox 3">
             <a:extLst>
               <a:ext uri="{FF2B5EF4-FFF2-40B4-BE49-F238E27FC236}">
-                <a16:creationId xmlns="" xmlns:a16="http://schemas.microsoft.com/office/drawing/2014/main" id="{7B06AA4D-FCEA-43B4-B026-FE247331C6AC}"/>
+                <a16:creationId xmlns:a16="http://schemas.microsoft.com/office/drawing/2014/main" xmlns="" id="{7B06AA4D-FCEA-43B4-B026-FE247331C6AC}"/>
               </a:ext>
             </a:extLst>
           </p:cNvPr>
@@ -24238,7 +24346,7 @@
           <p:cNvPr id="8" name="TextBox 7">
             <a:extLst>
               <a:ext uri="{FF2B5EF4-FFF2-40B4-BE49-F238E27FC236}">
-                <a16:creationId xmlns="" xmlns:a16="http://schemas.microsoft.com/office/drawing/2014/main" id="{0D83BEF6-B093-42CC-AF65-FD674D663988}"/>
+                <a16:creationId xmlns:a16="http://schemas.microsoft.com/office/drawing/2014/main" xmlns="" id="{0D83BEF6-B093-42CC-AF65-FD674D663988}"/>
               </a:ext>
             </a:extLst>
           </p:cNvPr>
@@ -24324,7 +24432,7 @@
           <p:cNvPr id="14" name="TextBox 13">
             <a:extLst>
               <a:ext uri="{FF2B5EF4-FFF2-40B4-BE49-F238E27FC236}">
-                <a16:creationId xmlns="" xmlns:a16="http://schemas.microsoft.com/office/drawing/2014/main" id="{2B308F06-D02C-25BC-8380-9984090E2D11}"/>
+                <a16:creationId xmlns:a16="http://schemas.microsoft.com/office/drawing/2014/main" xmlns="" id="{2B308F06-D02C-25BC-8380-9984090E2D11}"/>
               </a:ext>
             </a:extLst>
           </p:cNvPr>
@@ -24387,7 +24495,10 @@
               </a:rPr>
               <a:t>TẠO TÀI LIỆU GIẢNG DẠY</a:t>
             </a:r>
-            <a:endParaRPr lang="en-US" sz="3600"/>
+            <a:endParaRPr lang="en-US" sz="3600">
+              <a:latin typeface="Arial" panose="020B0604020202020204" pitchFamily="34" charset="0"/>
+              <a:cs typeface="Arial" panose="020B0604020202020204" pitchFamily="34" charset="0"/>
+            </a:endParaRPr>
           </a:p>
         </p:txBody>
       </p:sp>
@@ -24429,7 +24540,7 @@
           <p:cNvPr id="11" name="TextBox 10">
             <a:extLst>
               <a:ext uri="{FF2B5EF4-FFF2-40B4-BE49-F238E27FC236}">
-                <a16:creationId xmlns="" xmlns:a16="http://schemas.microsoft.com/office/drawing/2014/main" id="{0D83BEF6-B093-42CC-AF65-FD674D663988}"/>
+                <a16:creationId xmlns:a16="http://schemas.microsoft.com/office/drawing/2014/main" xmlns="" id="{0D83BEF6-B093-42CC-AF65-FD674D663988}"/>
               </a:ext>
             </a:extLst>
           </p:cNvPr>
@@ -24439,7 +24550,7 @@
         <p:spPr>
           <a:xfrm>
             <a:off x="2150307" y="1798419"/>
-            <a:ext cx="4843383" cy="496996"/>
+            <a:ext cx="4843383" cy="553998"/>
           </a:xfrm>
           <a:prstGeom prst="rect">
             <a:avLst/>
@@ -24494,10 +24605,16 @@
           <a:lstStyle/>
           <a:p>
             <a:r>
-              <a:rPr lang="vi-VN" smtClean="0"/>
+              <a:rPr lang="vi-VN" smtClean="0">
+                <a:latin typeface="Arial" panose="020B0604020202020204" pitchFamily="34" charset="0"/>
+                <a:cs typeface="Arial" panose="020B0604020202020204" pitchFamily="34" charset="0"/>
+              </a:rPr>
               <a:t>1</a:t>
             </a:r>
-            <a:endParaRPr lang="en-US"/>
+            <a:endParaRPr lang="en-US">
+              <a:latin typeface="Arial" panose="020B0604020202020204" pitchFamily="34" charset="0"/>
+              <a:cs typeface="Arial" panose="020B0604020202020204" pitchFamily="34" charset="0"/>
+            </a:endParaRPr>
           </a:p>
         </p:txBody>
       </p:sp>
@@ -24551,170 +24668,8 @@
           <a:lstStyle/>
           <a:p>
             <a:r>
-              <a:rPr lang="en-US" sz="3200" b="1" smtClean="0">
-                <a:solidFill>
-                  <a:schemeClr val="accent1">
-                    <a:lumMod val="75000"/>
-                  </a:schemeClr>
-                </a:solidFill>
-              </a:rPr>
-              <a:t>KIẾN TRÚC HỆ THỐNG</a:t>
-            </a:r>
-            <a:endParaRPr sz="3200" b="1">
-              <a:solidFill>
-                <a:schemeClr val="accent1">
-                  <a:lumMod val="75000"/>
-                </a:schemeClr>
-              </a:solidFill>
-            </a:endParaRPr>
-          </a:p>
-        </p:txBody>
-      </p:sp>
-      <p:pic>
-        <p:nvPicPr>
-          <p:cNvPr id="5" name="Picture 4"/>
-          <p:cNvPicPr>
-            <a:picLocks noChangeAspect="1"/>
-          </p:cNvPicPr>
-          <p:nvPr/>
-        </p:nvPicPr>
-        <p:blipFill>
-          <a:blip r:embed="rId3">
-            <a:extLst>
-              <a:ext uri="{28A0092B-C50C-407E-A947-70E740481C1C}">
-                <a14:useLocalDpi xmlns:a14="http://schemas.microsoft.com/office/drawing/2010/main" val="0"/>
-              </a:ext>
-            </a:extLst>
-          </a:blip>
-          <a:stretch>
-            <a:fillRect/>
-          </a:stretch>
-        </p:blipFill>
-        <p:spPr>
-          <a:xfrm>
-            <a:off x="2752437" y="984580"/>
-            <a:ext cx="6391564" cy="5282291"/>
-          </a:xfrm>
-          <a:prstGeom prst="rect">
-            <a:avLst/>
-          </a:prstGeom>
-        </p:spPr>
-      </p:pic>
-      <p:graphicFrame>
-        <p:nvGraphicFramePr>
-          <p:cNvPr id="8" name="Diagram 7">
-            <a:extLst>
-              <a:ext uri="{FF2B5EF4-FFF2-40B4-BE49-F238E27FC236}">
-                <a16:creationId xmlns="" xmlns:a16="http://schemas.microsoft.com/office/drawing/2014/main" id="{1ED27C14-4121-4D4D-47A7-FBE3633FA51B}"/>
-              </a:ext>
-            </a:extLst>
-          </p:cNvPr>
-          <p:cNvGraphicFramePr/>
-          <p:nvPr>
-            <p:extLst>
-              <p:ext uri="{D42A27DB-BD31-4B8C-83A1-F6EECF244321}">
-                <p14:modId xmlns:p14="http://schemas.microsoft.com/office/powerpoint/2010/main" val="2653314555"/>
-              </p:ext>
-            </p:extLst>
-          </p:nvPr>
-        </p:nvGraphicFramePr>
-        <p:xfrm>
-          <a:off x="-576" y="984580"/>
-          <a:ext cx="2687366" cy="4525109"/>
-        </p:xfrm>
-        <a:graphic>
-          <a:graphicData uri="http://schemas.openxmlformats.org/drawingml/2006/diagram">
-            <dgm:relIds xmlns:dgm="http://schemas.openxmlformats.org/drawingml/2006/diagram" xmlns:r="http://schemas.openxmlformats.org/officeDocument/2006/relationships" r:dm="rId4" r:lo="rId5" r:qs="rId6" r:cs="rId7"/>
-          </a:graphicData>
-        </a:graphic>
-      </p:graphicFrame>
-      <p:sp>
-        <p:nvSpPr>
-          <p:cNvPr id="6" name="TextBox 5"/>
-          <p:cNvSpPr txBox="1"/>
-          <p:nvPr/>
-        </p:nvSpPr>
-        <p:spPr>
-          <a:xfrm>
-            <a:off x="8728363" y="0"/>
-            <a:ext cx="498764" cy="369332"/>
-          </a:xfrm>
-          <a:prstGeom prst="rect">
-            <a:avLst/>
-          </a:prstGeom>
-          <a:noFill/>
-        </p:spPr>
-        <p:txBody>
-          <a:bodyPr wrap="square" rtlCol="0">
-            <a:spAutoFit/>
-          </a:bodyPr>
-          <a:lstStyle/>
-          <a:p>
-            <a:r>
-              <a:rPr lang="vi-VN" smtClean="0"/>
-              <a:t>10</a:t>
-            </a:r>
-            <a:endParaRPr lang="en-US"/>
-          </a:p>
-        </p:txBody>
-      </p:sp>
-    </p:spTree>
-    <p:extLst>
-      <p:ext uri="{BB962C8B-B14F-4D97-AF65-F5344CB8AC3E}">
-        <p14:creationId xmlns:p14="http://schemas.microsoft.com/office/powerpoint/2010/main" val="1601513226"/>
-      </p:ext>
-    </p:extLst>
-  </p:cSld>
-  <p:clrMapOvr>
-    <a:masterClrMapping/>
-  </p:clrMapOvr>
-  <p:timing>
-    <p:tnLst>
-      <p:par>
-        <p:cTn id="1" dur="indefinite" restart="never" nodeType="tmRoot"/>
-      </p:par>
-    </p:tnLst>
-  </p:timing>
-</p:sld>
-</file>
-
-<file path=ppt/slides/slide11.xml><?xml version="1.0" encoding="utf-8"?>
-<p:sld xmlns:a="http://schemas.openxmlformats.org/drawingml/2006/main" xmlns:r="http://schemas.openxmlformats.org/officeDocument/2006/relationships" xmlns:p="http://schemas.openxmlformats.org/presentationml/2006/main">
-  <p:cSld>
-    <p:spTree>
-      <p:nvGrpSpPr>
-        <p:cNvPr id="1" name=""/>
-        <p:cNvGrpSpPr/>
-        <p:nvPr/>
-      </p:nvGrpSpPr>
-      <p:grpSpPr>
-        <a:xfrm>
-          <a:off x="0" y="0"/>
-          <a:ext cx="0" cy="0"/>
-          <a:chOff x="0" y="0"/>
-          <a:chExt cx="0" cy="0"/>
-        </a:xfrm>
-      </p:grpSpPr>
-      <p:sp>
-        <p:nvSpPr>
-          <p:cNvPr id="2" name="Title 1"/>
-          <p:cNvSpPr>
-            <a:spLocks noGrp="1"/>
-          </p:cNvSpPr>
-          <p:nvPr>
-            <p:ph type="title"/>
-          </p:nvPr>
-        </p:nvSpPr>
-        <p:spPr/>
-        <p:txBody>
-          <a:bodyPr>
-            <a:noAutofit/>
-          </a:bodyPr>
-          <a:lstStyle/>
-          <a:p>
-            <a:r>
               <a:rPr lang="en-US" sz="3200" smtClean="0"/>
-              <a:t>QUY TRÌNH NGHIỆP VỤ</a:t>
+              <a:t>QUY TRÌNH SỬ DỤNG</a:t>
             </a:r>
             <a:endParaRPr sz="3200" b="1">
               <a:solidFill>
@@ -25146,8 +25101,8 @@
         </p:nvSpPr>
         <p:spPr>
           <a:xfrm>
-            <a:off x="1980510" y="3254216"/>
-            <a:ext cx="1423780" cy="646331"/>
+            <a:off x="1980509" y="3254216"/>
+            <a:ext cx="1466963" cy="646331"/>
           </a:xfrm>
           <a:prstGeom prst="rect">
             <a:avLst/>
@@ -25164,7 +25119,7 @@
                 <a:latin typeface="Arial" panose="020B0604020202020204" pitchFamily="34" charset="0"/>
                 <a:cs typeface="Arial" panose="020B0604020202020204" pitchFamily="34" charset="0"/>
               </a:rPr>
-              <a:t>Xây dựng kho tri thức</a:t>
+              <a:t>Khởi tạo dự án bài giảng</a:t>
             </a:r>
             <a:endParaRPr lang="en-US">
               <a:latin typeface="Arial" panose="020B0604020202020204" pitchFamily="34" charset="0"/>
@@ -25181,8 +25136,8 @@
         </p:nvSpPr>
         <p:spPr>
           <a:xfrm>
-            <a:off x="3745347" y="3294178"/>
-            <a:ext cx="1579418" cy="646331"/>
+            <a:off x="3707377" y="3294178"/>
+            <a:ext cx="1639786" cy="923330"/>
           </a:xfrm>
           <a:prstGeom prst="rect">
             <a:avLst/>
@@ -25199,7 +25154,7 @@
                 <a:latin typeface="Arial" panose="020B0604020202020204" pitchFamily="34" charset="0"/>
                 <a:cs typeface="Arial" panose="020B0604020202020204" pitchFamily="34" charset="0"/>
               </a:rPr>
-              <a:t>Tạo bài giảng tự động</a:t>
+              <a:t>Tạo và phê duyệt cấu trúc mục lục</a:t>
             </a:r>
             <a:endParaRPr lang="en-US">
               <a:latin typeface="Arial" panose="020B0604020202020204" pitchFamily="34" charset="0"/>
@@ -25217,7 +25172,7 @@
         <p:spPr>
           <a:xfrm>
             <a:off x="5589616" y="3294178"/>
-            <a:ext cx="1423780" cy="646331"/>
+            <a:ext cx="1423780" cy="369332"/>
           </a:xfrm>
           <a:prstGeom prst="rect">
             <a:avLst/>
@@ -25229,13 +25184,6 @@
           </a:bodyPr>
           <a:lstStyle/>
           <a:p>
-            <a:r>
-              <a:rPr lang="en-US" smtClean="0">
-                <a:latin typeface="Arial" panose="020B0604020202020204" pitchFamily="34" charset="0"/>
-                <a:cs typeface="Arial" panose="020B0604020202020204" pitchFamily="34" charset="0"/>
-              </a:rPr>
-              <a:t>Tạo câu hỏi trắc nghiệm</a:t>
-            </a:r>
             <a:endParaRPr lang="en-US">
               <a:latin typeface="Arial" panose="020B0604020202020204" pitchFamily="34" charset="0"/>
               <a:cs typeface="Arial" panose="020B0604020202020204" pitchFamily="34" charset="0"/>
@@ -25514,14 +25462,62 @@
       </p:sp>
       <p:sp>
         <p:nvSpPr>
-          <p:cNvPr id="22" name="TextBox 21"/>
+          <p:cNvPr id="29" name="Rectangle 28"/>
+          <p:cNvSpPr/>
+          <p:nvPr/>
+        </p:nvSpPr>
+        <p:spPr>
+          <a:xfrm>
+            <a:off x="5495974" y="3290958"/>
+            <a:ext cx="1579418" cy="923330"/>
+          </a:xfrm>
+          <a:prstGeom prst="rect">
+            <a:avLst/>
+          </a:prstGeom>
+        </p:spPr>
+        <p:txBody>
+          <a:bodyPr wrap="square">
+            <a:spAutoFit/>
+          </a:bodyPr>
+          <a:lstStyle/>
+          <a:p>
+            <a:r>
+              <a:rPr lang="en-US" smtClean="0">
+                <a:latin typeface="Arial" panose="020B0604020202020204" pitchFamily="34" charset="0"/>
+                <a:cs typeface="Arial" panose="020B0604020202020204" pitchFamily="34" charset="0"/>
+              </a:rPr>
+              <a:t>Tạo bài giảng </a:t>
+            </a:r>
+            <a:endParaRPr lang="en-US">
+              <a:latin typeface="Arial" panose="020B0604020202020204" pitchFamily="34" charset="0"/>
+              <a:cs typeface="Arial" panose="020B0604020202020204" pitchFamily="34" charset="0"/>
+            </a:endParaRPr>
+          </a:p>
+          <a:p>
+            <a:r>
+              <a:rPr lang="en-US" smtClean="0">
+                <a:latin typeface="Arial" panose="020B0604020202020204" pitchFamily="34" charset="0"/>
+                <a:cs typeface="Arial" panose="020B0604020202020204" pitchFamily="34" charset="0"/>
+              </a:rPr>
+              <a:t>Tạo câu hỏi trắc nghiệm</a:t>
+            </a:r>
+            <a:endParaRPr lang="en-US">
+              <a:latin typeface="Arial" panose="020B0604020202020204" pitchFamily="34" charset="0"/>
+              <a:cs typeface="Arial" panose="020B0604020202020204" pitchFamily="34" charset="0"/>
+            </a:endParaRPr>
+          </a:p>
+        </p:txBody>
+      </p:sp>
+      <p:sp>
+        <p:nvSpPr>
+          <p:cNvPr id="3" name="TextBox 2"/>
           <p:cNvSpPr txBox="1"/>
           <p:nvPr/>
         </p:nvSpPr>
         <p:spPr>
           <a:xfrm>
-            <a:off x="8682182" y="0"/>
-            <a:ext cx="461818" cy="369332"/>
+            <a:off x="8686800" y="0"/>
+            <a:ext cx="457200" cy="369332"/>
           </a:xfrm>
           <a:prstGeom prst="rect">
             <a:avLst/>
@@ -25535,8 +25531,8 @@
           <a:lstStyle/>
           <a:p>
             <a:r>
-              <a:rPr lang="vi-VN" smtClean="0"/>
-              <a:t>11</a:t>
+              <a:rPr lang="en-US" smtClean="0"/>
+              <a:t>10</a:t>
             </a:r>
             <a:endParaRPr lang="en-US"/>
           </a:p>
@@ -25562,7 +25558,7 @@
 </p:sld>
 </file>
 
-<file path=ppt/slides/slide12.xml><?xml version="1.0" encoding="utf-8"?>
+<file path=ppt/slides/slide11.xml><?xml version="1.0" encoding="utf-8"?>
 <p:sld xmlns:a="http://schemas.openxmlformats.org/drawingml/2006/main" xmlns:r="http://schemas.openxmlformats.org/officeDocument/2006/relationships" xmlns:p="http://schemas.openxmlformats.org/presentationml/2006/main">
   <p:cSld>
     <p:spTree>
@@ -25641,7 +25637,7 @@
         <p:spPr>
           <a:xfrm>
             <a:off x="3528291" y="5837382"/>
-            <a:ext cx="2318327" cy="378691"/>
+            <a:ext cx="2576945" cy="369332"/>
           </a:xfrm>
           <a:prstGeom prst="rect">
             <a:avLst/>
@@ -25655,10 +25651,16 @@
           <a:lstStyle/>
           <a:p>
             <a:r>
-              <a:rPr lang="en-US" smtClean="0"/>
+              <a:rPr lang="en-US" smtClean="0">
+                <a:latin typeface="Arial" panose="020B0604020202020204" pitchFamily="34" charset="0"/>
+                <a:cs typeface="Arial" panose="020B0604020202020204" pitchFamily="34" charset="0"/>
+              </a:rPr>
               <a:t>Kết quả tạo bài giảng</a:t>
             </a:r>
-            <a:endParaRPr lang="en-US"/>
+            <a:endParaRPr lang="en-US">
+              <a:latin typeface="Arial" panose="020B0604020202020204" pitchFamily="34" charset="0"/>
+              <a:cs typeface="Arial" panose="020B0604020202020204" pitchFamily="34" charset="0"/>
+            </a:endParaRPr>
           </a:p>
         </p:txBody>
       </p:sp>
@@ -25686,9 +25688,19 @@
           <a:p>
             <a:r>
               <a:rPr lang="vi-VN" smtClean="0"/>
-              <a:t>12</a:t>
+              <a:t>1</a:t>
             </a:r>
-            <a:endParaRPr lang="en-US"/>
+            <a:r>
+              <a:rPr lang="en-US" smtClean="0">
+                <a:latin typeface="Arial" panose="020B0604020202020204" pitchFamily="34" charset="0"/>
+                <a:cs typeface="Arial" panose="020B0604020202020204" pitchFamily="34" charset="0"/>
+              </a:rPr>
+              <a:t>1</a:t>
+            </a:r>
+            <a:endParaRPr lang="en-US">
+              <a:latin typeface="Arial" panose="020B0604020202020204" pitchFamily="34" charset="0"/>
+              <a:cs typeface="Arial" panose="020B0604020202020204" pitchFamily="34" charset="0"/>
+            </a:endParaRPr>
           </a:p>
         </p:txBody>
       </p:sp>
@@ -25712,7 +25724,7 @@
 </p:sld>
 </file>
 
-<file path=ppt/slides/slide13.xml><?xml version="1.0" encoding="utf-8"?>
+<file path=ppt/slides/slide12.xml><?xml version="1.0" encoding="utf-8"?>
 <p:sld xmlns:a="http://schemas.openxmlformats.org/drawingml/2006/main" xmlns:r="http://schemas.openxmlformats.org/officeDocument/2006/relationships" xmlns:p="http://schemas.openxmlformats.org/presentationml/2006/main">
   <p:cSld>
     <p:spTree>
@@ -25818,8 +25830,8 @@
         </p:nvSpPr>
         <p:spPr>
           <a:xfrm>
-            <a:off x="1848196" y="5941171"/>
-            <a:ext cx="5558444" cy="369332"/>
+            <a:off x="1482898" y="5941171"/>
+            <a:ext cx="6178204" cy="369332"/>
           </a:xfrm>
           <a:prstGeom prst="rect">
             <a:avLst/>
@@ -25833,10 +25845,16 @@
           <a:lstStyle/>
           <a:p>
             <a:r>
-              <a:rPr lang="en-US" smtClean="0"/>
+              <a:rPr lang="en-US" smtClean="0">
+                <a:latin typeface="Arial" panose="020B0604020202020204" pitchFamily="34" charset="0"/>
+                <a:cs typeface="Arial" panose="020B0604020202020204" pitchFamily="34" charset="0"/>
+              </a:rPr>
               <a:t>Kết quả chức năng gợi ý Prompt và gợi ý Placeholder ảnh</a:t>
             </a:r>
-            <a:endParaRPr lang="en-US"/>
+            <a:endParaRPr lang="en-US">
+              <a:latin typeface="Arial" panose="020B0604020202020204" pitchFamily="34" charset="0"/>
+              <a:cs typeface="Arial" panose="020B0604020202020204" pitchFamily="34" charset="0"/>
+            </a:endParaRPr>
           </a:p>
         </p:txBody>
       </p:sp>
@@ -25864,9 +25882,19 @@
           <a:p>
             <a:r>
               <a:rPr lang="vi-VN" smtClean="0"/>
-              <a:t>13</a:t>
+              <a:t>1</a:t>
             </a:r>
-            <a:endParaRPr lang="en-US"/>
+            <a:r>
+              <a:rPr lang="en-US" smtClean="0">
+                <a:latin typeface="Arial" panose="020B0604020202020204" pitchFamily="34" charset="0"/>
+                <a:cs typeface="Arial" panose="020B0604020202020204" pitchFamily="34" charset="0"/>
+              </a:rPr>
+              <a:t>2</a:t>
+            </a:r>
+            <a:endParaRPr lang="en-US">
+              <a:latin typeface="Arial" panose="020B0604020202020204" pitchFamily="34" charset="0"/>
+              <a:cs typeface="Arial" panose="020B0604020202020204" pitchFamily="34" charset="0"/>
+            </a:endParaRPr>
           </a:p>
         </p:txBody>
       </p:sp>
@@ -25890,7 +25918,7 @@
 </p:sld>
 </file>
 
-<file path=ppt/slides/slide14.xml><?xml version="1.0" encoding="utf-8"?>
+<file path=ppt/slides/slide13.xml><?xml version="1.0" encoding="utf-8"?>
 <p:sld xmlns:a="http://schemas.openxmlformats.org/drawingml/2006/main" xmlns:r="http://schemas.openxmlformats.org/officeDocument/2006/relationships" xmlns:p="http://schemas.openxmlformats.org/presentationml/2006/main">
   <p:cSld>
     <p:spTree>
@@ -26005,10 +26033,16 @@
           <a:lstStyle/>
           <a:p>
             <a:r>
-              <a:rPr lang="en-US" smtClean="0"/>
+              <a:rPr lang="en-US" smtClean="0">
+                <a:latin typeface="Arial" panose="020B0604020202020204" pitchFamily="34" charset="0"/>
+                <a:cs typeface="Arial" panose="020B0604020202020204" pitchFamily="34" charset="0"/>
+              </a:rPr>
               <a:t>Kết quả tạo và xuất câu hỏi trắc nghiệm</a:t>
             </a:r>
-            <a:endParaRPr lang="en-US"/>
+            <a:endParaRPr lang="en-US">
+              <a:latin typeface="Arial" panose="020B0604020202020204" pitchFamily="34" charset="0"/>
+              <a:cs typeface="Arial" panose="020B0604020202020204" pitchFamily="34" charset="0"/>
+            </a:endParaRPr>
           </a:p>
         </p:txBody>
       </p:sp>
@@ -26035,10 +26069,23 @@
           <a:lstStyle/>
           <a:p>
             <a:r>
-              <a:rPr lang="vi-VN" smtClean="0"/>
-              <a:t>14</a:t>
+              <a:rPr lang="vi-VN" smtClean="0">
+                <a:latin typeface="Arial" panose="020B0604020202020204" pitchFamily="34" charset="0"/>
+                <a:cs typeface="Arial" panose="020B0604020202020204" pitchFamily="34" charset="0"/>
+              </a:rPr>
+              <a:t>1</a:t>
             </a:r>
-            <a:endParaRPr lang="en-US"/>
+            <a:r>
+              <a:rPr lang="en-US" smtClean="0">
+                <a:latin typeface="Arial" panose="020B0604020202020204" pitchFamily="34" charset="0"/>
+                <a:cs typeface="Arial" panose="020B0604020202020204" pitchFamily="34" charset="0"/>
+              </a:rPr>
+              <a:t>3</a:t>
+            </a:r>
+            <a:endParaRPr lang="en-US">
+              <a:latin typeface="Arial" panose="020B0604020202020204" pitchFamily="34" charset="0"/>
+              <a:cs typeface="Arial" panose="020B0604020202020204" pitchFamily="34" charset="0"/>
+            </a:endParaRPr>
           </a:p>
         </p:txBody>
       </p:sp>
@@ -26062,7 +26109,7 @@
 </p:sld>
 </file>
 
-<file path=ppt/slides/slide15.xml><?xml version="1.0" encoding="utf-8"?>
+<file path=ppt/slides/slide14.xml><?xml version="1.0" encoding="utf-8"?>
 <p:sld xmlns:a="http://schemas.openxmlformats.org/drawingml/2006/main" xmlns:r="http://schemas.openxmlformats.org/officeDocument/2006/relationships" xmlns:p="http://schemas.openxmlformats.org/presentationml/2006/main">
   <p:cSld>
     <p:spTree>
@@ -26133,22 +26180,30 @@
           <a:lstStyle/>
           <a:p>
             <a:r>
-              <a:rPr lang="en-US" smtClean="0"/>
+              <a:rPr lang="en-US" smtClean="0">
+                <a:latin typeface="Arial" panose="020B0604020202020204" pitchFamily="34" charset="0"/>
+                <a:cs typeface="Arial" panose="020B0604020202020204" pitchFamily="34" charset="0"/>
+              </a:rPr>
               <a:t>Kết quả </a:t>
             </a:r>
             <a:r>
-              <a:rPr lang="vi-VN"/>
-              <a:t>import thành công </a:t>
+              <a:rPr lang="vi-VN">
+                <a:latin typeface="Arial" panose="020B0604020202020204" pitchFamily="34" charset="0"/>
+                <a:cs typeface="Arial" panose="020B0604020202020204" pitchFamily="34" charset="0"/>
+              </a:rPr>
+              <a:t>import thành công lên </a:t>
             </a:r>
             <a:r>
-              <a:rPr lang="vi-VN"/>
-              <a:t>lên </a:t>
-            </a:r>
-            <a:r>
-              <a:rPr lang="vi-VN" smtClean="0"/>
+              <a:rPr lang="vi-VN" smtClean="0">
+                <a:latin typeface="Arial" panose="020B0604020202020204" pitchFamily="34" charset="0"/>
+                <a:cs typeface="Arial" panose="020B0604020202020204" pitchFamily="34" charset="0"/>
+              </a:rPr>
               <a:t>Moodle</a:t>
             </a:r>
-            <a:endParaRPr lang="en-US"/>
+            <a:endParaRPr lang="en-US">
+              <a:latin typeface="Arial" panose="020B0604020202020204" pitchFamily="34" charset="0"/>
+              <a:cs typeface="Arial" panose="020B0604020202020204" pitchFamily="34" charset="0"/>
+            </a:endParaRPr>
           </a:p>
         </p:txBody>
       </p:sp>
@@ -26176,9 +26231,19 @@
           <a:p>
             <a:r>
               <a:rPr lang="vi-VN" smtClean="0"/>
-              <a:t>15</a:t>
+              <a:t>1</a:t>
             </a:r>
-            <a:endParaRPr lang="en-US"/>
+            <a:r>
+              <a:rPr lang="en-US" smtClean="0">
+                <a:latin typeface="Arial" panose="020B0604020202020204" pitchFamily="34" charset="0"/>
+                <a:cs typeface="Arial" panose="020B0604020202020204" pitchFamily="34" charset="0"/>
+              </a:rPr>
+              <a:t>4</a:t>
+            </a:r>
+            <a:endParaRPr lang="en-US">
+              <a:latin typeface="Arial" panose="020B0604020202020204" pitchFamily="34" charset="0"/>
+              <a:cs typeface="Arial" panose="020B0604020202020204" pitchFamily="34" charset="0"/>
+            </a:endParaRPr>
           </a:p>
         </p:txBody>
       </p:sp>
@@ -26232,7 +26297,7 @@
 </p:sld>
 </file>
 
-<file path=ppt/slides/slide16.xml><?xml version="1.0" encoding="utf-8"?>
+<file path=ppt/slides/slide15.xml><?xml version="1.0" encoding="utf-8"?>
 <p:sld xmlns:a="http://schemas.openxmlformats.org/drawingml/2006/main" xmlns:r="http://schemas.openxmlformats.org/officeDocument/2006/relationships" xmlns:p="http://schemas.openxmlformats.org/presentationml/2006/main">
   <p:cSld>
     <p:spTree>
@@ -26267,8 +26332,14 @@
           <a:lstStyle/>
           <a:p>
             <a:r>
-              <a:rPr lang="en-US" smtClean="0"/>
-              <a:t>KẾT LUẬN</a:t>
+              <a:rPr lang="en-US" b="1" smtClean="0">
+                <a:solidFill>
+                  <a:schemeClr val="accent1">
+                    <a:lumMod val="75000"/>
+                  </a:schemeClr>
+                </a:solidFill>
+              </a:rPr>
+              <a:t>KẾT LUẬN VÀ HƯỚNG PHÁT TRIỂN</a:t>
             </a:r>
             <a:endParaRPr b="1">
               <a:solidFill>
@@ -26280,404 +26351,37 @@
           </a:p>
         </p:txBody>
       </p:sp>
-      <p:sp>
-        <p:nvSpPr>
-          <p:cNvPr id="3" name="Rectangle 2"/>
-          <p:cNvSpPr/>
-          <p:nvPr/>
-        </p:nvSpPr>
-        <p:spPr>
-          <a:xfrm>
-            <a:off x="0" y="1259037"/>
-            <a:ext cx="8686800" cy="2862322"/>
-          </a:xfrm>
-          <a:prstGeom prst="rect">
-            <a:avLst/>
-          </a:prstGeom>
-        </p:spPr>
-        <p:txBody>
-          <a:bodyPr wrap="square">
-            <a:spAutoFit/>
-          </a:bodyPr>
-          <a:lstStyle/>
-          <a:p>
-            <a:pPr marL="342900" indent="-342900">
-              <a:lnSpc>
-                <a:spcPct val="150000"/>
-              </a:lnSpc>
-              <a:buFont typeface="Arial" panose="020B0604020202020204" pitchFamily="34" charset="0"/>
-              <a:buChar char="•"/>
-            </a:pPr>
-            <a:r>
-              <a:rPr lang="en-US" sz="2400" smtClean="0">
-                <a:latin typeface="Arial" panose="020B0604020202020204" pitchFamily="34" charset="0"/>
-                <a:cs typeface="Arial" panose="020B0604020202020204" pitchFamily="34" charset="0"/>
-              </a:rPr>
-              <a:t>Xây dựng thành công hệ thống </a:t>
-            </a:r>
-          </a:p>
-          <a:p>
-            <a:pPr marL="342900" indent="-342900">
-              <a:lnSpc>
-                <a:spcPct val="150000"/>
-              </a:lnSpc>
-              <a:buFont typeface="Arial" panose="020B0604020202020204" pitchFamily="34" charset="0"/>
-              <a:buChar char="•"/>
-            </a:pPr>
-            <a:r>
-              <a:rPr lang="vi-VN" sz="2400" smtClean="0">
-                <a:latin typeface="Arial" panose="020B0604020202020204" pitchFamily="34" charset="0"/>
-                <a:cs typeface="Arial" panose="020B0604020202020204" pitchFamily="34" charset="0"/>
-              </a:rPr>
-              <a:t>Giảm </a:t>
-            </a:r>
-            <a:r>
-              <a:rPr lang="vi-VN" sz="2400">
-                <a:latin typeface="Arial" panose="020B0604020202020204" pitchFamily="34" charset="0"/>
-                <a:cs typeface="Arial" panose="020B0604020202020204" pitchFamily="34" charset="0"/>
-              </a:rPr>
-              <a:t>thời </a:t>
-            </a:r>
-            <a:r>
-              <a:rPr lang="vi-VN" sz="2400" smtClean="0">
-                <a:latin typeface="Arial" panose="020B0604020202020204" pitchFamily="34" charset="0"/>
-                <a:cs typeface="Arial" panose="020B0604020202020204" pitchFamily="34" charset="0"/>
-              </a:rPr>
-              <a:t>gian</a:t>
-            </a:r>
-            <a:r>
-              <a:rPr lang="en-US" sz="2400" smtClean="0">
-                <a:latin typeface="Arial" panose="020B0604020202020204" pitchFamily="34" charset="0"/>
-                <a:cs typeface="Arial" panose="020B0604020202020204" pitchFamily="34" charset="0"/>
-              </a:rPr>
-              <a:t>, công sức </a:t>
-            </a:r>
-            <a:r>
-              <a:rPr lang="vi-VN" sz="2400" smtClean="0">
-                <a:latin typeface="Arial" panose="020B0604020202020204" pitchFamily="34" charset="0"/>
-                <a:cs typeface="Arial" panose="020B0604020202020204" pitchFamily="34" charset="0"/>
-              </a:rPr>
-              <a:t>biên </a:t>
-            </a:r>
-            <a:r>
-              <a:rPr lang="vi-VN" sz="2400">
-                <a:latin typeface="Arial" panose="020B0604020202020204" pitchFamily="34" charset="0"/>
-                <a:cs typeface="Arial" panose="020B0604020202020204" pitchFamily="34" charset="0"/>
-              </a:rPr>
-              <a:t>soạn học liệu cho giảng viên.</a:t>
-            </a:r>
-          </a:p>
-          <a:p>
-            <a:pPr marL="342900" indent="-342900">
-              <a:lnSpc>
-                <a:spcPct val="150000"/>
-              </a:lnSpc>
-              <a:buFont typeface="Arial" panose="020B0604020202020204" pitchFamily="34" charset="0"/>
-              <a:buChar char="•"/>
-            </a:pPr>
-            <a:r>
-              <a:rPr lang="vi-VN" sz="2400" smtClean="0">
-                <a:latin typeface="Arial" panose="020B0604020202020204" pitchFamily="34" charset="0"/>
-                <a:cs typeface="Arial" panose="020B0604020202020204" pitchFamily="34" charset="0"/>
-              </a:rPr>
-              <a:t>Khai </a:t>
-            </a:r>
-            <a:r>
-              <a:rPr lang="vi-VN" sz="2400">
-                <a:latin typeface="Arial" panose="020B0604020202020204" pitchFamily="34" charset="0"/>
-                <a:cs typeface="Arial" panose="020B0604020202020204" pitchFamily="34" charset="0"/>
-              </a:rPr>
-              <a:t>thác hiệu quả nguồn tài liệu chuyên </a:t>
-            </a:r>
-            <a:r>
-              <a:rPr lang="vi-VN" sz="2400" smtClean="0">
-                <a:latin typeface="Arial" panose="020B0604020202020204" pitchFamily="34" charset="0"/>
-                <a:cs typeface="Arial" panose="020B0604020202020204" pitchFamily="34" charset="0"/>
-              </a:rPr>
-              <a:t>ngành</a:t>
-            </a:r>
-            <a:endParaRPr lang="vi-VN" sz="2400">
-              <a:latin typeface="Arial" panose="020B0604020202020204" pitchFamily="34" charset="0"/>
-              <a:cs typeface="Arial" panose="020B0604020202020204" pitchFamily="34" charset="0"/>
-            </a:endParaRPr>
-          </a:p>
-          <a:p>
-            <a:pPr marL="342900" indent="-342900">
-              <a:lnSpc>
-                <a:spcPct val="150000"/>
-              </a:lnSpc>
-              <a:buFont typeface="Arial" panose="020B0604020202020204" pitchFamily="34" charset="0"/>
-              <a:buChar char="•"/>
-            </a:pPr>
-            <a:r>
-              <a:rPr lang="vi-VN" sz="2400" smtClean="0">
-                <a:latin typeface="Arial" panose="020B0604020202020204" pitchFamily="34" charset="0"/>
-                <a:cs typeface="Arial" panose="020B0604020202020204" pitchFamily="34" charset="0"/>
-              </a:rPr>
-              <a:t>Nâng </a:t>
-            </a:r>
-            <a:r>
-              <a:rPr lang="vi-VN" sz="2400">
-                <a:latin typeface="Arial" panose="020B0604020202020204" pitchFamily="34" charset="0"/>
-                <a:cs typeface="Arial" panose="020B0604020202020204" pitchFamily="34" charset="0"/>
-              </a:rPr>
-              <a:t>cao tính chính xác, minh bạch và khả năng truy vết của nội dung được </a:t>
-            </a:r>
-            <a:r>
-              <a:rPr lang="vi-VN" sz="2400" smtClean="0">
-                <a:latin typeface="Arial" panose="020B0604020202020204" pitchFamily="34" charset="0"/>
-                <a:cs typeface="Arial" panose="020B0604020202020204" pitchFamily="34" charset="0"/>
-              </a:rPr>
-              <a:t>tạo</a:t>
-            </a:r>
-            <a:r>
-              <a:rPr lang="en-US" sz="2400">
-                <a:latin typeface="Arial" panose="020B0604020202020204" pitchFamily="34" charset="0"/>
-                <a:cs typeface="Arial" panose="020B0604020202020204" pitchFamily="34" charset="0"/>
-              </a:rPr>
-              <a:t> </a:t>
-            </a:r>
-            <a:r>
-              <a:rPr lang="en-US" sz="2400" smtClean="0">
-                <a:latin typeface="Arial" panose="020B0604020202020204" pitchFamily="34" charset="0"/>
-                <a:cs typeface="Arial" panose="020B0604020202020204" pitchFamily="34" charset="0"/>
-              </a:rPr>
-              <a:t>ra</a:t>
-            </a:r>
-            <a:endParaRPr lang="vi-VN" sz="2400">
-              <a:latin typeface="Arial" panose="020B0604020202020204" pitchFamily="34" charset="0"/>
-              <a:cs typeface="Arial" panose="020B0604020202020204" pitchFamily="34" charset="0"/>
-            </a:endParaRPr>
-          </a:p>
-        </p:txBody>
-      </p:sp>
-      <p:sp>
-        <p:nvSpPr>
-          <p:cNvPr id="4" name="TextBox 3"/>
-          <p:cNvSpPr txBox="1"/>
-          <p:nvPr/>
-        </p:nvSpPr>
-        <p:spPr>
-          <a:xfrm>
-            <a:off x="8719127" y="0"/>
-            <a:ext cx="508000" cy="369332"/>
-          </a:xfrm>
-          <a:prstGeom prst="rect">
-            <a:avLst/>
-          </a:prstGeom>
-          <a:noFill/>
-        </p:spPr>
-        <p:txBody>
-          <a:bodyPr wrap="square" rtlCol="0">
-            <a:spAutoFit/>
-          </a:bodyPr>
-          <a:lstStyle/>
-          <a:p>
-            <a:r>
-              <a:rPr lang="vi-VN" smtClean="0"/>
-              <a:t>16</a:t>
-            </a:r>
-            <a:endParaRPr lang="en-US"/>
-          </a:p>
-        </p:txBody>
-      </p:sp>
-    </p:spTree>
-    <p:extLst>
-      <p:ext uri="{BB962C8B-B14F-4D97-AF65-F5344CB8AC3E}">
-        <p14:creationId xmlns:p14="http://schemas.microsoft.com/office/powerpoint/2010/main" val="3765683109"/>
-      </p:ext>
-    </p:extLst>
-  </p:cSld>
-  <p:clrMapOvr>
-    <a:masterClrMapping/>
-  </p:clrMapOvr>
-</p:sld>
-</file>
-
-<file path=ppt/slides/slide17.xml><?xml version="1.0" encoding="utf-8"?>
-<p:sld xmlns:a="http://schemas.openxmlformats.org/drawingml/2006/main" xmlns:r="http://schemas.openxmlformats.org/officeDocument/2006/relationships" xmlns:p="http://schemas.openxmlformats.org/presentationml/2006/main">
-  <p:cSld>
-    <p:spTree>
-      <p:nvGrpSpPr>
-        <p:cNvPr id="1" name=""/>
-        <p:cNvGrpSpPr/>
-        <p:nvPr/>
-      </p:nvGrpSpPr>
-      <p:grpSpPr>
-        <a:xfrm>
-          <a:off x="0" y="0"/>
-          <a:ext cx="0" cy="0"/>
-          <a:chOff x="0" y="0"/>
-          <a:chExt cx="0" cy="0"/>
-        </a:xfrm>
-      </p:grpSpPr>
-      <p:sp>
-        <p:nvSpPr>
-          <p:cNvPr id="2" name="Title 1"/>
-          <p:cNvSpPr>
-            <a:spLocks noGrp="1"/>
-          </p:cNvSpPr>
+      <p:graphicFrame>
+        <p:nvGraphicFramePr>
+          <p:cNvPr id="5" name="Content Placeholder 4">
+            <a:extLst>
+              <a:ext uri="{FF2B5EF4-FFF2-40B4-BE49-F238E27FC236}">
+                <a16:creationId xmlns:a16="http://schemas.microsoft.com/office/drawing/2014/main" xmlns="" id="{5655C326-A335-860B-7E3F-CE90C033816A}"/>
+              </a:ext>
+            </a:extLst>
+          </p:cNvPr>
+          <p:cNvGraphicFramePr>
+            <a:graphicFrameLocks noGrp="1"/>
+          </p:cNvGraphicFramePr>
           <p:nvPr>
-            <p:ph type="title"/>
+            <p:ph idx="1"/>
+            <p:extLst>
+              <p:ext uri="{D42A27DB-BD31-4B8C-83A1-F6EECF244321}">
+                <p14:modId xmlns:p14="http://schemas.microsoft.com/office/powerpoint/2010/main" val="1419901916"/>
+              </p:ext>
+            </p:extLst>
           </p:nvPr>
-        </p:nvSpPr>
-        <p:spPr/>
-        <p:txBody>
-          <a:bodyPr>
-            <a:normAutofit fontScale="90000"/>
-          </a:bodyPr>
-          <a:lstStyle/>
-          <a:p>
-            <a:r>
-              <a:rPr lang="en-US" smtClean="0"/>
-              <a:t>HƯỚNG PHÁT TRIỂN</a:t>
-            </a:r>
-            <a:endParaRPr b="1">
-              <a:solidFill>
-                <a:schemeClr val="accent1">
-                  <a:lumMod val="75000"/>
-                </a:schemeClr>
-              </a:solidFill>
-            </a:endParaRPr>
-          </a:p>
-        </p:txBody>
-      </p:sp>
-      <p:sp>
-        <p:nvSpPr>
-          <p:cNvPr id="3" name="Rectangle 2"/>
-          <p:cNvSpPr/>
-          <p:nvPr/>
-        </p:nvSpPr>
-        <p:spPr>
-          <a:xfrm>
-            <a:off x="0" y="1259037"/>
-            <a:ext cx="8950036" cy="2862322"/>
-          </a:xfrm>
-          <a:prstGeom prst="rect">
-            <a:avLst/>
-          </a:prstGeom>
-        </p:spPr>
-        <p:txBody>
-          <a:bodyPr wrap="square">
-            <a:spAutoFit/>
-          </a:bodyPr>
-          <a:lstStyle/>
-          <a:p>
-            <a:pPr marL="342900" indent="-342900">
-              <a:lnSpc>
-                <a:spcPct val="150000"/>
-              </a:lnSpc>
-              <a:buFont typeface="Arial" panose="020B0604020202020204" pitchFamily="34" charset="0"/>
-              <a:buChar char="•"/>
-            </a:pPr>
-            <a:r>
-              <a:rPr lang="vi-VN" sz="2400">
-                <a:latin typeface="Arial" panose="020B0604020202020204" pitchFamily="34" charset="0"/>
-                <a:cs typeface="Arial" panose="020B0604020202020204" pitchFamily="34" charset="0"/>
-              </a:rPr>
-              <a:t>Mở rộng </a:t>
-            </a:r>
-            <a:r>
-              <a:rPr lang="en-US" sz="2400" smtClean="0">
-                <a:latin typeface="Arial" panose="020B0604020202020204" pitchFamily="34" charset="0"/>
-                <a:cs typeface="Arial" panose="020B0604020202020204" pitchFamily="34" charset="0"/>
-              </a:rPr>
-              <a:t>áp dụng cho nhiều môn học khác</a:t>
-            </a:r>
-          </a:p>
-          <a:p>
-            <a:pPr marL="342900" indent="-342900">
-              <a:lnSpc>
-                <a:spcPct val="150000"/>
-              </a:lnSpc>
-              <a:buFont typeface="Arial" panose="020B0604020202020204" pitchFamily="34" charset="0"/>
-              <a:buChar char="•"/>
-            </a:pPr>
-            <a:r>
-              <a:rPr lang="vi-VN" sz="2400" smtClean="0">
-                <a:latin typeface="Arial" panose="020B0604020202020204" pitchFamily="34" charset="0"/>
-                <a:cs typeface="Arial" panose="020B0604020202020204" pitchFamily="34" charset="0"/>
-              </a:rPr>
-              <a:t>Tích </a:t>
-            </a:r>
-            <a:r>
-              <a:rPr lang="vi-VN" sz="2400">
-                <a:latin typeface="Arial" panose="020B0604020202020204" pitchFamily="34" charset="0"/>
-                <a:cs typeface="Arial" panose="020B0604020202020204" pitchFamily="34" charset="0"/>
-              </a:rPr>
-              <a:t>hợp LMS và các mô hình AI </a:t>
-            </a:r>
-            <a:r>
-              <a:rPr lang="vi-VN" sz="2400" smtClean="0">
-                <a:latin typeface="Arial" panose="020B0604020202020204" pitchFamily="34" charset="0"/>
-                <a:cs typeface="Arial" panose="020B0604020202020204" pitchFamily="34" charset="0"/>
-              </a:rPr>
-              <a:t>mới.</a:t>
-            </a:r>
-            <a:endParaRPr lang="en-US" sz="2400" smtClean="0">
-              <a:latin typeface="Arial" panose="020B0604020202020204" pitchFamily="34" charset="0"/>
-              <a:cs typeface="Arial" panose="020B0604020202020204" pitchFamily="34" charset="0"/>
-            </a:endParaRPr>
-          </a:p>
-          <a:p>
-            <a:pPr marL="342900" indent="-342900">
-              <a:lnSpc>
-                <a:spcPct val="150000"/>
-              </a:lnSpc>
-              <a:buFont typeface="Arial" panose="020B0604020202020204" pitchFamily="34" charset="0"/>
-              <a:buChar char="•"/>
-            </a:pPr>
-            <a:r>
-              <a:rPr lang="vi-VN" sz="2400">
-                <a:latin typeface="Arial" panose="020B0604020202020204" pitchFamily="34" charset="0"/>
-                <a:cs typeface="Arial" panose="020B0604020202020204" pitchFamily="34" charset="0"/>
-              </a:rPr>
-              <a:t>Nâng cao chất lượng </a:t>
-            </a:r>
-            <a:r>
-              <a:rPr lang="vi-VN" sz="2400" smtClean="0">
-                <a:latin typeface="Arial" panose="020B0604020202020204" pitchFamily="34" charset="0"/>
-                <a:cs typeface="Arial" panose="020B0604020202020204" pitchFamily="34" charset="0"/>
-              </a:rPr>
-              <a:t>và </a:t>
-            </a:r>
-            <a:r>
-              <a:rPr lang="vi-VN" sz="2400">
-                <a:latin typeface="Arial" panose="020B0604020202020204" pitchFamily="34" charset="0"/>
-                <a:cs typeface="Arial" panose="020B0604020202020204" pitchFamily="34" charset="0"/>
-              </a:rPr>
-              <a:t>đánh giá nội dung bằng các kỹ thuật RAG tiên tiến.</a:t>
-            </a:r>
-            <a:endParaRPr lang="en-US" sz="2400" smtClean="0">
-              <a:latin typeface="Arial" panose="020B0604020202020204" pitchFamily="34" charset="0"/>
-              <a:cs typeface="Arial" panose="020B0604020202020204" pitchFamily="34" charset="0"/>
-            </a:endParaRPr>
-          </a:p>
-          <a:p>
-            <a:pPr marL="342900" indent="-342900">
-              <a:lnSpc>
-                <a:spcPct val="150000"/>
-              </a:lnSpc>
-              <a:buFont typeface="Arial" panose="020B0604020202020204" pitchFamily="34" charset="0"/>
-              <a:buChar char="•"/>
-            </a:pPr>
-            <a:r>
-              <a:rPr lang="vi-VN" sz="2400" smtClean="0">
-                <a:latin typeface="Arial" panose="020B0604020202020204" pitchFamily="34" charset="0"/>
-                <a:cs typeface="Arial" panose="020B0604020202020204" pitchFamily="34" charset="0"/>
-              </a:rPr>
-              <a:t>Hỗ </a:t>
-            </a:r>
-            <a:r>
-              <a:rPr lang="vi-VN" sz="2400">
-                <a:latin typeface="Arial" panose="020B0604020202020204" pitchFamily="34" charset="0"/>
-                <a:cs typeface="Arial" panose="020B0604020202020204" pitchFamily="34" charset="0"/>
-              </a:rPr>
-              <a:t>trợ tạo Slide, hình ảnh và học liệu đa phương tiện.</a:t>
-            </a:r>
-          </a:p>
-        </p:txBody>
-      </p:sp>
+        </p:nvGraphicFramePr>
+        <p:xfrm>
+          <a:off x="128563" y="969817"/>
+          <a:ext cx="8442782" cy="4645891"/>
+        </p:xfrm>
+        <a:graphic>
+          <a:graphicData uri="http://schemas.openxmlformats.org/drawingml/2006/diagram">
+            <dgm:relIds xmlns:dgm="http://schemas.openxmlformats.org/drawingml/2006/diagram" xmlns:r="http://schemas.openxmlformats.org/officeDocument/2006/relationships" r:dm="rId3" r:lo="rId4" r:qs="rId5" r:cs="rId6"/>
+          </a:graphicData>
+        </a:graphic>
+      </p:graphicFrame>
       <p:sp>
         <p:nvSpPr>
           <p:cNvPr id="4" name="TextBox 3"/>
@@ -26701,27 +26405,40 @@
           <a:lstStyle/>
           <a:p>
             <a:r>
-              <a:rPr lang="vi-VN" smtClean="0"/>
-              <a:t>17</a:t>
+              <a:rPr lang="en-US" smtClean="0">
+                <a:latin typeface="Arial" panose="020B0604020202020204" pitchFamily="34" charset="0"/>
+                <a:cs typeface="Arial" panose="020B0604020202020204" pitchFamily="34" charset="0"/>
+              </a:rPr>
+              <a:t>15</a:t>
             </a:r>
-            <a:endParaRPr lang="en-US"/>
+            <a:endParaRPr lang="en-US">
+              <a:latin typeface="Arial" panose="020B0604020202020204" pitchFamily="34" charset="0"/>
+              <a:cs typeface="Arial" panose="020B0604020202020204" pitchFamily="34" charset="0"/>
+            </a:endParaRPr>
           </a:p>
         </p:txBody>
       </p:sp>
     </p:spTree>
     <p:extLst>
       <p:ext uri="{BB962C8B-B14F-4D97-AF65-F5344CB8AC3E}">
-        <p14:creationId xmlns:p14="http://schemas.microsoft.com/office/powerpoint/2010/main" val="1242678958"/>
+        <p14:creationId xmlns:p14="http://schemas.microsoft.com/office/powerpoint/2010/main" val="3038241116"/>
       </p:ext>
     </p:extLst>
   </p:cSld>
   <p:clrMapOvr>
     <a:masterClrMapping/>
   </p:clrMapOvr>
+  <p:timing>
+    <p:tnLst>
+      <p:par>
+        <p:cTn id="1" dur="indefinite" restart="never" nodeType="tmRoot"/>
+      </p:par>
+    </p:tnLst>
+  </p:timing>
 </p:sld>
 </file>
 
-<file path=ppt/slides/slide18.xml><?xml version="1.0" encoding="utf-8"?>
+<file path=ppt/slides/slide16.xml><?xml version="1.0" encoding="utf-8"?>
 <p:sld xmlns:a="http://schemas.openxmlformats.org/drawingml/2006/main" xmlns:r="http://schemas.openxmlformats.org/officeDocument/2006/relationships" xmlns:p="http://schemas.openxmlformats.org/presentationml/2006/main">
   <p:cSld>
     <p:spTree>
@@ -26832,7 +26549,11 @@
           <a:p>
             <a:r>
               <a:rPr lang="vi-VN" smtClean="0"/>
-              <a:t>17</a:t>
+              <a:t>1</a:t>
+            </a:r>
+            <a:r>
+              <a:rPr lang="en-US" smtClean="0"/>
+              <a:t>6</a:t>
             </a:r>
             <a:endParaRPr lang="en-US"/>
           </a:p>
@@ -26848,6 +26569,13 @@
   <p:clrMapOvr>
     <a:masterClrMapping/>
   </p:clrMapOvr>
+  <p:timing>
+    <p:tnLst>
+      <p:par>
+        <p:cTn id="1" dur="indefinite" restart="never" nodeType="tmRoot"/>
+      </p:par>
+    </p:tnLst>
+  </p:timing>
 </p:sld>
 </file>
 
@@ -26904,7 +26632,7 @@
           <p:cNvPr id="7" name="Content Placeholder 6">
             <a:extLst>
               <a:ext uri="{FF2B5EF4-FFF2-40B4-BE49-F238E27FC236}">
-                <a16:creationId xmlns="" xmlns:a16="http://schemas.microsoft.com/office/drawing/2014/main" id="{615EE8C7-E09F-F17F-2235-567C32037D1E}"/>
+                <a16:creationId xmlns:a16="http://schemas.microsoft.com/office/drawing/2014/main" xmlns="" id="{615EE8C7-E09F-F17F-2235-567C32037D1E}"/>
               </a:ext>
             </a:extLst>
           </p:cNvPr>
@@ -26915,7 +26643,7 @@
             <p:ph idx="1"/>
             <p:extLst>
               <p:ext uri="{D42A27DB-BD31-4B8C-83A1-F6EECF244321}">
-                <p14:modId xmlns:p14="http://schemas.microsoft.com/office/powerpoint/2010/main" val="2077196256"/>
+                <p14:modId xmlns:p14="http://schemas.microsoft.com/office/powerpoint/2010/main" val="3184644545"/>
               </p:ext>
             </p:extLst>
           </p:nvPr>
@@ -27034,7 +26762,7 @@
           <p:cNvPr id="5" name="Content Placeholder 4">
             <a:extLst>
               <a:ext uri="{FF2B5EF4-FFF2-40B4-BE49-F238E27FC236}">
-                <a16:creationId xmlns="" xmlns:a16="http://schemas.microsoft.com/office/drawing/2014/main" id="{5655C326-A335-860B-7E3F-CE90C033816A}"/>
+                <a16:creationId xmlns:a16="http://schemas.microsoft.com/office/drawing/2014/main" xmlns="" id="{5655C326-A335-860B-7E3F-CE90C033816A}"/>
               </a:ext>
             </a:extLst>
           </p:cNvPr>
@@ -27045,7 +26773,7 @@
             <p:ph idx="1"/>
             <p:extLst>
               <p:ext uri="{D42A27DB-BD31-4B8C-83A1-F6EECF244321}">
-                <p14:modId xmlns:p14="http://schemas.microsoft.com/office/powerpoint/2010/main" val="681358308"/>
+                <p14:modId xmlns:p14="http://schemas.microsoft.com/office/powerpoint/2010/main" val="286817171"/>
               </p:ext>
             </p:extLst>
           </p:nvPr>
@@ -27083,10 +26811,16 @@
           <a:lstStyle/>
           <a:p>
             <a:r>
-              <a:rPr lang="vi-VN"/>
+              <a:rPr lang="vi-VN">
+                <a:latin typeface="Arial" panose="020B0604020202020204" pitchFamily="34" charset="0"/>
+                <a:cs typeface="Arial" panose="020B0604020202020204" pitchFamily="34" charset="0"/>
+              </a:rPr>
               <a:t>3</a:t>
             </a:r>
-            <a:endParaRPr lang="en-US"/>
+            <a:endParaRPr lang="en-US">
+              <a:latin typeface="Arial" panose="020B0604020202020204" pitchFamily="34" charset="0"/>
+              <a:cs typeface="Arial" panose="020B0604020202020204" pitchFamily="34" charset="0"/>
+            </a:endParaRPr>
           </a:p>
         </p:txBody>
       </p:sp>
@@ -27163,7 +26897,7 @@
           <p:cNvPr id="9" name="Diagram 8">
             <a:extLst>
               <a:ext uri="{FF2B5EF4-FFF2-40B4-BE49-F238E27FC236}">
-                <a16:creationId xmlns="" xmlns:a16="http://schemas.microsoft.com/office/drawing/2014/main" id="{2D53CFDA-CB5C-E60E-3BD7-FCE432853F09}"/>
+                <a16:creationId xmlns:a16="http://schemas.microsoft.com/office/drawing/2014/main" xmlns="" id="{2D53CFDA-CB5C-E60E-3BD7-FCE432853F09}"/>
               </a:ext>
             </a:extLst>
           </p:cNvPr>
@@ -27428,8 +27162,8 @@
           <a:lstStyle/>
           <a:p>
             <a:r>
-              <a:rPr lang="vi-VN" sz="3200" smtClean="0"/>
-              <a:t>CƠ SỞ LÝ THUYẾT</a:t>
+              <a:rPr lang="en-US" sz="3200" smtClean="0"/>
+              <a:t>CÔNG NGHỆ SỬ DỤNG</a:t>
             </a:r>
             <a:endParaRPr sz="3200" b="1">
               <a:solidFill>
@@ -27443,54 +27177,6 @@
       </p:sp>
       <p:pic>
         <p:nvPicPr>
-          <p:cNvPr id="3" name="Picture 2"/>
-          <p:cNvPicPr>
-            <a:picLocks noChangeAspect="1"/>
-          </p:cNvPicPr>
-          <p:nvPr/>
-        </p:nvPicPr>
-        <p:blipFill>
-          <a:blip r:embed="rId3"/>
-          <a:stretch>
-            <a:fillRect/>
-          </a:stretch>
-        </p:blipFill>
-        <p:spPr>
-          <a:xfrm>
-            <a:off x="126696" y="1423822"/>
-            <a:ext cx="3000478" cy="1684704"/>
-          </a:xfrm>
-          <a:prstGeom prst="rect">
-            <a:avLst/>
-          </a:prstGeom>
-        </p:spPr>
-      </p:pic>
-      <p:pic>
-        <p:nvPicPr>
-          <p:cNvPr id="5" name="Picture 4"/>
-          <p:cNvPicPr>
-            <a:picLocks noChangeAspect="1"/>
-          </p:cNvPicPr>
-          <p:nvPr/>
-        </p:nvPicPr>
-        <p:blipFill>
-          <a:blip r:embed="rId4"/>
-          <a:stretch>
-            <a:fillRect/>
-          </a:stretch>
-        </p:blipFill>
-        <p:spPr>
-          <a:xfrm>
-            <a:off x="3692666" y="1440692"/>
-            <a:ext cx="2467892" cy="1650964"/>
-          </a:xfrm>
-          <a:prstGeom prst="rect">
-            <a:avLst/>
-          </a:prstGeom>
-        </p:spPr>
-      </p:pic>
-      <p:pic>
-        <p:nvPicPr>
           <p:cNvPr id="2050" name="Picture 2" descr="Định nghĩa React.js"/>
           <p:cNvPicPr>
             <a:picLocks noChangeAspect="1" noChangeArrowheads="1"/>
@@ -27498,7 +27184,7 @@
           <p:nvPr/>
         </p:nvPicPr>
         <p:blipFill>
-          <a:blip r:embed="rId5">
+          <a:blip r:embed="rId3">
             <a:extLst>
               <a:ext uri="{28A0092B-C50C-407E-A947-70E740481C1C}">
                 <a14:useLocalDpi xmlns:a14="http://schemas.microsoft.com/office/drawing/2010/main" val="0"/>
@@ -27512,8 +27198,8 @@
         </p:blipFill>
         <p:spPr bwMode="auto">
           <a:xfrm>
-            <a:off x="-195221" y="3483776"/>
-            <a:ext cx="2134907" cy="1445510"/>
+            <a:off x="3146469" y="1174648"/>
+            <a:ext cx="2768883" cy="1874765"/>
           </a:xfrm>
           <a:prstGeom prst="rect">
             <a:avLst/>
@@ -27539,15 +27225,15 @@
           <p:nvPr/>
         </p:nvPicPr>
         <p:blipFill>
-          <a:blip r:embed="rId6"/>
+          <a:blip r:embed="rId4"/>
           <a:stretch>
             <a:fillRect/>
           </a:stretch>
         </p:blipFill>
         <p:spPr>
           <a:xfrm>
-            <a:off x="1885718" y="3520686"/>
-            <a:ext cx="1857816" cy="1432533"/>
+            <a:off x="167754" y="1174649"/>
+            <a:ext cx="2549286" cy="1965715"/>
           </a:xfrm>
           <a:prstGeom prst="rect">
             <a:avLst/>
@@ -27563,15 +27249,15 @@
           <p:nvPr/>
         </p:nvPicPr>
         <p:blipFill>
-          <a:blip r:embed="rId7"/>
+          <a:blip r:embed="rId5"/>
           <a:stretch>
             <a:fillRect/>
           </a:stretch>
         </p:blipFill>
         <p:spPr>
           <a:xfrm>
-            <a:off x="805288" y="4896551"/>
-            <a:ext cx="2938246" cy="1328331"/>
+            <a:off x="5300562" y="5006430"/>
+            <a:ext cx="2834944" cy="1281630"/>
           </a:xfrm>
           <a:prstGeom prst="rect">
             <a:avLst/>
@@ -27587,15 +27273,15 @@
           <p:nvPr/>
         </p:nvPicPr>
         <p:blipFill>
-          <a:blip r:embed="rId8"/>
+          <a:blip r:embed="rId6"/>
           <a:stretch>
             <a:fillRect/>
           </a:stretch>
         </p:blipFill>
         <p:spPr>
           <a:xfrm>
-            <a:off x="4180401" y="3538804"/>
-            <a:ext cx="1492422" cy="1438349"/>
+            <a:off x="6236393" y="1290007"/>
+            <a:ext cx="1899113" cy="1830305"/>
           </a:xfrm>
           <a:prstGeom prst="rect">
             <a:avLst/>
@@ -27611,15 +27297,15 @@
           <p:nvPr/>
         </p:nvPicPr>
         <p:blipFill>
-          <a:blip r:embed="rId9"/>
+          <a:blip r:embed="rId7"/>
           <a:stretch>
             <a:fillRect/>
           </a:stretch>
         </p:blipFill>
         <p:spPr>
           <a:xfrm>
-            <a:off x="4279243" y="5037046"/>
-            <a:ext cx="3245635" cy="1187836"/>
+            <a:off x="733345" y="4958458"/>
+            <a:ext cx="3395310" cy="1242614"/>
           </a:xfrm>
           <a:prstGeom prst="rect">
             <a:avLst/>
@@ -27635,14 +27321,14 @@
           <p:nvPr/>
         </p:nvPicPr>
         <p:blipFill>
-          <a:blip r:embed="rId10"/>
+          <a:blip r:embed="rId8"/>
           <a:stretch>
             <a:fillRect/>
           </a:stretch>
         </p:blipFill>
         <p:spPr>
           <a:xfrm>
-            <a:off x="6628039" y="1457562"/>
+            <a:off x="3311073" y="3216543"/>
             <a:ext cx="1989489" cy="1650964"/>
           </a:xfrm>
           <a:prstGeom prst="rect">
@@ -27659,14 +27345,14 @@
           <p:nvPr/>
         </p:nvPicPr>
         <p:blipFill>
-          <a:blip r:embed="rId11"/>
+          <a:blip r:embed="rId9"/>
           <a:stretch>
             <a:fillRect/>
           </a:stretch>
         </p:blipFill>
         <p:spPr>
           <a:xfrm>
-            <a:off x="6109690" y="3710343"/>
+            <a:off x="175168" y="3398444"/>
             <a:ext cx="2541872" cy="1301934"/>
           </a:xfrm>
           <a:prstGeom prst="rect">
@@ -27704,6 +27390,30 @@
           </a:p>
         </p:txBody>
       </p:sp>
+      <p:pic>
+        <p:nvPicPr>
+          <p:cNvPr id="6" name="Picture 5"/>
+          <p:cNvPicPr>
+            <a:picLocks noChangeAspect="1"/>
+          </p:cNvPicPr>
+          <p:nvPr/>
+        </p:nvPicPr>
+        <p:blipFill>
+          <a:blip r:embed="rId10"/>
+          <a:stretch>
+            <a:fillRect/>
+          </a:stretch>
+        </p:blipFill>
+        <p:spPr>
+          <a:xfrm>
+            <a:off x="6221369" y="3220880"/>
+            <a:ext cx="1929159" cy="1516189"/>
+          </a:xfrm>
+          <a:prstGeom prst="rect">
+            <a:avLst/>
+          </a:prstGeom>
+        </p:spPr>
+      </p:pic>
     </p:spTree>
     <p:extLst>
       <p:ext uri="{BB962C8B-B14F-4D97-AF65-F5344CB8AC3E}">
@@ -27759,7 +27469,7 @@
           <a:lstStyle/>
           <a:p>
             <a:r>
-              <a:rPr lang="en-US" sz="3400" b="1">
+              <a:rPr lang="en-US" sz="3200" b="1">
                 <a:solidFill>
                   <a:schemeClr val="accent1">
                     <a:lumMod val="75000"/>
@@ -27768,7 +27478,7 @@
               </a:rPr>
               <a:t>USE-CASE &amp; YÊU CẦU HỆ THỐNG</a:t>
             </a:r>
-            <a:endParaRPr sz="3400" b="1">
+            <a:endParaRPr sz="3200" b="1">
               <a:solidFill>
                 <a:schemeClr val="accent1">
                   <a:lumMod val="75000"/>
@@ -27783,7 +27493,7 @@
           <p:cNvPr id="11" name="Diagram 10">
             <a:extLst>
               <a:ext uri="{FF2B5EF4-FFF2-40B4-BE49-F238E27FC236}">
-                <a16:creationId xmlns="" xmlns:a16="http://schemas.microsoft.com/office/drawing/2014/main" id="{1ED27C14-4121-4D4D-47A7-FBE3633FA51B}"/>
+                <a16:creationId xmlns:a16="http://schemas.microsoft.com/office/drawing/2014/main" xmlns="" id="{1ED27C14-4121-4D4D-47A7-FBE3633FA51B}"/>
               </a:ext>
             </a:extLst>
           </p:cNvPr>
@@ -27791,14 +27501,14 @@
           <p:nvPr>
             <p:extLst>
               <p:ext uri="{D42A27DB-BD31-4B8C-83A1-F6EECF244321}">
-                <p14:modId xmlns:p14="http://schemas.microsoft.com/office/powerpoint/2010/main" val="4055902992"/>
+                <p14:modId xmlns:p14="http://schemas.microsoft.com/office/powerpoint/2010/main" val="3826426991"/>
               </p:ext>
             </p:extLst>
           </p:nvPr>
         </p:nvGraphicFramePr>
         <p:xfrm>
-          <a:off x="138465" y="1043709"/>
-          <a:ext cx="2983426" cy="5061527"/>
+          <a:off x="138465" y="960583"/>
+          <a:ext cx="2983426" cy="5347854"/>
         </p:xfrm>
         <a:graphic>
           <a:graphicData uri="http://schemas.openxmlformats.org/drawingml/2006/diagram">
@@ -27820,8 +27530,8 @@
         </p:blipFill>
         <p:spPr>
           <a:xfrm>
-            <a:off x="3121891" y="1587082"/>
-            <a:ext cx="5950527" cy="4003588"/>
+            <a:off x="3121891" y="1505527"/>
+            <a:ext cx="6022109" cy="4279106"/>
           </a:xfrm>
           <a:prstGeom prst="rect">
             <a:avLst/>
@@ -27930,17 +27640,7 @@
                   </a:schemeClr>
                 </a:solidFill>
               </a:rPr>
-              <a:t> </a:t>
-            </a:r>
-            <a:r>
-              <a:rPr lang="en-US" sz="3200" b="1" smtClean="0">
-                <a:solidFill>
-                  <a:schemeClr val="accent1">
-                    <a:lumMod val="75000"/>
-                  </a:schemeClr>
-                </a:solidFill>
-              </a:rPr>
-              <a:t>ERD</a:t>
+              <a:t> ERD</a:t>
             </a:r>
             <a:endParaRPr sz="3200" b="1">
               <a:solidFill>
@@ -28085,7 +27785,7 @@
           <p:cNvPr id="11" name="Diagram 10">
             <a:extLst>
               <a:ext uri="{FF2B5EF4-FFF2-40B4-BE49-F238E27FC236}">
-                <a16:creationId xmlns="" xmlns:a16="http://schemas.microsoft.com/office/drawing/2014/main" id="{1ED27C14-4121-4D4D-47A7-FBE3633FA51B}"/>
+                <a16:creationId xmlns:a16="http://schemas.microsoft.com/office/drawing/2014/main" xmlns="" id="{1ED27C14-4121-4D4D-47A7-FBE3633FA51B}"/>
               </a:ext>
             </a:extLst>
           </p:cNvPr>

</xml_diff>